<commit_message>
Align solution naming with mplanit.co.kr structure
회사 사이트 솔루션 섹션 기준으로 명칭 체계 정정.

- AI LAB = GEO Metric Care Solution (AI 기반 SEO + GEO 통합 광고 최적화 분석)
- M Ai Platform = AI 그로스 통합 플랫폼 (광고 AI 자동 소재 제작 · 실시간 통합 리포트 분석)
  → 배너핏 · 릴스 스튜디오 · 애드리포트 · MI 솔루션이 여기에 속함
- 기존에 AI LAB을 전체 우산 명칭으로 쓴 부분을 '엠플랜잇 AI 솔루션 통합 구조'로 교체
- 통합 맵 카드에 소속 배지(M Ai / AI LAB / Hub) 표기, 제품 장 kicker에 플랫폼 병기
- GEO 장 제목·부제를 사이트 카피로 교체
- HTML · 단일 HTML · PDF · PPTX 전부 동기화

Co-Authored-By: Claude Opus 5 <noreply@anthropic.com>
Claude-Session: https://claude.ai/code/session_011X2s4AJGYKPxJHXCXs5Aou
</commit_message>
<xml_diff>
--- a/ai-solution/mplanit-ai-solution.pptx
+++ b/ai-solution/mplanit-ai-solution.pptx
@@ -1622,7 +1622,7 @@
                 <a:ea typeface="페이퍼로지 8 ExtraBold" pitchFamily="34" charset="-122"/>
                 <a:cs typeface="페이퍼로지 8 ExtraBold" pitchFamily="34" charset="-120"/>
               </a:rPr>
-              <a:t>AI LAB 솔루션 소개서 · 2026.09</a:t>
+              <a:t>AI 솔루션 소개서 · 2026.09</a:t>
             </a:r>
             <a:endParaRPr lang="en-US" sz="850" dirty="0"/>
           </a:p>
@@ -1697,23 +1697,37 @@
         <p:spPr>
           <a:xfrm>
             <a:off x="533399" y="2343144"/>
-            <a:ext cx="8572479" cy="190500"/>
-          </a:xfrm>
-          <a:prstGeom prst="rect">
-            <a:avLst/>
-          </a:prstGeom>
-          <a:noFill/>
-          <a:ln/>
-        </p:spPr>
-        <p:txBody>
-          <a:bodyPr wrap="square" lIns="0" tIns="0" rIns="0" bIns="0" rtlCol="0" anchor="ctr"/>
-          <a:lstStyle/>
-          <a:p>
-            <a:pPr indent="0" marL="0">
-              <a:buNone/>
-            </a:pPr>
-            <a:r>
-              <a:rPr lang="en-US" sz="1100" dirty="0">
+            <a:ext cx="11048972" cy="190500"/>
+          </a:xfrm>
+          <a:prstGeom prst="rect">
+            <a:avLst/>
+          </a:prstGeom>
+          <a:noFill/>
+          <a:ln/>
+        </p:spPr>
+        <p:txBody>
+          <a:bodyPr wrap="square" lIns="0" tIns="0" rIns="0" bIns="0" rtlCol="0" anchor="ctr"/>
+          <a:lstStyle/>
+          <a:p>
+            <a:pPr indent="0" marL="0">
+              <a:buNone/>
+            </a:pPr>
+            <a:r>
+              <a:rPr lang="en-US" sz="1050" dirty="0">
+                <a:solidFill>
+                  <a:srgbClr val="1B468B"/>
+                </a:solidFill>
+                <a:latin typeface="페이퍼로지 8 ExtraBold" pitchFamily="34" charset="0"/>
+                <a:ea typeface="페이퍼로지 8 ExtraBold" pitchFamily="34" charset="-122"/>
+                <a:cs typeface="페이퍼로지 8 ExtraBold" pitchFamily="34" charset="-120"/>
+              </a:rPr>
+              <a:t>M Ai Platform</a:t>
+            </a:r>
+            <a:pPr indent="0" marL="0">
+              <a:buNone/>
+            </a:pPr>
+            <a:r>
+              <a:rPr lang="en-US" sz="1050" dirty="0">
                 <a:solidFill>
                   <a:srgbClr val="334155"/>
                 </a:solidFill>
@@ -1721,9 +1735,37 @@
                 <a:ea typeface="페이퍼로지 4 Regular" pitchFamily="34" charset="-122"/>
                 <a:cs typeface="페이퍼로지 4 Regular" pitchFamily="34" charset="-120"/>
               </a:rPr>
-              <a:t>엠플랜잇 AI LAB 솔루션 6종 — 대행사 실무 기준 설계, 1인 기업까지 사용</a:t>
-            </a:r>
-            <a:endParaRPr lang="en-US" sz="1100" dirty="0"/>
+              <a:t> — AI 그로스 통합 플랫폼(소재 제작 · 실시간 통합 리포트)  +  </a:t>
+            </a:r>
+            <a:pPr indent="0" marL="0">
+              <a:buNone/>
+            </a:pPr>
+            <a:r>
+              <a:rPr lang="en-US" sz="1050" dirty="0">
+                <a:solidFill>
+                  <a:srgbClr val="1B468B"/>
+                </a:solidFill>
+                <a:latin typeface="페이퍼로지 8 ExtraBold" pitchFamily="34" charset="0"/>
+                <a:ea typeface="페이퍼로지 8 ExtraBold" pitchFamily="34" charset="-122"/>
+                <a:cs typeface="페이퍼로지 8 ExtraBold" pitchFamily="34" charset="-120"/>
+              </a:rPr>
+              <a:t>AI LAB</a:t>
+            </a:r>
+            <a:pPr indent="0" marL="0">
+              <a:buNone/>
+            </a:pPr>
+            <a:r>
+              <a:rPr lang="en-US" sz="1050" dirty="0">
+                <a:solidFill>
+                  <a:srgbClr val="334155"/>
+                </a:solidFill>
+                <a:latin typeface="페이퍼로지 4 Regular" pitchFamily="34" charset="0"/>
+                <a:ea typeface="페이퍼로지 4 Regular" pitchFamily="34" charset="-122"/>
+                <a:cs typeface="페이퍼로지 4 Regular" pitchFamily="34" charset="-120"/>
+              </a:rPr>
+              <a:t> — GEO Metric Care(SEO + GEO 통합 분석) · 솔루션 6종</a:t>
+            </a:r>
+            <a:endParaRPr lang="en-US" sz="1050" dirty="0"/>
           </a:p>
         </p:txBody>
       </p:sp>
@@ -6314,7 +6356,7 @@
                 <a:ea typeface="페이퍼로지 4 Regular" pitchFamily="34" charset="-122"/>
                 <a:cs typeface="페이퍼로지 4 Regular" pitchFamily="34" charset="-120"/>
               </a:rPr>
-              <a:t>엠플랜잇 AIU본부 · AI LAB · mplanit.co.kr</a:t>
+              <a:t>엠플랜잇 AIU본부 · M Ai Platform · AI LAB · mplanit.co.kr</a:t>
             </a:r>
             <a:endParaRPr lang="en-US" sz="800" dirty="0"/>
           </a:p>
@@ -6464,7 +6506,7 @@
                 <a:ea typeface="페이퍼로지 8 ExtraBold" pitchFamily="34" charset="-122"/>
                 <a:cs typeface="페이퍼로지 8 ExtraBold" pitchFamily="34" charset="-120"/>
               </a:rPr>
-              <a:t>AI LAB INTEGRATION</a:t>
+              <a:t>SOLUTION ARCHITECTURE</a:t>
             </a:r>
             <a:endParaRPr lang="en-US" sz="850" dirty="0"/>
           </a:p>
@@ -6503,7 +6545,7 @@
                 <a:ea typeface="페이퍼로지 8 ExtraBold" pitchFamily="34" charset="-122"/>
                 <a:cs typeface="페이퍼로지 8 ExtraBold" pitchFamily="34" charset="-120"/>
               </a:rPr>
-              <a:t>AI LAB 통합 구조 — </a:t>
+              <a:t>엠플랜잇 AI 솔루션 통합 구조 — </a:t>
             </a:r>
             <a:pPr indent="0" marL="0">
               <a:buNone/>
@@ -6556,7 +6598,7 @@
                 <a:ea typeface="페이퍼로지 4 Regular" pitchFamily="34" charset="-122"/>
                 <a:cs typeface="페이퍼로지 4 Regular" pitchFamily="34" charset="-120"/>
               </a:rPr>
-              <a:t>솔루션 6종 · 단계별 역할 · 데이터 연결 · 적용 대상 요약</a:t>
+              <a:t>M Ai Platform 제작·성과·운영 · AI LAB AI 검색 최적화 · 커머스허브 판매 — 6종</a:t>
             </a:r>
             <a:endParaRPr lang="en-US" sz="1000" dirty="0"/>
           </a:p>
@@ -6809,7 +6851,7 @@
                 <a:ea typeface="페이퍼로지 8 ExtraBold" pitchFamily="34" charset="-122"/>
                 <a:cs typeface="페이퍼로지 8 ExtraBold" pitchFamily="34" charset="-120"/>
               </a:rPr>
-              <a:t>운영</a:t>
+              <a:t>M Ai</a:t>
             </a:r>
             <a:endParaRPr lang="en-US" sz="650" dirty="0"/>
           </a:p>
@@ -7198,7 +7240,7 @@
                 <a:ea typeface="페이퍼로지 8 ExtraBold" pitchFamily="34" charset="-122"/>
                 <a:cs typeface="페이퍼로지 8 ExtraBold" pitchFamily="34" charset="-120"/>
               </a:rPr>
-              <a:t>운영</a:t>
+              <a:t>M Ai</a:t>
             </a:r>
             <a:endParaRPr lang="en-US" sz="650" dirty="0"/>
           </a:p>
@@ -7587,7 +7629,7 @@
                 <a:ea typeface="페이퍼로지 8 ExtraBold" pitchFamily="34" charset="-122"/>
                 <a:cs typeface="페이퍼로지 8 ExtraBold" pitchFamily="34" charset="-120"/>
               </a:rPr>
-              <a:t>운영</a:t>
+              <a:t>AI LAB</a:t>
             </a:r>
             <a:endParaRPr lang="en-US" sz="650" dirty="0"/>
           </a:p>
@@ -7976,7 +8018,7 @@
                 <a:ea typeface="페이퍼로지 8 ExtraBold" pitchFamily="34" charset="-122"/>
                 <a:cs typeface="페이퍼로지 8 ExtraBold" pitchFamily="34" charset="-120"/>
               </a:rPr>
-              <a:t>운영</a:t>
+              <a:t>Hub</a:t>
             </a:r>
             <a:endParaRPr lang="en-US" sz="650" dirty="0"/>
           </a:p>
@@ -8365,7 +8407,7 @@
                 <a:ea typeface="페이퍼로지 8 ExtraBold" pitchFamily="34" charset="-122"/>
                 <a:cs typeface="페이퍼로지 8 ExtraBold" pitchFamily="34" charset="-120"/>
               </a:rPr>
-              <a:t>운영</a:t>
+              <a:t>M Ai</a:t>
             </a:r>
             <a:endParaRPr lang="en-US" sz="650" dirty="0"/>
           </a:p>
@@ -10201,7 +10243,7 @@
                 <a:ea typeface="페이퍼로지 4 Regular" pitchFamily="34" charset="-122"/>
                 <a:cs typeface="페이퍼로지 4 Regular" pitchFamily="34" charset="-120"/>
               </a:rPr>
-              <a:t>AI LAB · 통합 구조 요약</a:t>
+              <a:t>Solution Architecture · 통합 구조 요약</a:t>
             </a:r>
             <a:endParaRPr lang="en-US" sz="800" dirty="0"/>
           </a:p>
@@ -10443,7 +10485,7 @@
                 <a:ea typeface="페이퍼로지 4 Regular" pitchFamily="34" charset="-122"/>
                 <a:cs typeface="페이퍼로지 4 Regular" pitchFamily="34" charset="-120"/>
               </a:rPr>
-              <a:t>제작 → 노출 → 판매 → 성과 → 운영, 실제 운영 화면 기준</a:t>
+              <a:t>제작 → 노출 → 판매 → 성과 → 운영 · M Ai Platform / AI LAB / 커머스허브 구성</a:t>
             </a:r>
             <a:endParaRPr lang="en-US" sz="1000" dirty="0"/>
           </a:p>
@@ -12422,7 +12464,7 @@
                 <a:ea typeface="페이퍼로지 8 ExtraBold" pitchFamily="34" charset="-122"/>
                 <a:cs typeface="페이퍼로지 8 ExtraBold" pitchFamily="34" charset="-120"/>
               </a:rPr>
-              <a:t>01 CREATIVE</a:t>
+              <a:t>01 CREATIVE · M AI PLATFORM</a:t>
             </a:r>
             <a:endParaRPr lang="en-US" sz="850" dirty="0"/>
           </a:p>
@@ -14200,7 +14242,7 @@
                 <a:ea typeface="페이퍼로지 8 ExtraBold" pitchFamily="34" charset="-122"/>
                 <a:cs typeface="페이퍼로지 8 ExtraBold" pitchFamily="34" charset="-120"/>
               </a:rPr>
-              <a:t>02 VIDEO</a:t>
+              <a:t>02 VIDEO · M AI PLATFORM</a:t>
             </a:r>
             <a:endParaRPr lang="en-US" sz="850" dirty="0"/>
           </a:p>
@@ -15978,7 +16020,7 @@
                 <a:ea typeface="페이퍼로지 8 ExtraBold" pitchFamily="34" charset="-122"/>
                 <a:cs typeface="페이퍼로지 8 ExtraBold" pitchFamily="34" charset="-120"/>
               </a:rPr>
-              <a:t>03 VISIBILITY</a:t>
+              <a:t>03 VISIBILITY · AI LAB</a:t>
             </a:r>
             <a:endParaRPr lang="en-US" sz="850" dirty="0"/>
           </a:p>
@@ -16017,7 +16059,7 @@
                 <a:ea typeface="페이퍼로지 8 ExtraBold" pitchFamily="34" charset="-122"/>
                 <a:cs typeface="페이퍼로지 8 ExtraBold" pitchFamily="34" charset="-120"/>
               </a:rPr>
-              <a:t>GEO Metric Care — </a:t>
+              <a:t>AI LAB · GEO Metric Care — </a:t>
             </a:r>
             <a:pPr indent="0" marL="0">
               <a:buNone/>
@@ -16031,7 +16073,7 @@
                 <a:ea typeface="페이퍼로지 8 ExtraBold" pitchFamily="34" charset="-122"/>
                 <a:cs typeface="페이퍼로지 8 ExtraBold" pitchFamily="34" charset="-120"/>
               </a:rPr>
-              <a:t>AI 답변 내 브랜드 인용 진단</a:t>
+              <a:t>AI 기반 SEO + GEO 통합 분석</a:t>
             </a:r>
             <a:endParaRPr lang="en-US" sz="2100" dirty="0"/>
           </a:p>
@@ -16070,7 +16112,7 @@
                 <a:ea typeface="페이퍼로지 4 Regular" pitchFamily="34" charset="-122"/>
                 <a:cs typeface="페이퍼로지 4 Regular" pitchFamily="34" charset="-120"/>
               </a:rPr>
-              <a:t>URL 입력 → SEO · GEO 통합 분석 → 점수 · 개선 가이드 · PDF 리포트</a:t>
+              <a:t>전통적인 SEO 점검과 AI 검색 최적화 분석을 한 번에 — 메타 태그 최적화 상태까지 점검</a:t>
             </a:r>
             <a:endParaRPr lang="en-US" sz="1000" dirty="0"/>
           </a:p>
@@ -17505,7 +17547,7 @@
                 <a:ea typeface="페이퍼로지 4 Regular" pitchFamily="34" charset="-122"/>
                 <a:cs typeface="페이퍼로지 4 Regular" pitchFamily="34" charset="-120"/>
               </a:rPr>
-              <a:t>GEO Metric Care · 지오 메트릭 케어</a:t>
+              <a:t>AI LAB · GEO Metric Care Solution</a:t>
             </a:r>
             <a:endParaRPr lang="en-US" sz="800" dirty="0"/>
           </a:p>
@@ -17655,7 +17697,7 @@
                 <a:ea typeface="페이퍼로지 8 ExtraBold" pitchFamily="34" charset="-122"/>
                 <a:cs typeface="페이퍼로지 8 ExtraBold" pitchFamily="34" charset="-120"/>
               </a:rPr>
-              <a:t>04 COMMERCE · 05 PERFORMANCE</a:t>
+              <a:t>04 COMMERCE · 05 PERFORMANCE · M AI PLATFORM</a:t>
             </a:r>
             <a:endParaRPr lang="en-US" sz="850" dirty="0"/>
           </a:p>
@@ -17747,7 +17789,7 @@
                 <a:ea typeface="페이퍼로지 4 Regular" pitchFamily="34" charset="-122"/>
                 <a:cs typeface="페이퍼로지 4 Regular" pitchFamily="34" charset="-120"/>
               </a:rPr>
-              <a:t>한 계정으로 AD REPORT · AD MONITOR · COMMERCE HUB · SETTINGS 이동 (네이버웍스 SSO)</a:t>
+              <a:t>광고 AI 자동 소재 제작 · 실시간 통합 리포트 분석 — AD REPORT · AD MONITOR · COMMERCE HUB · SETTINGS</a:t>
             </a:r>
             <a:endParaRPr lang="en-US" sz="1000" dirty="0"/>
           </a:p>
@@ -21331,7 +21373,7 @@
                 <a:ea typeface="페이퍼로지 8 ExtraBold" pitchFamily="34" charset="-122"/>
                 <a:cs typeface="페이퍼로지 8 ExtraBold" pitchFamily="34" charset="-120"/>
               </a:rPr>
-              <a:t>06 OPERATION</a:t>
+              <a:t>06 OPERATION · M AI PLATFORM</a:t>
             </a:r>
             <a:endParaRPr lang="en-US" sz="850" dirty="0"/>
           </a:p>

</xml_diff>

<commit_message>
Fix slide overflow and simplify copy for readability
잘림 수정 (자동 검사로 3건 확인 후 조치)
- 1장: 출처·공개 프로젝트 줄이 푸터와 겹침 → 시장 수치 3종을 부록으로 이동, 한 줄로 정리
- 7장: 마감 바가 슬라이드 밖 27px → 마감 바 제거, 각주 1줄로 축약
- 8장: 하단 3카드가 푸터와 35px 겹침 → 한 줄 밴드로 축약, 우측 박스 여백 조정
- 넘침 자동 검사 도구 도입(배율 보정 후 bottom/푸터 겹침 판정) — 현재 9장 모두 0건

가독성
- 표지 구조 단순화: 헤드라인 + 한 줄 요약 + 흐름 + 솔루션 카드 + 하단 한 줄
- 전 장표 특장점 설명을 한 줄(30자 내외)로 축약, 괄호 부연·꼬리 문구 제거
- MI 각주 4줄 → 2줄

- PPTX 동일 반영(9장, 경계 밖 도형 0건), PDF 9페이지, 단일 HTML 재생성
- 스킬에 설명 길이·표지 블록 수·넘침 검사 절차 추가

Co-Authored-By: Claude Opus 5 <noreply@anthropic.com>
Claude-Session: https://claude.ai/code/session_011X2s4AJGYKPxJHXCXs5Aou
</commit_message>
<xml_diff>
--- a/ai-solution/mplanit-ai-solution.pptx
+++ b/ai-solution/mplanit-ai-solution.pptx
@@ -1785,24 +1785,24 @@
         </p:nvSpPr>
         <p:spPr>
           <a:xfrm>
-            <a:off x="533399" y="2343144"/>
-            <a:ext cx="11048972" cy="190500"/>
-          </a:xfrm>
-          <a:prstGeom prst="rect">
-            <a:avLst/>
-          </a:prstGeom>
-          <a:noFill/>
-          <a:ln/>
-        </p:spPr>
-        <p:txBody>
-          <a:bodyPr wrap="square" lIns="0" tIns="0" rIns="0" bIns="0" rtlCol="0" anchor="ctr"/>
-          <a:lstStyle/>
-          <a:p>
-            <a:pPr indent="0" marL="0">
-              <a:buNone/>
-            </a:pPr>
-            <a:r>
-              <a:rPr lang="en-US" sz="1050" dirty="0">
+            <a:off x="533399" y="2362194"/>
+            <a:ext cx="11048972" cy="209549"/>
+          </a:xfrm>
+          <a:prstGeom prst="rect">
+            <a:avLst/>
+          </a:prstGeom>
+          <a:noFill/>
+          <a:ln/>
+        </p:spPr>
+        <p:txBody>
+          <a:bodyPr wrap="square" lIns="0" tIns="0" rIns="0" bIns="0" rtlCol="0" anchor="ctr"/>
+          <a:lstStyle/>
+          <a:p>
+            <a:pPr indent="0" marL="0">
+              <a:buNone/>
+            </a:pPr>
+            <a:r>
+              <a:rPr lang="en-US" sz="1200" dirty="0">
                 <a:solidFill>
                   <a:srgbClr val="1B468B"/>
                 </a:solidFill>
@@ -1810,13 +1810,13 @@
                 <a:ea typeface="페이퍼로지 8 ExtraBold" pitchFamily="34" charset="-122"/>
                 <a:cs typeface="페이퍼로지 8 ExtraBold" pitchFamily="34" charset="-120"/>
               </a:rPr>
-              <a:t>M Ai Platform</a:t>
-            </a:r>
-            <a:pPr indent="0" marL="0">
-              <a:buNone/>
-            </a:pPr>
-            <a:r>
-              <a:rPr lang="en-US" sz="1050" dirty="0">
+              <a:t>AI 솔루션 5종 + 데이터 인프라 1</a:t>
+            </a:r>
+            <a:pPr indent="0" marL="0">
+              <a:buNone/>
+            </a:pPr>
+            <a:r>
+              <a:rPr lang="en-US" sz="1200" dirty="0">
                 <a:solidFill>
                   <a:srgbClr val="334155"/>
                 </a:solidFill>
@@ -1824,52 +1824,9 @@
                 <a:ea typeface="페이퍼로지 4 Regular" pitchFamily="34" charset="-122"/>
                 <a:cs typeface="페이퍼로지 4 Regular" pitchFamily="34" charset="-120"/>
               </a:rPr>
-              <a:t> — AI 그로스 통합 플랫폼(소재 제작 · 실시간 통합 리포트)  +  </a:t>
-            </a:r>
-            <a:pPr indent="0" marL="0">
-              <a:buNone/>
-            </a:pPr>
-            <a:r>
-              <a:rPr lang="en-US" sz="1050" dirty="0">
-                <a:solidFill>
-                  <a:srgbClr val="1B468B"/>
-                </a:solidFill>
-                <a:latin typeface="페이퍼로지 8 ExtraBold" pitchFamily="34" charset="0"/>
-                <a:ea typeface="페이퍼로지 8 ExtraBold" pitchFamily="34" charset="-122"/>
-                <a:cs typeface="페이퍼로지 8 ExtraBold" pitchFamily="34" charset="-120"/>
-              </a:rPr>
-              <a:t>AI LAB</a:t>
-            </a:r>
-            <a:pPr indent="0" marL="0">
-              <a:buNone/>
-            </a:pPr>
-            <a:r>
-              <a:rPr lang="en-US" sz="1050" dirty="0">
-                <a:solidFill>
-                  <a:srgbClr val="334155"/>
-                </a:solidFill>
-                <a:latin typeface="페이퍼로지 4 Regular" pitchFamily="34" charset="0"/>
-                <a:ea typeface="페이퍼로지 4 Regular" pitchFamily="34" charset="-122"/>
-                <a:cs typeface="페이퍼로지 4 Regular" pitchFamily="34" charset="-120"/>
-              </a:rPr>
-              <a:t> — GEO Metric Care(SEO + GEO 통합 분석)
-</a:t>
-            </a:r>
-            <a:pPr indent="0" marL="0">
-              <a:buNone/>
-            </a:pPr>
-            <a:r>
-              <a:rPr lang="en-US" sz="1050" dirty="0">
-                <a:solidFill>
-                  <a:srgbClr val="334155"/>
-                </a:solidFill>
-                <a:latin typeface="페이퍼로지 4 Regular" pitchFamily="34" charset="0"/>
-                <a:ea typeface="페이퍼로지 4 Regular" pitchFamily="34" charset="-122"/>
-                <a:cs typeface="페이퍼로지 4 Regular" pitchFamily="34" charset="-120"/>
-              </a:rPr>
-              <a:t>AI 솔루션 5종 + 이를 떠받치는 데이터 인프라(MI) — 수집·정규화·집계까지 자체 기술</a:t>
-            </a:r>
-            <a:endParaRPr lang="en-US" sz="1050" dirty="0"/>
+              <a:t>  —  M Ai Platform · AI LAB · 커머스허브 · MI</a:t>
+            </a:r>
+            <a:endParaRPr lang="en-US" sz="1200" dirty="0"/>
           </a:p>
         </p:txBody>
       </p:sp>
@@ -2636,7 +2593,7 @@
                 <a:ea typeface="페이퍼로지 4 Regular" pitchFamily="34" charset="-122"/>
                 <a:cs typeface="페이퍼로지 4 Regular" pitchFamily="34" charset="-120"/>
               </a:rPr>
-              <a:t>배너 시안 생성 · 매체 규격 변형 · 레이어 편집 · 영상 전환</a:t>
+              <a:t>배너 생성 · 규격 변형 · 레이어 편집 · 영상</a:t>
             </a:r>
             <a:endParaRPr lang="en-US" sz="750" dirty="0"/>
           </a:p>
@@ -2911,7 +2868,7 @@
                 <a:ea typeface="페이퍼로지 4 Regular" pitchFamily="34" charset="-122"/>
                 <a:cs typeface="페이퍼로지 4 Regular" pitchFamily="34" charset="-120"/>
               </a:rPr>
-              <a:t>한 줄 아이디어 · 기획 노드 · 컷별 프롬프트 · 모델 선택</a:t>
+              <a:t>한 줄 입력 · 컷 승인형 숏폼 제작</a:t>
             </a:r>
             <a:endParaRPr lang="en-US" sz="750" dirty="0"/>
           </a:p>
@@ -3186,7 +3143,7 @@
                 <a:ea typeface="페이퍼로지 4 Regular" pitchFamily="34" charset="-122"/>
                 <a:cs typeface="페이퍼로지 4 Regular" pitchFamily="34" charset="-120"/>
               </a:rPr>
-              <a:t>AI 검색 노출 진단 · 점수화 · 개선 가이드 · 정기 재측정</a:t>
+              <a:t>AI 검색 노출 진단 · 개선 가이드</a:t>
             </a:r>
             <a:endParaRPr lang="en-US" sz="750" dirty="0"/>
           </a:p>
@@ -3461,7 +3418,7 @@
                 <a:ea typeface="페이퍼로지 4 Regular" pitchFamily="34" charset="-122"/>
                 <a:cs typeface="페이퍼로지 4 Regular" pitchFamily="34" charset="-120"/>
               </a:rPr>
-              <a:t>7개 마켓 주문 · 배송 · 정산 · 재고 통합 관리</a:t>
+              <a:t>7개 마켓 주문 · 정산 · 재고 통합</a:t>
             </a:r>
             <a:endParaRPr lang="en-US" sz="750" dirty="0"/>
           </a:p>
@@ -3736,7 +3693,7 @@
                 <a:ea typeface="페이퍼로지 4 Regular" pitchFamily="34" charset="-122"/>
                 <a:cs typeface="페이퍼로지 4 Regular" pitchFamily="34" charset="-120"/>
               </a:rPr>
-              <a:t>14개 매체 집행 현황 · 전환 · ROAS · 알림 · 리포트</a:t>
+              <a:t>14개 매체 성과 · ROAS · 알림</a:t>
             </a:r>
             <a:endParaRPr lang="en-US" sz="750" dirty="0"/>
           </a:p>
@@ -4011,7 +3968,7 @@
                 <a:ea typeface="페이퍼로지 4 Regular" pitchFamily="34" charset="-122"/>
                 <a:cs typeface="페이퍼로지 4 Regular" pitchFamily="34" charset="-120"/>
               </a:rPr>
-              <a:t>네이버 자동입찰 · 대량 통합 리포트 · 통합 데이터 분석 · 인프라 구성</a:t>
+              <a:t>자동입찰 · 대량 리포트 · 데이터 인프라</a:t>
             </a:r>
             <a:endParaRPr lang="en-US" sz="750" dirty="0"/>
           </a:p>
@@ -4081,316 +4038,13 @@
       </p:sp>
       <p:sp>
         <p:nvSpPr>
-          <p:cNvPr id="71" name="Shape 68"/>
-          <p:cNvSpPr/>
+          <p:cNvPr id="71" name="Text 68"/>
+          <p:cNvSpPr txBox="1"/>
           <p:nvPr/>
         </p:nvSpPr>
         <p:spPr>
           <a:xfrm>
             <a:off x="533399" y="5124437"/>
-            <a:ext cx="28575" cy="438149"/>
-          </a:xfrm>
-          <a:prstGeom prst="rect">
-            <a:avLst/>
-          </a:prstGeom>
-          <a:solidFill>
-            <a:srgbClr val="399BC1"/>
-          </a:solidFill>
-          <a:ln/>
-        </p:spPr>
-      </p:sp>
-      <p:sp>
-        <p:nvSpPr>
-          <p:cNvPr id="72" name="Text 69"/>
-          <p:cNvSpPr txBox="1"/>
-          <p:nvPr/>
-        </p:nvSpPr>
-        <p:spPr>
-          <a:xfrm>
-            <a:off x="647698" y="5086337"/>
-            <a:ext cx="3428991" cy="247649"/>
-          </a:xfrm>
-          <a:prstGeom prst="rect">
-            <a:avLst/>
-          </a:prstGeom>
-          <a:noFill/>
-          <a:ln/>
-        </p:spPr>
-        <p:txBody>
-          <a:bodyPr wrap="square" lIns="0" tIns="0" rIns="0" bIns="0" rtlCol="0" anchor="ctr"/>
-          <a:lstStyle/>
-          <a:p>
-            <a:pPr indent="0" marL="0">
-              <a:buNone/>
-            </a:pPr>
-            <a:r>
-              <a:rPr lang="en-US" sz="1400" dirty="0">
-                <a:solidFill>
-                  <a:srgbClr val="1B468B"/>
-                </a:solidFill>
-                <a:latin typeface="페이퍼로지 8 ExtraBold" pitchFamily="34" charset="0"/>
-                <a:ea typeface="페이퍼로지 8 ExtraBold" pitchFamily="34" charset="-122"/>
-                <a:cs typeface="페이퍼로지 8 ExtraBold" pitchFamily="34" charset="-120"/>
-              </a:rPr>
-              <a:t>주간 10억 명</a:t>
-            </a:r>
-            <a:endParaRPr lang="en-US" sz="1400" dirty="0"/>
-          </a:p>
-        </p:txBody>
-      </p:sp>
-      <p:sp>
-        <p:nvSpPr>
-          <p:cNvPr id="73" name="Text 70"/>
-          <p:cNvSpPr txBox="1"/>
-          <p:nvPr/>
-        </p:nvSpPr>
-        <p:spPr>
-          <a:xfrm>
-            <a:off x="647698" y="5333987"/>
-            <a:ext cx="3428991" cy="247649"/>
-          </a:xfrm>
-          <a:prstGeom prst="rect">
-            <a:avLst/>
-          </a:prstGeom>
-          <a:noFill/>
-          <a:ln/>
-        </p:spPr>
-        <p:txBody>
-          <a:bodyPr wrap="square" lIns="0" tIns="0" rIns="0" bIns="0" rtlCol="0" anchor="ctr"/>
-          <a:lstStyle/>
-          <a:p>
-            <a:pPr indent="0" marL="0">
-              <a:lnSpc>
-                <a:spcPct val="120000"/>
-              </a:lnSpc>
-              <a:buNone/>
-            </a:pPr>
-            <a:r>
-              <a:rPr lang="en-US" sz="800" dirty="0">
-                <a:solidFill>
-                  <a:srgbClr val="334155"/>
-                </a:solidFill>
-                <a:latin typeface="페이퍼로지 4 Regular" pitchFamily="34" charset="0"/>
-                <a:ea typeface="페이퍼로지 4 Regular" pitchFamily="34" charset="-122"/>
-                <a:cs typeface="페이퍼로지 4 Regular" pitchFamily="34" charset="-120"/>
-              </a:rPr>
-              <a:t>ChatGPT 주간 활성 이용자 — 검색 시작점 이동</a:t>
-            </a:r>
-            <a:endParaRPr lang="en-US" sz="800" dirty="0"/>
-          </a:p>
-        </p:txBody>
-      </p:sp>
-      <p:sp>
-        <p:nvSpPr>
-          <p:cNvPr id="74" name="Shape 71"/>
-          <p:cNvSpPr/>
-          <p:nvPr/>
-        </p:nvSpPr>
-        <p:spPr>
-          <a:xfrm>
-            <a:off x="4267189" y="5124437"/>
-            <a:ext cx="28575" cy="438149"/>
-          </a:xfrm>
-          <a:prstGeom prst="rect">
-            <a:avLst/>
-          </a:prstGeom>
-          <a:solidFill>
-            <a:srgbClr val="399BC1"/>
-          </a:solidFill>
-          <a:ln/>
-        </p:spPr>
-      </p:sp>
-      <p:sp>
-        <p:nvSpPr>
-          <p:cNvPr id="75" name="Text 72"/>
-          <p:cNvSpPr txBox="1"/>
-          <p:nvPr/>
-        </p:nvSpPr>
-        <p:spPr>
-          <a:xfrm>
-            <a:off x="4381489" y="5086337"/>
-            <a:ext cx="3428991" cy="247649"/>
-          </a:xfrm>
-          <a:prstGeom prst="rect">
-            <a:avLst/>
-          </a:prstGeom>
-          <a:noFill/>
-          <a:ln/>
-        </p:spPr>
-        <p:txBody>
-          <a:bodyPr wrap="square" lIns="0" tIns="0" rIns="0" bIns="0" rtlCol="0" anchor="ctr"/>
-          <a:lstStyle/>
-          <a:p>
-            <a:pPr indent="0" marL="0">
-              <a:buNone/>
-            </a:pPr>
-            <a:r>
-              <a:rPr lang="en-US" sz="1400" dirty="0">
-                <a:solidFill>
-                  <a:srgbClr val="1B468B"/>
-                </a:solidFill>
-                <a:latin typeface="페이퍼로지 8 ExtraBold" pitchFamily="34" charset="0"/>
-                <a:ea typeface="페이퍼로지 8 ExtraBold" pitchFamily="34" charset="-122"/>
-                <a:cs typeface="페이퍼로지 8 ExtraBold" pitchFamily="34" charset="-120"/>
-              </a:rPr>
-              <a:t>약 40%</a:t>
-            </a:r>
-            <a:endParaRPr lang="en-US" sz="1400" dirty="0"/>
-          </a:p>
-        </p:txBody>
-      </p:sp>
-      <p:sp>
-        <p:nvSpPr>
-          <p:cNvPr id="76" name="Text 73"/>
-          <p:cNvSpPr txBox="1"/>
-          <p:nvPr/>
-        </p:nvSpPr>
-        <p:spPr>
-          <a:xfrm>
-            <a:off x="4381489" y="5333987"/>
-            <a:ext cx="3428991" cy="247649"/>
-          </a:xfrm>
-          <a:prstGeom prst="rect">
-            <a:avLst/>
-          </a:prstGeom>
-          <a:noFill/>
-          <a:ln/>
-        </p:spPr>
-        <p:txBody>
-          <a:bodyPr wrap="square" lIns="0" tIns="0" rIns="0" bIns="0" rtlCol="0" anchor="ctr"/>
-          <a:lstStyle/>
-          <a:p>
-            <a:pPr indent="0" marL="0">
-              <a:lnSpc>
-                <a:spcPct val="120000"/>
-              </a:lnSpc>
-              <a:buNone/>
-            </a:pPr>
-            <a:r>
-              <a:rPr lang="en-US" sz="800" dirty="0">
-                <a:solidFill>
-                  <a:srgbClr val="334155"/>
-                </a:solidFill>
-                <a:latin typeface="페이퍼로지 4 Regular" pitchFamily="34" charset="0"/>
-                <a:ea typeface="페이퍼로지 4 Regular" pitchFamily="34" charset="-122"/>
-                <a:cs typeface="페이퍼로지 4 Regular" pitchFamily="34" charset="-120"/>
-              </a:rPr>
-              <a:t>2026년 AI 제작 디지털 광고 비중 전망</a:t>
-            </a:r>
-            <a:endParaRPr lang="en-US" sz="800" dirty="0"/>
-          </a:p>
-        </p:txBody>
-      </p:sp>
-      <p:sp>
-        <p:nvSpPr>
-          <p:cNvPr id="77" name="Shape 74"/>
-          <p:cNvSpPr/>
-          <p:nvPr/>
-        </p:nvSpPr>
-        <p:spPr>
-          <a:xfrm>
-            <a:off x="8000980" y="5124437"/>
-            <a:ext cx="28575" cy="438149"/>
-          </a:xfrm>
-          <a:prstGeom prst="rect">
-            <a:avLst/>
-          </a:prstGeom>
-          <a:solidFill>
-            <a:srgbClr val="399BC1"/>
-          </a:solidFill>
-          <a:ln/>
-        </p:spPr>
-      </p:sp>
-      <p:sp>
-        <p:nvSpPr>
-          <p:cNvPr id="78" name="Text 75"/>
-          <p:cNvSpPr txBox="1"/>
-          <p:nvPr/>
-        </p:nvSpPr>
-        <p:spPr>
-          <a:xfrm>
-            <a:off x="8115280" y="5086337"/>
-            <a:ext cx="3428991" cy="247649"/>
-          </a:xfrm>
-          <a:prstGeom prst="rect">
-            <a:avLst/>
-          </a:prstGeom>
-          <a:noFill/>
-          <a:ln/>
-        </p:spPr>
-        <p:txBody>
-          <a:bodyPr wrap="square" lIns="0" tIns="0" rIns="0" bIns="0" rtlCol="0" anchor="ctr"/>
-          <a:lstStyle/>
-          <a:p>
-            <a:pPr indent="0" marL="0">
-              <a:buNone/>
-            </a:pPr>
-            <a:r>
-              <a:rPr lang="en-US" sz="1400" dirty="0">
-                <a:solidFill>
-                  <a:srgbClr val="1B468B"/>
-                </a:solidFill>
-                <a:latin typeface="페이퍼로지 8 ExtraBold" pitchFamily="34" charset="0"/>
-                <a:ea typeface="페이퍼로지 8 ExtraBold" pitchFamily="34" charset="-122"/>
-                <a:cs typeface="페이퍼로지 8 ExtraBold" pitchFamily="34" charset="-120"/>
-              </a:rPr>
-              <a:t>0.8~1.3%</a:t>
-            </a:r>
-            <a:endParaRPr lang="en-US" sz="1400" dirty="0"/>
-          </a:p>
-        </p:txBody>
-      </p:sp>
-      <p:sp>
-        <p:nvSpPr>
-          <p:cNvPr id="79" name="Text 76"/>
-          <p:cNvSpPr txBox="1"/>
-          <p:nvPr/>
-        </p:nvSpPr>
-        <p:spPr>
-          <a:xfrm>
-            <a:off x="8115280" y="5333987"/>
-            <a:ext cx="3428991" cy="247649"/>
-          </a:xfrm>
-          <a:prstGeom prst="rect">
-            <a:avLst/>
-          </a:prstGeom>
-          <a:noFill/>
-          <a:ln/>
-        </p:spPr>
-        <p:txBody>
-          <a:bodyPr wrap="square" lIns="0" tIns="0" rIns="0" bIns="0" rtlCol="0" anchor="ctr"/>
-          <a:lstStyle/>
-          <a:p>
-            <a:pPr indent="0" marL="0">
-              <a:lnSpc>
-                <a:spcPct val="120000"/>
-              </a:lnSpc>
-              <a:buNone/>
-            </a:pPr>
-            <a:r>
-              <a:rPr lang="en-US" sz="800" dirty="0">
-                <a:solidFill>
-                  <a:srgbClr val="334155"/>
-                </a:solidFill>
-                <a:latin typeface="페이퍼로지 4 Regular" pitchFamily="34" charset="0"/>
-                <a:ea typeface="페이퍼로지 4 Regular" pitchFamily="34" charset="-122"/>
-                <a:cs typeface="페이퍼로지 4 Regular" pitchFamily="34" charset="-120"/>
-              </a:rPr>
-              <a:t>AI 검색 클릭률(구글 29%) — 인용 없으면 유입 없음</a:t>
-            </a:r>
-            <a:endParaRPr lang="en-US" sz="800" dirty="0"/>
-          </a:p>
-        </p:txBody>
-      </p:sp>
-      <p:sp>
-        <p:nvSpPr>
-          <p:cNvPr id="80" name="Text 77"/>
-          <p:cNvSpPr txBox="1"/>
-          <p:nvPr/>
-        </p:nvSpPr>
-        <p:spPr>
-          <a:xfrm>
-            <a:off x="533399" y="5676886"/>
             <a:ext cx="851533" cy="209549"/>
           </a:xfrm>
           <a:prstGeom prst="rect">
@@ -4423,13 +4077,13 @@
       </p:sp>
       <p:sp>
         <p:nvSpPr>
-          <p:cNvPr id="81" name="Shape 78"/>
-          <p:cNvSpPr/>
-          <p:nvPr/>
-        </p:nvSpPr>
-        <p:spPr>
-          <a:xfrm>
-            <a:off x="1423031" y="5676886"/>
+          <p:cNvPr id="72" name="Shape 69"/>
+          <p:cNvSpPr/>
+          <p:nvPr/>
+        </p:nvSpPr>
+        <p:spPr>
+          <a:xfrm>
+            <a:off x="1423031" y="5124437"/>
             <a:ext cx="720088" cy="209549"/>
           </a:xfrm>
           <a:prstGeom prst="roundRect">
@@ -4450,7 +4104,7 @@
       </p:sp>
       <p:pic>
         <p:nvPicPr>
-          <p:cNvPr id="82" name="Image 1" descr="/home/user/mplanit/ai-solution/assets/png/icon-naver.png">    </p:cNvPr>
+          <p:cNvPr id="73" name="Image 1" descr="/home/user/mplanit/ai-solution/assets/png/icon-naver.png">    </p:cNvPr>
           <p:cNvPicPr>
             <a:picLocks noChangeAspect="1"/>
           </p:cNvPicPr>
@@ -4464,7 +4118,7 @@
         </p:blipFill>
         <p:spPr>
           <a:xfrm>
-            <a:off x="1489706" y="5729273"/>
+            <a:off x="1489706" y="5176825"/>
             <a:ext cx="104775" cy="104775"/>
           </a:xfrm>
           <a:prstGeom prst="rect">
@@ -4474,13 +4128,13 @@
       </p:pic>
       <p:sp>
         <p:nvSpPr>
-          <p:cNvPr id="83" name="Text 79"/>
-          <p:cNvSpPr txBox="1"/>
-          <p:nvPr/>
-        </p:nvSpPr>
-        <p:spPr>
-          <a:xfrm>
-            <a:off x="1623056" y="5676886"/>
+          <p:cNvPr id="74" name="Text 70"/>
+          <p:cNvSpPr txBox="1"/>
+          <p:nvPr/>
+        </p:nvSpPr>
+        <p:spPr>
+          <a:xfrm>
+            <a:off x="1623056" y="5124437"/>
             <a:ext cx="472439" cy="209549"/>
           </a:xfrm>
           <a:prstGeom prst="rect">
@@ -4513,13 +4167,13 @@
       </p:sp>
       <p:sp>
         <p:nvSpPr>
-          <p:cNvPr id="84" name="Shape 80"/>
-          <p:cNvSpPr/>
-          <p:nvPr/>
-        </p:nvSpPr>
-        <p:spPr>
-          <a:xfrm>
-            <a:off x="2200269" y="5676886"/>
+          <p:cNvPr id="75" name="Shape 71"/>
+          <p:cNvSpPr/>
+          <p:nvPr/>
+        </p:nvSpPr>
+        <p:spPr>
+          <a:xfrm>
+            <a:off x="2200269" y="5124437"/>
             <a:ext cx="445769" cy="209549"/>
           </a:xfrm>
           <a:prstGeom prst="roundRect">
@@ -4540,13 +4194,13 @@
       </p:sp>
       <p:sp>
         <p:nvSpPr>
-          <p:cNvPr id="85" name="Shape 81"/>
-          <p:cNvSpPr/>
-          <p:nvPr/>
-        </p:nvSpPr>
-        <p:spPr>
-          <a:xfrm>
-            <a:off x="2276469" y="5753086"/>
+          <p:cNvPr id="76" name="Shape 72"/>
+          <p:cNvSpPr/>
+          <p:nvPr/>
+        </p:nvSpPr>
+        <p:spPr>
+          <a:xfrm>
+            <a:off x="2276469" y="5200637"/>
             <a:ext cx="57150" cy="57150"/>
           </a:xfrm>
           <a:prstGeom prst="ellipse">
@@ -4565,13 +4219,13 @@
       </p:sp>
       <p:sp>
         <p:nvSpPr>
-          <p:cNvPr id="86" name="Text 82"/>
-          <p:cNvSpPr txBox="1"/>
-          <p:nvPr/>
-        </p:nvSpPr>
-        <p:spPr>
-          <a:xfrm>
-            <a:off x="2371719" y="5676886"/>
+          <p:cNvPr id="77" name="Text 73"/>
+          <p:cNvSpPr txBox="1"/>
+          <p:nvPr/>
+        </p:nvSpPr>
+        <p:spPr>
+          <a:xfrm>
+            <a:off x="2371719" y="5124437"/>
             <a:ext cx="217169" cy="209549"/>
           </a:xfrm>
           <a:prstGeom prst="rect">
@@ -4604,13 +4258,13 @@
       </p:sp>
       <p:sp>
         <p:nvSpPr>
-          <p:cNvPr id="87" name="Shape 83"/>
-          <p:cNvSpPr/>
-          <p:nvPr/>
-        </p:nvSpPr>
-        <p:spPr>
-          <a:xfrm>
-            <a:off x="2703188" y="5676886"/>
+          <p:cNvPr id="78" name="Shape 74"/>
+          <p:cNvSpPr/>
+          <p:nvPr/>
+        </p:nvSpPr>
+        <p:spPr>
+          <a:xfrm>
+            <a:off x="2703188" y="5124437"/>
             <a:ext cx="518159" cy="209549"/>
           </a:xfrm>
           <a:prstGeom prst="roundRect">
@@ -4631,13 +4285,13 @@
       </p:sp>
       <p:sp>
         <p:nvSpPr>
-          <p:cNvPr id="88" name="Shape 84"/>
-          <p:cNvSpPr/>
-          <p:nvPr/>
-        </p:nvSpPr>
-        <p:spPr>
-          <a:xfrm>
-            <a:off x="2779388" y="5753086"/>
+          <p:cNvPr id="79" name="Shape 75"/>
+          <p:cNvSpPr/>
+          <p:nvPr/>
+        </p:nvSpPr>
+        <p:spPr>
+          <a:xfrm>
+            <a:off x="2779388" y="5200637"/>
             <a:ext cx="57150" cy="57150"/>
           </a:xfrm>
           <a:prstGeom prst="ellipse">
@@ -4656,13 +4310,13 @@
       </p:sp>
       <p:sp>
         <p:nvSpPr>
-          <p:cNvPr id="89" name="Text 85"/>
-          <p:cNvSpPr txBox="1"/>
-          <p:nvPr/>
-        </p:nvSpPr>
-        <p:spPr>
-          <a:xfrm>
-            <a:off x="2874638" y="5676886"/>
+          <p:cNvPr id="80" name="Text 76"/>
+          <p:cNvSpPr txBox="1"/>
+          <p:nvPr/>
+        </p:nvSpPr>
+        <p:spPr>
+          <a:xfrm>
+            <a:off x="2874638" y="5124437"/>
             <a:ext cx="289559" cy="209549"/>
           </a:xfrm>
           <a:prstGeom prst="rect">
@@ -4695,13 +4349,13 @@
       </p:sp>
       <p:sp>
         <p:nvSpPr>
-          <p:cNvPr id="90" name="Shape 86"/>
-          <p:cNvSpPr/>
-          <p:nvPr/>
-        </p:nvSpPr>
-        <p:spPr>
-          <a:xfrm>
-            <a:off x="3278497" y="5676886"/>
+          <p:cNvPr id="81" name="Shape 77"/>
+          <p:cNvSpPr/>
+          <p:nvPr/>
+        </p:nvSpPr>
+        <p:spPr>
+          <a:xfrm>
+            <a:off x="3278497" y="5124437"/>
             <a:ext cx="662938" cy="209549"/>
           </a:xfrm>
           <a:prstGeom prst="roundRect">
@@ -4722,13 +4376,13 @@
       </p:sp>
       <p:sp>
         <p:nvSpPr>
-          <p:cNvPr id="91" name="Shape 87"/>
-          <p:cNvSpPr/>
-          <p:nvPr/>
-        </p:nvSpPr>
-        <p:spPr>
-          <a:xfrm>
-            <a:off x="3354697" y="5753086"/>
+          <p:cNvPr id="82" name="Shape 78"/>
+          <p:cNvSpPr/>
+          <p:nvPr/>
+        </p:nvSpPr>
+        <p:spPr>
+          <a:xfrm>
+            <a:off x="3354697" y="5200637"/>
             <a:ext cx="57150" cy="57150"/>
           </a:xfrm>
           <a:prstGeom prst="ellipse">
@@ -4747,13 +4401,13 @@
       </p:sp>
       <p:sp>
         <p:nvSpPr>
-          <p:cNvPr id="92" name="Text 88"/>
-          <p:cNvSpPr txBox="1"/>
-          <p:nvPr/>
-        </p:nvSpPr>
-        <p:spPr>
-          <a:xfrm>
-            <a:off x="3449946" y="5676886"/>
+          <p:cNvPr id="83" name="Text 79"/>
+          <p:cNvSpPr txBox="1"/>
+          <p:nvPr/>
+        </p:nvSpPr>
+        <p:spPr>
+          <a:xfrm>
+            <a:off x="3449946" y="5124437"/>
             <a:ext cx="434339" cy="209549"/>
           </a:xfrm>
           <a:prstGeom prst="rect">
@@ -4786,13 +4440,13 @@
       </p:sp>
       <p:sp>
         <p:nvSpPr>
-          <p:cNvPr id="93" name="Shape 89"/>
-          <p:cNvSpPr/>
-          <p:nvPr/>
-        </p:nvSpPr>
-        <p:spPr>
-          <a:xfrm>
-            <a:off x="3998585" y="5676886"/>
+          <p:cNvPr id="84" name="Shape 80"/>
+          <p:cNvSpPr/>
+          <p:nvPr/>
+        </p:nvSpPr>
+        <p:spPr>
+          <a:xfrm>
+            <a:off x="3998585" y="5124437"/>
             <a:ext cx="590549" cy="209549"/>
           </a:xfrm>
           <a:prstGeom prst="roundRect">
@@ -4813,13 +4467,13 @@
       </p:sp>
       <p:sp>
         <p:nvSpPr>
-          <p:cNvPr id="94" name="Shape 90"/>
-          <p:cNvSpPr/>
-          <p:nvPr/>
-        </p:nvSpPr>
-        <p:spPr>
-          <a:xfrm>
-            <a:off x="4074785" y="5753086"/>
+          <p:cNvPr id="85" name="Shape 81"/>
+          <p:cNvSpPr/>
+          <p:nvPr/>
+        </p:nvSpPr>
+        <p:spPr>
+          <a:xfrm>
+            <a:off x="4074785" y="5200637"/>
             <a:ext cx="57150" cy="57150"/>
           </a:xfrm>
           <a:prstGeom prst="ellipse">
@@ -4838,13 +4492,13 @@
       </p:sp>
       <p:sp>
         <p:nvSpPr>
-          <p:cNvPr id="95" name="Text 91"/>
-          <p:cNvSpPr txBox="1"/>
-          <p:nvPr/>
-        </p:nvSpPr>
-        <p:spPr>
-          <a:xfrm>
-            <a:off x="4170035" y="5676886"/>
+          <p:cNvPr id="86" name="Text 82"/>
+          <p:cNvSpPr txBox="1"/>
+          <p:nvPr/>
+        </p:nvSpPr>
+        <p:spPr>
+          <a:xfrm>
+            <a:off x="4170035" y="5124437"/>
             <a:ext cx="361949" cy="209549"/>
           </a:xfrm>
           <a:prstGeom prst="rect">
@@ -4877,13 +4531,13 @@
       </p:sp>
       <p:sp>
         <p:nvSpPr>
-          <p:cNvPr id="96" name="Shape 92"/>
-          <p:cNvSpPr/>
-          <p:nvPr/>
-        </p:nvSpPr>
-        <p:spPr>
-          <a:xfrm>
-            <a:off x="4646283" y="5676886"/>
+          <p:cNvPr id="87" name="Shape 83"/>
+          <p:cNvSpPr/>
+          <p:nvPr/>
+        </p:nvSpPr>
+        <p:spPr>
+          <a:xfrm>
+            <a:off x="4646283" y="5124437"/>
             <a:ext cx="1009647" cy="209549"/>
           </a:xfrm>
           <a:prstGeom prst="roundRect">
@@ -4904,7 +4558,7 @@
       </p:sp>
       <p:pic>
         <p:nvPicPr>
-          <p:cNvPr id="97" name="Image 2" descr="/home/user/mplanit/ai-solution/assets/png/icon-googleads.png">    </p:cNvPr>
+          <p:cNvPr id="88" name="Image 2" descr="/home/user/mplanit/ai-solution/assets/png/icon-googleads.png">    </p:cNvPr>
           <p:cNvPicPr>
             <a:picLocks noChangeAspect="1"/>
           </p:cNvPicPr>
@@ -4918,7 +4572,7 @@
         </p:blipFill>
         <p:spPr>
           <a:xfrm>
-            <a:off x="4712958" y="5729273"/>
+            <a:off x="4712958" y="5176825"/>
             <a:ext cx="104775" cy="104775"/>
           </a:xfrm>
           <a:prstGeom prst="rect">
@@ -4928,13 +4582,13 @@
       </p:pic>
       <p:sp>
         <p:nvSpPr>
-          <p:cNvPr id="98" name="Text 93"/>
-          <p:cNvSpPr txBox="1"/>
-          <p:nvPr/>
-        </p:nvSpPr>
-        <p:spPr>
-          <a:xfrm>
-            <a:off x="4846308" y="5676886"/>
+          <p:cNvPr id="89" name="Text 84"/>
+          <p:cNvSpPr txBox="1"/>
+          <p:nvPr/>
+        </p:nvSpPr>
+        <p:spPr>
+          <a:xfrm>
+            <a:off x="4846308" y="5124437"/>
             <a:ext cx="761998" cy="209549"/>
           </a:xfrm>
           <a:prstGeom prst="rect">
@@ -4967,13 +4621,13 @@
       </p:sp>
       <p:sp>
         <p:nvSpPr>
-          <p:cNvPr id="99" name="Shape 94"/>
-          <p:cNvSpPr/>
-          <p:nvPr/>
-        </p:nvSpPr>
-        <p:spPr>
-          <a:xfrm>
-            <a:off x="5713081" y="5676886"/>
+          <p:cNvPr id="90" name="Shape 85"/>
+          <p:cNvSpPr/>
+          <p:nvPr/>
+        </p:nvSpPr>
+        <p:spPr>
+          <a:xfrm>
+            <a:off x="5713081" y="5124437"/>
             <a:ext cx="430529" cy="209549"/>
           </a:xfrm>
           <a:prstGeom prst="roundRect">
@@ -4994,7 +4648,7 @@
       </p:sp>
       <p:pic>
         <p:nvPicPr>
-          <p:cNvPr id="100" name="Image 3" descr="/home/user/mplanit/ai-solution/assets/png/icon-meta.png">    </p:cNvPr>
+          <p:cNvPr id="91" name="Image 3" descr="/home/user/mplanit/ai-solution/assets/png/icon-meta.png">    </p:cNvPr>
           <p:cNvPicPr>
             <a:picLocks noChangeAspect="1"/>
           </p:cNvPicPr>
@@ -5008,7 +4662,7 @@
         </p:blipFill>
         <p:spPr>
           <a:xfrm>
-            <a:off x="5779756" y="5729273"/>
+            <a:off x="5779756" y="5176825"/>
             <a:ext cx="104775" cy="104775"/>
           </a:xfrm>
           <a:prstGeom prst="rect">
@@ -5018,13 +4672,13 @@
       </p:pic>
       <p:sp>
         <p:nvSpPr>
-          <p:cNvPr id="101" name="Text 95"/>
-          <p:cNvSpPr txBox="1"/>
-          <p:nvPr/>
-        </p:nvSpPr>
-        <p:spPr>
-          <a:xfrm>
-            <a:off x="5913105" y="5676886"/>
+          <p:cNvPr id="92" name="Text 86"/>
+          <p:cNvSpPr txBox="1"/>
+          <p:nvPr/>
+        </p:nvSpPr>
+        <p:spPr>
+          <a:xfrm>
+            <a:off x="5913105" y="5124437"/>
             <a:ext cx="182880" cy="209549"/>
           </a:xfrm>
           <a:prstGeom prst="rect">
@@ -5057,13 +4711,13 @@
       </p:sp>
       <p:sp>
         <p:nvSpPr>
-          <p:cNvPr id="102" name="Shape 96"/>
-          <p:cNvSpPr/>
-          <p:nvPr/>
-        </p:nvSpPr>
-        <p:spPr>
-          <a:xfrm>
-            <a:off x="6200759" y="5676886"/>
+          <p:cNvPr id="93" name="Shape 87"/>
+          <p:cNvSpPr/>
+          <p:nvPr/>
+        </p:nvSpPr>
+        <p:spPr>
+          <a:xfrm>
+            <a:off x="6200759" y="5124437"/>
             <a:ext cx="430529" cy="209549"/>
           </a:xfrm>
           <a:prstGeom prst="roundRect">
@@ -5084,7 +4738,7 @@
       </p:sp>
       <p:pic>
         <p:nvPicPr>
-          <p:cNvPr id="103" name="Image 4" descr="/home/user/mplanit/ai-solution/assets/png/icon-tiktok.png">    </p:cNvPr>
+          <p:cNvPr id="94" name="Image 4" descr="/home/user/mplanit/ai-solution/assets/png/icon-tiktok.png">    </p:cNvPr>
           <p:cNvPicPr>
             <a:picLocks noChangeAspect="1"/>
           </p:cNvPicPr>
@@ -5098,7 +4752,7 @@
         </p:blipFill>
         <p:spPr>
           <a:xfrm>
-            <a:off x="6267434" y="5729273"/>
+            <a:off x="6267434" y="5176825"/>
             <a:ext cx="104775" cy="104775"/>
           </a:xfrm>
           <a:prstGeom prst="rect">
@@ -5108,13 +4762,13 @@
       </p:pic>
       <p:sp>
         <p:nvSpPr>
-          <p:cNvPr id="104" name="Text 97"/>
-          <p:cNvSpPr txBox="1"/>
-          <p:nvPr/>
-        </p:nvSpPr>
-        <p:spPr>
-          <a:xfrm>
-            <a:off x="6400784" y="5676886"/>
+          <p:cNvPr id="95" name="Text 88"/>
+          <p:cNvSpPr txBox="1"/>
+          <p:nvPr/>
+        </p:nvSpPr>
+        <p:spPr>
+          <a:xfrm>
+            <a:off x="6400784" y="5124437"/>
             <a:ext cx="182880" cy="209549"/>
           </a:xfrm>
           <a:prstGeom prst="rect">
@@ -5147,13 +4801,13 @@
       </p:sp>
       <p:sp>
         <p:nvSpPr>
-          <p:cNvPr id="105" name="Shape 98"/>
-          <p:cNvSpPr/>
-          <p:nvPr/>
-        </p:nvSpPr>
-        <p:spPr>
-          <a:xfrm>
-            <a:off x="6688438" y="5676886"/>
+          <p:cNvPr id="96" name="Shape 89"/>
+          <p:cNvSpPr/>
+          <p:nvPr/>
+        </p:nvSpPr>
+        <p:spPr>
+          <a:xfrm>
+            <a:off x="6688438" y="5124437"/>
             <a:ext cx="518159" cy="209549"/>
           </a:xfrm>
           <a:prstGeom prst="roundRect">
@@ -5174,13 +4828,13 @@
       </p:sp>
       <p:sp>
         <p:nvSpPr>
-          <p:cNvPr id="106" name="Shape 99"/>
-          <p:cNvSpPr/>
-          <p:nvPr/>
-        </p:nvSpPr>
-        <p:spPr>
-          <a:xfrm>
-            <a:off x="6764638" y="5753086"/>
+          <p:cNvPr id="97" name="Shape 90"/>
+          <p:cNvSpPr/>
+          <p:nvPr/>
+        </p:nvSpPr>
+        <p:spPr>
+          <a:xfrm>
+            <a:off x="6764638" y="5200637"/>
             <a:ext cx="57150" cy="57150"/>
           </a:xfrm>
           <a:prstGeom prst="ellipse">
@@ -5199,13 +4853,13 @@
       </p:sp>
       <p:sp>
         <p:nvSpPr>
-          <p:cNvPr id="107" name="Text 100"/>
-          <p:cNvSpPr txBox="1"/>
-          <p:nvPr/>
-        </p:nvSpPr>
-        <p:spPr>
-          <a:xfrm>
-            <a:off x="6859888" y="5676886"/>
+          <p:cNvPr id="98" name="Text 91"/>
+          <p:cNvSpPr txBox="1"/>
+          <p:nvPr/>
+        </p:nvSpPr>
+        <p:spPr>
+          <a:xfrm>
+            <a:off x="6859888" y="5124437"/>
             <a:ext cx="289559" cy="209549"/>
           </a:xfrm>
           <a:prstGeom prst="rect">
@@ -5238,13 +4892,13 @@
       </p:sp>
       <p:sp>
         <p:nvSpPr>
-          <p:cNvPr id="108" name="Shape 101"/>
-          <p:cNvSpPr/>
-          <p:nvPr/>
-        </p:nvSpPr>
-        <p:spPr>
-          <a:xfrm>
-            <a:off x="7263747" y="5676886"/>
+          <p:cNvPr id="99" name="Shape 92"/>
+          <p:cNvSpPr/>
+          <p:nvPr/>
+        </p:nvSpPr>
+        <p:spPr>
+          <a:xfrm>
+            <a:off x="7263747" y="5124437"/>
             <a:ext cx="445769" cy="209549"/>
           </a:xfrm>
           <a:prstGeom prst="roundRect">
@@ -5265,13 +4919,13 @@
       </p:sp>
       <p:sp>
         <p:nvSpPr>
-          <p:cNvPr id="109" name="Shape 102"/>
-          <p:cNvSpPr/>
-          <p:nvPr/>
-        </p:nvSpPr>
-        <p:spPr>
-          <a:xfrm>
-            <a:off x="7339947" y="5753086"/>
+          <p:cNvPr id="100" name="Shape 93"/>
+          <p:cNvSpPr/>
+          <p:nvPr/>
+        </p:nvSpPr>
+        <p:spPr>
+          <a:xfrm>
+            <a:off x="7339947" y="5200637"/>
             <a:ext cx="57150" cy="57150"/>
           </a:xfrm>
           <a:prstGeom prst="ellipse">
@@ -5290,13 +4944,13 @@
       </p:sp>
       <p:sp>
         <p:nvSpPr>
-          <p:cNvPr id="110" name="Text 103"/>
-          <p:cNvSpPr txBox="1"/>
-          <p:nvPr/>
-        </p:nvSpPr>
-        <p:spPr>
-          <a:xfrm>
-            <a:off x="7435196" y="5676886"/>
+          <p:cNvPr id="101" name="Text 94"/>
+          <p:cNvSpPr txBox="1"/>
+          <p:nvPr/>
+        </p:nvSpPr>
+        <p:spPr>
+          <a:xfrm>
+            <a:off x="7435196" y="5124437"/>
             <a:ext cx="217169" cy="209549"/>
           </a:xfrm>
           <a:prstGeom prst="rect">
@@ -5329,13 +4983,13 @@
       </p:sp>
       <p:sp>
         <p:nvSpPr>
-          <p:cNvPr id="111" name="Shape 104"/>
-          <p:cNvSpPr/>
-          <p:nvPr/>
-        </p:nvSpPr>
-        <p:spPr>
-          <a:xfrm>
-            <a:off x="7766666" y="5676886"/>
+          <p:cNvPr id="102" name="Shape 95"/>
+          <p:cNvSpPr/>
+          <p:nvPr/>
+        </p:nvSpPr>
+        <p:spPr>
+          <a:xfrm>
+            <a:off x="7766666" y="5124437"/>
             <a:ext cx="937258" cy="209549"/>
           </a:xfrm>
           <a:prstGeom prst="roundRect">
@@ -5356,7 +5010,7 @@
       </p:sp>
       <p:pic>
         <p:nvPicPr>
-          <p:cNvPr id="112" name="Image 5" descr="/home/user/mplanit/ai-solution/assets/png/icon-apple.png">    </p:cNvPr>
+          <p:cNvPr id="103" name="Image 5" descr="/home/user/mplanit/ai-solution/assets/png/icon-apple.png">    </p:cNvPr>
           <p:cNvPicPr>
             <a:picLocks noChangeAspect="1"/>
           </p:cNvPicPr>
@@ -5370,7 +5024,7 @@
         </p:blipFill>
         <p:spPr>
           <a:xfrm>
-            <a:off x="7833340" y="5729273"/>
+            <a:off x="7833340" y="5176825"/>
             <a:ext cx="104775" cy="104775"/>
           </a:xfrm>
           <a:prstGeom prst="rect">
@@ -5380,13 +5034,13 @@
       </p:pic>
       <p:sp>
         <p:nvSpPr>
-          <p:cNvPr id="113" name="Text 105"/>
-          <p:cNvSpPr txBox="1"/>
-          <p:nvPr/>
-        </p:nvSpPr>
-        <p:spPr>
-          <a:xfrm>
-            <a:off x="7966690" y="5676886"/>
+          <p:cNvPr id="104" name="Text 96"/>
+          <p:cNvSpPr txBox="1"/>
+          <p:nvPr/>
+        </p:nvSpPr>
+        <p:spPr>
+          <a:xfrm>
+            <a:off x="7966690" y="5124437"/>
             <a:ext cx="689608" cy="209549"/>
           </a:xfrm>
           <a:prstGeom prst="rect">
@@ -5419,13 +5073,13 @@
       </p:sp>
       <p:sp>
         <p:nvSpPr>
-          <p:cNvPr id="114" name="Shape 106"/>
-          <p:cNvSpPr/>
-          <p:nvPr/>
-        </p:nvSpPr>
-        <p:spPr>
-          <a:xfrm>
-            <a:off x="8761073" y="5676886"/>
+          <p:cNvPr id="105" name="Shape 97"/>
+          <p:cNvSpPr/>
+          <p:nvPr/>
+        </p:nvSpPr>
+        <p:spPr>
+          <a:xfrm>
+            <a:off x="8761073" y="5124437"/>
             <a:ext cx="373379" cy="209549"/>
           </a:xfrm>
           <a:prstGeom prst="roundRect">
@@ -5446,13 +5100,13 @@
       </p:sp>
       <p:sp>
         <p:nvSpPr>
-          <p:cNvPr id="115" name="Shape 107"/>
-          <p:cNvSpPr/>
-          <p:nvPr/>
-        </p:nvSpPr>
-        <p:spPr>
-          <a:xfrm>
-            <a:off x="8837273" y="5753086"/>
+          <p:cNvPr id="106" name="Shape 98"/>
+          <p:cNvSpPr/>
+          <p:nvPr/>
+        </p:nvSpPr>
+        <p:spPr>
+          <a:xfrm>
+            <a:off x="8837273" y="5200637"/>
             <a:ext cx="57150" cy="57150"/>
           </a:xfrm>
           <a:prstGeom prst="ellipse">
@@ -5471,13 +5125,13 @@
       </p:sp>
       <p:sp>
         <p:nvSpPr>
-          <p:cNvPr id="116" name="Text 108"/>
-          <p:cNvSpPr txBox="1"/>
-          <p:nvPr/>
-        </p:nvSpPr>
-        <p:spPr>
-          <a:xfrm>
-            <a:off x="8932523" y="5676886"/>
+          <p:cNvPr id="107" name="Text 99"/>
+          <p:cNvSpPr txBox="1"/>
+          <p:nvPr/>
+        </p:nvSpPr>
+        <p:spPr>
+          <a:xfrm>
+            <a:off x="8932523" y="5124437"/>
             <a:ext cx="144780" cy="209549"/>
           </a:xfrm>
           <a:prstGeom prst="rect">
@@ -5510,13 +5164,13 @@
       </p:sp>
       <p:sp>
         <p:nvSpPr>
-          <p:cNvPr id="117" name="Shape 109"/>
-          <p:cNvSpPr/>
-          <p:nvPr/>
-        </p:nvSpPr>
-        <p:spPr>
-          <a:xfrm>
-            <a:off x="9191602" y="5676886"/>
+          <p:cNvPr id="108" name="Shape 100"/>
+          <p:cNvSpPr/>
+          <p:nvPr/>
+        </p:nvSpPr>
+        <p:spPr>
+          <a:xfrm>
+            <a:off x="9191602" y="5124437"/>
             <a:ext cx="445769" cy="209549"/>
           </a:xfrm>
           <a:prstGeom prst="roundRect">
@@ -5537,13 +5191,13 @@
       </p:sp>
       <p:sp>
         <p:nvSpPr>
-          <p:cNvPr id="118" name="Shape 110"/>
-          <p:cNvSpPr/>
-          <p:nvPr/>
-        </p:nvSpPr>
-        <p:spPr>
-          <a:xfrm>
-            <a:off x="9267802" y="5753086"/>
+          <p:cNvPr id="109" name="Shape 101"/>
+          <p:cNvSpPr/>
+          <p:nvPr/>
+        </p:nvSpPr>
+        <p:spPr>
+          <a:xfrm>
+            <a:off x="9267802" y="5200637"/>
             <a:ext cx="57150" cy="57150"/>
           </a:xfrm>
           <a:prstGeom prst="ellipse">
@@ -5562,13 +5216,13 @@
       </p:sp>
       <p:sp>
         <p:nvSpPr>
-          <p:cNvPr id="119" name="Text 111"/>
-          <p:cNvSpPr txBox="1"/>
-          <p:nvPr/>
-        </p:nvSpPr>
-        <p:spPr>
-          <a:xfrm>
-            <a:off x="9363052" y="5676886"/>
+          <p:cNvPr id="110" name="Text 102"/>
+          <p:cNvSpPr txBox="1"/>
+          <p:nvPr/>
+        </p:nvSpPr>
+        <p:spPr>
+          <a:xfrm>
+            <a:off x="9363052" y="5124437"/>
             <a:ext cx="217169" cy="209549"/>
           </a:xfrm>
           <a:prstGeom prst="rect">
@@ -5601,13 +5255,13 @@
       </p:sp>
       <p:sp>
         <p:nvSpPr>
-          <p:cNvPr id="120" name="Shape 112"/>
-          <p:cNvSpPr/>
-          <p:nvPr/>
-        </p:nvSpPr>
-        <p:spPr>
-          <a:xfrm>
-            <a:off x="9694521" y="5676886"/>
+          <p:cNvPr id="111" name="Shape 103"/>
+          <p:cNvSpPr/>
+          <p:nvPr/>
+        </p:nvSpPr>
+        <p:spPr>
+          <a:xfrm>
+            <a:off x="9694521" y="5124437"/>
             <a:ext cx="518159" cy="209549"/>
           </a:xfrm>
           <a:prstGeom prst="roundRect">
@@ -5628,13 +5282,13 @@
       </p:sp>
       <p:sp>
         <p:nvSpPr>
-          <p:cNvPr id="121" name="Shape 113"/>
-          <p:cNvSpPr/>
-          <p:nvPr/>
-        </p:nvSpPr>
-        <p:spPr>
-          <a:xfrm>
-            <a:off x="9770721" y="5753086"/>
+          <p:cNvPr id="112" name="Shape 104"/>
+          <p:cNvSpPr/>
+          <p:nvPr/>
+        </p:nvSpPr>
+        <p:spPr>
+          <a:xfrm>
+            <a:off x="9770721" y="5200637"/>
             <a:ext cx="57150" cy="57150"/>
           </a:xfrm>
           <a:prstGeom prst="ellipse">
@@ -5653,13 +5307,13 @@
       </p:sp>
       <p:sp>
         <p:nvSpPr>
-          <p:cNvPr id="122" name="Text 114"/>
-          <p:cNvSpPr txBox="1"/>
-          <p:nvPr/>
-        </p:nvSpPr>
-        <p:spPr>
-          <a:xfrm>
-            <a:off x="9865970" y="5676886"/>
+          <p:cNvPr id="113" name="Text 105"/>
+          <p:cNvSpPr txBox="1"/>
+          <p:nvPr/>
+        </p:nvSpPr>
+        <p:spPr>
+          <a:xfrm>
+            <a:off x="9865970" y="5124437"/>
             <a:ext cx="289559" cy="209549"/>
           </a:xfrm>
           <a:prstGeom prst="rect">
@@ -5692,13 +5346,13 @@
       </p:sp>
       <p:sp>
         <p:nvSpPr>
-          <p:cNvPr id="123" name="Text 115"/>
-          <p:cNvSpPr txBox="1"/>
-          <p:nvPr/>
-        </p:nvSpPr>
-        <p:spPr>
-          <a:xfrm>
-            <a:off x="10269829" y="5676886"/>
+          <p:cNvPr id="114" name="Text 106"/>
+          <p:cNvSpPr txBox="1"/>
+          <p:nvPr/>
+        </p:nvSpPr>
+        <p:spPr>
+          <a:xfrm>
+            <a:off x="10269829" y="5124437"/>
             <a:ext cx="569594" cy="209549"/>
           </a:xfrm>
           <a:prstGeom prst="rect">
@@ -5731,13 +5385,13 @@
       </p:sp>
       <p:sp>
         <p:nvSpPr>
-          <p:cNvPr id="124" name="Shape 116"/>
-          <p:cNvSpPr/>
-          <p:nvPr/>
-        </p:nvSpPr>
-        <p:spPr>
-          <a:xfrm>
-            <a:off x="10877523" y="5676886"/>
+          <p:cNvPr id="115" name="Shape 107"/>
+          <p:cNvSpPr/>
+          <p:nvPr/>
+        </p:nvSpPr>
+        <p:spPr>
+          <a:xfrm>
+            <a:off x="10877523" y="5124437"/>
             <a:ext cx="720088" cy="209549"/>
           </a:xfrm>
           <a:prstGeom prst="roundRect">
@@ -5758,7 +5412,7 @@
       </p:sp>
       <p:pic>
         <p:nvPicPr>
-          <p:cNvPr id="125" name="Image 6" descr="/home/user/mplanit/ai-solution/assets/png/icon-naver.png">    </p:cNvPr>
+          <p:cNvPr id="116" name="Image 6" descr="/home/user/mplanit/ai-solution/assets/png/icon-naver.png">    </p:cNvPr>
           <p:cNvPicPr>
             <a:picLocks noChangeAspect="1"/>
           </p:cNvPicPr>
@@ -5772,7 +5426,7 @@
         </p:blipFill>
         <p:spPr>
           <a:xfrm>
-            <a:off x="10944198" y="5729273"/>
+            <a:off x="10944198" y="5176825"/>
             <a:ext cx="104775" cy="104775"/>
           </a:xfrm>
           <a:prstGeom prst="rect">
@@ -5782,13 +5436,13 @@
       </p:pic>
       <p:sp>
         <p:nvSpPr>
-          <p:cNvPr id="126" name="Text 117"/>
-          <p:cNvSpPr txBox="1"/>
-          <p:nvPr/>
-        </p:nvSpPr>
-        <p:spPr>
-          <a:xfrm>
-            <a:off x="11077547" y="5676886"/>
+          <p:cNvPr id="117" name="Text 108"/>
+          <p:cNvSpPr txBox="1"/>
+          <p:nvPr/>
+        </p:nvSpPr>
+        <p:spPr>
+          <a:xfrm>
+            <a:off x="11077547" y="5124437"/>
             <a:ext cx="472439" cy="209549"/>
           </a:xfrm>
           <a:prstGeom prst="rect">
@@ -5821,13 +5475,13 @@
       </p:sp>
       <p:sp>
         <p:nvSpPr>
-          <p:cNvPr id="127" name="Shape 118"/>
-          <p:cNvSpPr/>
-          <p:nvPr/>
-        </p:nvSpPr>
-        <p:spPr>
-          <a:xfrm>
-            <a:off x="533399" y="5943585"/>
+          <p:cNvPr id="118" name="Shape 109"/>
+          <p:cNvSpPr/>
+          <p:nvPr/>
+        </p:nvSpPr>
+        <p:spPr>
+          <a:xfrm>
+            <a:off x="533399" y="5391137"/>
             <a:ext cx="373379" cy="209549"/>
           </a:xfrm>
           <a:prstGeom prst="roundRect">
@@ -5848,13 +5502,13 @@
       </p:sp>
       <p:sp>
         <p:nvSpPr>
-          <p:cNvPr id="128" name="Shape 119"/>
-          <p:cNvSpPr/>
-          <p:nvPr/>
-        </p:nvSpPr>
-        <p:spPr>
-          <a:xfrm>
-            <a:off x="609598" y="6019785"/>
+          <p:cNvPr id="119" name="Shape 110"/>
+          <p:cNvSpPr/>
+          <p:nvPr/>
+        </p:nvSpPr>
+        <p:spPr>
+          <a:xfrm>
+            <a:off x="609598" y="5467336"/>
             <a:ext cx="57150" cy="57150"/>
           </a:xfrm>
           <a:prstGeom prst="ellipse">
@@ -5873,13 +5527,13 @@
       </p:sp>
       <p:sp>
         <p:nvSpPr>
-          <p:cNvPr id="129" name="Text 120"/>
-          <p:cNvSpPr txBox="1"/>
-          <p:nvPr/>
-        </p:nvSpPr>
-        <p:spPr>
-          <a:xfrm>
-            <a:off x="704848" y="5943585"/>
+          <p:cNvPr id="120" name="Text 111"/>
+          <p:cNvSpPr txBox="1"/>
+          <p:nvPr/>
+        </p:nvSpPr>
+        <p:spPr>
+          <a:xfrm>
+            <a:off x="704848" y="5391137"/>
             <a:ext cx="144780" cy="209549"/>
           </a:xfrm>
           <a:prstGeom prst="rect">
@@ -5912,13 +5566,13 @@
       </p:sp>
       <p:sp>
         <p:nvSpPr>
-          <p:cNvPr id="130" name="Shape 121"/>
-          <p:cNvSpPr/>
-          <p:nvPr/>
-        </p:nvSpPr>
-        <p:spPr>
-          <a:xfrm>
-            <a:off x="963928" y="5943585"/>
+          <p:cNvPr id="121" name="Shape 112"/>
+          <p:cNvSpPr/>
+          <p:nvPr/>
+        </p:nvSpPr>
+        <p:spPr>
+          <a:xfrm>
+            <a:off x="963928" y="5391137"/>
             <a:ext cx="518159" cy="209549"/>
           </a:xfrm>
           <a:prstGeom prst="roundRect">
@@ -5939,13 +5593,13 @@
       </p:sp>
       <p:sp>
         <p:nvSpPr>
-          <p:cNvPr id="131" name="Shape 122"/>
-          <p:cNvSpPr/>
-          <p:nvPr/>
-        </p:nvSpPr>
-        <p:spPr>
-          <a:xfrm>
-            <a:off x="1040127" y="6019785"/>
+          <p:cNvPr id="122" name="Shape 113"/>
+          <p:cNvSpPr/>
+          <p:nvPr/>
+        </p:nvSpPr>
+        <p:spPr>
+          <a:xfrm>
+            <a:off x="1040127" y="5467336"/>
             <a:ext cx="57150" cy="57150"/>
           </a:xfrm>
           <a:prstGeom prst="ellipse">
@@ -5964,13 +5618,13 @@
       </p:sp>
       <p:sp>
         <p:nvSpPr>
-          <p:cNvPr id="132" name="Text 123"/>
-          <p:cNvSpPr txBox="1"/>
-          <p:nvPr/>
-        </p:nvSpPr>
-        <p:spPr>
-          <a:xfrm>
-            <a:off x="1135377" y="5943585"/>
+          <p:cNvPr id="123" name="Text 114"/>
+          <p:cNvSpPr txBox="1"/>
+          <p:nvPr/>
+        </p:nvSpPr>
+        <p:spPr>
+          <a:xfrm>
+            <a:off x="1135377" y="5391137"/>
             <a:ext cx="289559" cy="209549"/>
           </a:xfrm>
           <a:prstGeom prst="rect">
@@ -6003,13 +5657,13 @@
       </p:sp>
       <p:sp>
         <p:nvSpPr>
-          <p:cNvPr id="133" name="Shape 124"/>
-          <p:cNvSpPr/>
-          <p:nvPr/>
-        </p:nvSpPr>
-        <p:spPr>
-          <a:xfrm>
-            <a:off x="1539236" y="5943585"/>
+          <p:cNvPr id="124" name="Shape 115"/>
+          <p:cNvSpPr/>
+          <p:nvPr/>
+        </p:nvSpPr>
+        <p:spPr>
+          <a:xfrm>
+            <a:off x="1539236" y="5391137"/>
             <a:ext cx="518159" cy="209549"/>
           </a:xfrm>
           <a:prstGeom prst="roundRect">
@@ -6030,13 +5684,13 @@
       </p:sp>
       <p:sp>
         <p:nvSpPr>
-          <p:cNvPr id="134" name="Shape 125"/>
-          <p:cNvSpPr/>
-          <p:nvPr/>
-        </p:nvSpPr>
-        <p:spPr>
-          <a:xfrm>
-            <a:off x="1615436" y="6019785"/>
+          <p:cNvPr id="125" name="Shape 116"/>
+          <p:cNvSpPr/>
+          <p:nvPr/>
+        </p:nvSpPr>
+        <p:spPr>
+          <a:xfrm>
+            <a:off x="1615436" y="5467336"/>
             <a:ext cx="57150" cy="57150"/>
           </a:xfrm>
           <a:prstGeom prst="ellipse">
@@ -6055,13 +5709,13 @@
       </p:sp>
       <p:sp>
         <p:nvSpPr>
-          <p:cNvPr id="135" name="Text 126"/>
-          <p:cNvSpPr txBox="1"/>
-          <p:nvPr/>
-        </p:nvSpPr>
-        <p:spPr>
-          <a:xfrm>
-            <a:off x="1710686" y="5943585"/>
+          <p:cNvPr id="126" name="Text 117"/>
+          <p:cNvSpPr txBox="1"/>
+          <p:nvPr/>
+        </p:nvSpPr>
+        <p:spPr>
+          <a:xfrm>
+            <a:off x="1710686" y="5391137"/>
             <a:ext cx="289559" cy="209549"/>
           </a:xfrm>
           <a:prstGeom prst="rect">
@@ -6094,13 +5748,13 @@
       </p:sp>
       <p:sp>
         <p:nvSpPr>
-          <p:cNvPr id="136" name="Shape 127"/>
-          <p:cNvSpPr/>
-          <p:nvPr/>
-        </p:nvSpPr>
-        <p:spPr>
-          <a:xfrm>
-            <a:off x="2114545" y="5943585"/>
+          <p:cNvPr id="127" name="Shape 118"/>
+          <p:cNvSpPr/>
+          <p:nvPr/>
+        </p:nvSpPr>
+        <p:spPr>
+          <a:xfrm>
+            <a:off x="2114545" y="5391137"/>
             <a:ext cx="518159" cy="209549"/>
           </a:xfrm>
           <a:prstGeom prst="roundRect">
@@ -6121,13 +5775,13 @@
       </p:sp>
       <p:sp>
         <p:nvSpPr>
-          <p:cNvPr id="137" name="Shape 128"/>
-          <p:cNvSpPr/>
-          <p:nvPr/>
-        </p:nvSpPr>
-        <p:spPr>
-          <a:xfrm>
-            <a:off x="2190745" y="6019785"/>
+          <p:cNvPr id="128" name="Shape 119"/>
+          <p:cNvSpPr/>
+          <p:nvPr/>
+        </p:nvSpPr>
+        <p:spPr>
+          <a:xfrm>
+            <a:off x="2190745" y="5467336"/>
             <a:ext cx="57150" cy="57150"/>
           </a:xfrm>
           <a:prstGeom prst="ellipse">
@@ -6146,13 +5800,13 @@
       </p:sp>
       <p:sp>
         <p:nvSpPr>
-          <p:cNvPr id="138" name="Text 129"/>
-          <p:cNvSpPr txBox="1"/>
-          <p:nvPr/>
-        </p:nvSpPr>
-        <p:spPr>
-          <a:xfrm>
-            <a:off x="2285994" y="5943585"/>
+          <p:cNvPr id="129" name="Text 120"/>
+          <p:cNvSpPr txBox="1"/>
+          <p:nvPr/>
+        </p:nvSpPr>
+        <p:spPr>
+          <a:xfrm>
+            <a:off x="2285994" y="5391137"/>
             <a:ext cx="289559" cy="209549"/>
           </a:xfrm>
           <a:prstGeom prst="rect">
@@ -6185,13 +5839,13 @@
       </p:sp>
       <p:sp>
         <p:nvSpPr>
-          <p:cNvPr id="139" name="Shape 130"/>
-          <p:cNvSpPr/>
-          <p:nvPr/>
-        </p:nvSpPr>
-        <p:spPr>
-          <a:xfrm>
-            <a:off x="2689853" y="5943585"/>
+          <p:cNvPr id="130" name="Shape 121"/>
+          <p:cNvSpPr/>
+          <p:nvPr/>
+        </p:nvSpPr>
+        <p:spPr>
+          <a:xfrm>
+            <a:off x="2689853" y="5391137"/>
             <a:ext cx="662938" cy="209549"/>
           </a:xfrm>
           <a:prstGeom prst="roundRect">
@@ -6212,13 +5866,13 @@
       </p:sp>
       <p:sp>
         <p:nvSpPr>
-          <p:cNvPr id="140" name="Shape 131"/>
-          <p:cNvSpPr/>
-          <p:nvPr/>
-        </p:nvSpPr>
-        <p:spPr>
-          <a:xfrm>
-            <a:off x="2766053" y="6019785"/>
+          <p:cNvPr id="131" name="Shape 122"/>
+          <p:cNvSpPr/>
+          <p:nvPr/>
+        </p:nvSpPr>
+        <p:spPr>
+          <a:xfrm>
+            <a:off x="2766053" y="5467336"/>
             <a:ext cx="57150" cy="57150"/>
           </a:xfrm>
           <a:prstGeom prst="ellipse">
@@ -6237,13 +5891,13 @@
       </p:sp>
       <p:sp>
         <p:nvSpPr>
-          <p:cNvPr id="141" name="Text 132"/>
-          <p:cNvSpPr txBox="1"/>
-          <p:nvPr/>
-        </p:nvSpPr>
-        <p:spPr>
-          <a:xfrm>
-            <a:off x="2861303" y="5943585"/>
+          <p:cNvPr id="132" name="Text 123"/>
+          <p:cNvSpPr txBox="1"/>
+          <p:nvPr/>
+        </p:nvSpPr>
+        <p:spPr>
+          <a:xfrm>
+            <a:off x="2861303" y="5391137"/>
             <a:ext cx="434339" cy="209549"/>
           </a:xfrm>
           <a:prstGeom prst="rect">
@@ -6276,13 +5930,13 @@
       </p:sp>
       <p:sp>
         <p:nvSpPr>
-          <p:cNvPr id="142" name="Shape 133"/>
-          <p:cNvSpPr/>
-          <p:nvPr/>
-        </p:nvSpPr>
-        <p:spPr>
-          <a:xfrm>
-            <a:off x="3409941" y="5943585"/>
+          <p:cNvPr id="133" name="Shape 124"/>
+          <p:cNvSpPr/>
+          <p:nvPr/>
+        </p:nvSpPr>
+        <p:spPr>
+          <a:xfrm>
+            <a:off x="3409941" y="5391137"/>
             <a:ext cx="1097277" cy="209549"/>
           </a:xfrm>
           <a:prstGeom prst="roundRect">
@@ -6303,13 +5957,13 @@
       </p:sp>
       <p:sp>
         <p:nvSpPr>
-          <p:cNvPr id="143" name="Shape 134"/>
-          <p:cNvSpPr/>
-          <p:nvPr/>
-        </p:nvSpPr>
-        <p:spPr>
-          <a:xfrm>
-            <a:off x="3486141" y="6019785"/>
+          <p:cNvPr id="134" name="Shape 125"/>
+          <p:cNvSpPr/>
+          <p:nvPr/>
+        </p:nvSpPr>
+        <p:spPr>
+          <a:xfrm>
+            <a:off x="3486141" y="5467336"/>
             <a:ext cx="57150" cy="57150"/>
           </a:xfrm>
           <a:prstGeom prst="ellipse">
@@ -6328,13 +5982,13 @@
       </p:sp>
       <p:sp>
         <p:nvSpPr>
-          <p:cNvPr id="144" name="Text 135"/>
-          <p:cNvSpPr txBox="1"/>
-          <p:nvPr/>
-        </p:nvSpPr>
-        <p:spPr>
-          <a:xfrm>
-            <a:off x="3581391" y="5943585"/>
+          <p:cNvPr id="135" name="Text 126"/>
+          <p:cNvSpPr txBox="1"/>
+          <p:nvPr/>
+        </p:nvSpPr>
+        <p:spPr>
+          <a:xfrm>
+            <a:off x="3581391" y="5391137"/>
             <a:ext cx="868678" cy="209549"/>
           </a:xfrm>
           <a:prstGeom prst="rect">
@@ -6367,30 +6021,30 @@
       </p:sp>
       <p:sp>
         <p:nvSpPr>
-          <p:cNvPr id="145" name="Text 136"/>
-          <p:cNvSpPr txBox="1"/>
-          <p:nvPr/>
-        </p:nvSpPr>
-        <p:spPr>
-          <a:xfrm>
-            <a:off x="533399" y="6134085"/>
-            <a:ext cx="11125172" cy="133350"/>
-          </a:xfrm>
-          <a:prstGeom prst="rect">
-            <a:avLst/>
-          </a:prstGeom>
-          <a:noFill/>
-          <a:ln/>
-        </p:spPr>
-        <p:txBody>
-          <a:bodyPr wrap="square" lIns="0" tIns="0" rIns="0" bIns="0" rtlCol="0" anchor="ctr"/>
-          <a:lstStyle/>
-          <a:p>
-            <a:pPr indent="0" marL="0">
-              <a:buNone/>
-            </a:pPr>
-            <a:r>
-              <a:rPr lang="en-US" sz="650" dirty="0">
+          <p:cNvPr id="136" name="Text 127"/>
+          <p:cNvSpPr txBox="1"/>
+          <p:nvPr/>
+        </p:nvSpPr>
+        <p:spPr>
+          <a:xfrm>
+            <a:off x="533399" y="5772136"/>
+            <a:ext cx="11125172" cy="152400"/>
+          </a:xfrm>
+          <a:prstGeom prst="rect">
+            <a:avLst/>
+          </a:prstGeom>
+          <a:noFill/>
+          <a:ln/>
+        </p:spPr>
+        <p:txBody>
+          <a:bodyPr wrap="square" lIns="0" tIns="0" rIns="0" bIns="0" rtlCol="0" anchor="ctr"/>
+          <a:lstStyle/>
+          <a:p>
+            <a:pPr indent="0" marL="0">
+              <a:buNone/>
+            </a:pPr>
+            <a:r>
+              <a:rPr lang="en-US" sz="750" dirty="0">
                 <a:solidFill>
                   <a:srgbClr val="64748B"/>
                 </a:solidFill>
@@ -6404,7 +6058,7 @@
               <a:buNone/>
             </a:pPr>
             <a:r>
-              <a:rPr lang="en-US" sz="650" dirty="0">
+              <a:rPr lang="en-US" sz="750" dirty="0">
                 <a:solidFill>
                   <a:srgbClr val="94A3B8"/>
                 </a:solidFill>
@@ -6412,13 +6066,13 @@
                 <a:ea typeface="페이퍼로지 4 Regular" pitchFamily="34" charset="-122"/>
                 <a:cs typeface="페이퍼로지 4 Regular" pitchFamily="34" charset="-120"/>
               </a:rPr>
-              <a:t>삼성전자 DS · AIA생명 · 쿠쿠전자   |   </a:t>
-            </a:r>
-            <a:pPr indent="0" marL="0">
-              <a:buNone/>
-            </a:pPr>
-            <a:r>
-              <a:rPr lang="en-US" sz="650" dirty="0">
+              <a:t>삼성전자 DS · AIA생명 · 쿠쿠전자    </a:t>
+            </a:r>
+            <a:pPr indent="0" marL="0">
+              <a:buNone/>
+            </a:pPr>
+            <a:r>
+              <a:rPr lang="en-US" sz="750" dirty="0">
                 <a:solidFill>
                   <a:srgbClr val="64748B"/>
                 </a:solidFill>
@@ -6432,7 +6086,7 @@
               <a:buNone/>
             </a:pPr>
             <a:r>
-              <a:rPr lang="en-US" sz="650" dirty="0">
+              <a:rPr lang="en-US" sz="750" dirty="0">
                 <a:solidFill>
                   <a:srgbClr val="94A3B8"/>
                 </a:solidFill>
@@ -6440,38 +6094,61 @@
                 <a:ea typeface="페이퍼로지 4 Regular" pitchFamily="34" charset="-122"/>
                 <a:cs typeface="페이퍼로지 4 Regular" pitchFamily="34" charset="-120"/>
               </a:rPr>
-              <a:t>네이버 · 카카오 · 크리테오 — 공식 홈페이지 공개 기준(광고 실행 경험이며 AI 솔루션 도입 실적과 별개)</a:t>
-            </a:r>
-            <a:endParaRPr lang="en-US" sz="650" dirty="0"/>
-          </a:p>
-        </p:txBody>
-      </p:sp>
-      <p:sp>
-        <p:nvSpPr>
-          <p:cNvPr id="146" name="Text 137"/>
-          <p:cNvSpPr txBox="1"/>
-          <p:nvPr/>
-        </p:nvSpPr>
-        <p:spPr>
-          <a:xfrm>
-            <a:off x="533399" y="6267434"/>
-            <a:ext cx="11125172" cy="133350"/>
-          </a:xfrm>
-          <a:prstGeom prst="rect">
-            <a:avLst/>
-          </a:prstGeom>
-          <a:noFill/>
-          <a:ln/>
-        </p:spPr>
-        <p:txBody>
-          <a:bodyPr wrap="square" lIns="0" tIns="0" rIns="0" bIns="0" rtlCol="0" anchor="ctr"/>
-          <a:lstStyle/>
-          <a:p>
-            <a:pPr indent="0" marL="0">
-              <a:buNone/>
-            </a:pPr>
-            <a:r>
-              <a:rPr lang="en-US" sz="650" dirty="0">
+              <a:t>네이버 · 카카오 · 크리테오 — 공식 홈페이지 공개 기준</a:t>
+            </a:r>
+            <a:endParaRPr lang="en-US" sz="750" dirty="0"/>
+          </a:p>
+        </p:txBody>
+      </p:sp>
+      <p:sp>
+        <p:nvSpPr>
+          <p:cNvPr id="137" name="Shape 128"/>
+          <p:cNvSpPr/>
+          <p:nvPr/>
+        </p:nvSpPr>
+        <p:spPr>
+          <a:xfrm>
+            <a:off x="533399" y="6400784"/>
+            <a:ext cx="11125172" cy="0"/>
+          </a:xfrm>
+          <a:prstGeom prst="line">
+            <a:avLst/>
+          </a:prstGeom>
+          <a:noFill/>
+          <a:ln w="9525">
+            <a:solidFill>
+              <a:srgbClr val="E3EAF4"/>
+            </a:solidFill>
+            <a:prstDash val="solid"/>
+          </a:ln>
+        </p:spPr>
+      </p:sp>
+      <p:sp>
+        <p:nvSpPr>
+          <p:cNvPr id="138" name="Text 129"/>
+          <p:cNvSpPr txBox="1"/>
+          <p:nvPr/>
+        </p:nvSpPr>
+        <p:spPr>
+          <a:xfrm>
+            <a:off x="533399" y="6457934"/>
+            <a:ext cx="7619981" cy="190500"/>
+          </a:xfrm>
+          <a:prstGeom prst="rect">
+            <a:avLst/>
+          </a:prstGeom>
+          <a:noFill/>
+          <a:ln/>
+        </p:spPr>
+        <p:txBody>
+          <a:bodyPr wrap="square" lIns="0" tIns="0" rIns="0" bIns="0" rtlCol="0" anchor="ctr"/>
+          <a:lstStyle/>
+          <a:p>
+            <a:pPr indent="0" marL="0">
+              <a:buNone/>
+            </a:pPr>
+            <a:r>
+              <a:rPr lang="en-US" sz="800" dirty="0">
                 <a:solidFill>
                   <a:srgbClr val="94A3B8"/>
                 </a:solidFill>
@@ -6479,68 +6156,6 @@
                 <a:ea typeface="페이퍼로지 4 Regular" pitchFamily="34" charset="-122"/>
                 <a:cs typeface="페이퍼로지 4 Regular" pitchFamily="34" charset="-120"/>
               </a:rPr>
-              <a:t>출처 · OpenAI(2026.07), Similarweb AI Search Stats 2026, 국내 광고업계 AI 제작 비중 전망 보도(2025.10) · 매체/채널 표기는 연동 현황 안내용</a:t>
-            </a:r>
-            <a:endParaRPr lang="en-US" sz="650" dirty="0"/>
-          </a:p>
-        </p:txBody>
-      </p:sp>
-      <p:sp>
-        <p:nvSpPr>
-          <p:cNvPr id="147" name="Shape 138"/>
-          <p:cNvSpPr/>
-          <p:nvPr/>
-        </p:nvSpPr>
-        <p:spPr>
-          <a:xfrm>
-            <a:off x="533399" y="6400784"/>
-            <a:ext cx="11125172" cy="0"/>
-          </a:xfrm>
-          <a:prstGeom prst="line">
-            <a:avLst/>
-          </a:prstGeom>
-          <a:noFill/>
-          <a:ln w="9525">
-            <a:solidFill>
-              <a:srgbClr val="E3EAF4"/>
-            </a:solidFill>
-            <a:prstDash val="solid"/>
-          </a:ln>
-        </p:spPr>
-      </p:sp>
-      <p:sp>
-        <p:nvSpPr>
-          <p:cNvPr id="148" name="Text 139"/>
-          <p:cNvSpPr txBox="1"/>
-          <p:nvPr/>
-        </p:nvSpPr>
-        <p:spPr>
-          <a:xfrm>
-            <a:off x="533399" y="6457934"/>
-            <a:ext cx="7619981" cy="190500"/>
-          </a:xfrm>
-          <a:prstGeom prst="rect">
-            <a:avLst/>
-          </a:prstGeom>
-          <a:noFill/>
-          <a:ln/>
-        </p:spPr>
-        <p:txBody>
-          <a:bodyPr wrap="square" lIns="0" tIns="0" rIns="0" bIns="0" rtlCol="0" anchor="ctr"/>
-          <a:lstStyle/>
-          <a:p>
-            <a:pPr indent="0" marL="0">
-              <a:buNone/>
-            </a:pPr>
-            <a:r>
-              <a:rPr lang="en-US" sz="800" dirty="0">
-                <a:solidFill>
-                  <a:srgbClr val="94A3B8"/>
-                </a:solidFill>
-                <a:latin typeface="페이퍼로지 4 Regular" pitchFamily="34" charset="0"/>
-                <a:ea typeface="페이퍼로지 4 Regular" pitchFamily="34" charset="-122"/>
-                <a:cs typeface="페이퍼로지 4 Regular" pitchFamily="34" charset="-120"/>
-              </a:rPr>
               <a:t>엠플랜잇 AIU본부 · M Ai Platform · AI LAB · mplanit.co.kr</a:t>
             </a:r>
             <a:endParaRPr lang="en-US" sz="800" dirty="0"/>
@@ -6549,7 +6164,7 @@
       </p:sp>
       <p:sp>
         <p:nvSpPr>
-          <p:cNvPr id="149" name="Text 140"/>
+          <p:cNvPr id="139" name="Text 130"/>
           <p:cNvSpPr txBox="1"/>
           <p:nvPr/>
         </p:nvSpPr>
@@ -13217,7 +12832,7 @@
                 <a:ea typeface="페이퍼로지 4 Regular" pitchFamily="34" charset="-122"/>
                 <a:cs typeface="페이퍼로지 4 Regular" pitchFamily="34" charset="-120"/>
               </a:rPr>
-              <a:t>기본정보 · 이미지 업로드 · 스타일 · 텍스트&amp;폰트 · 출력 옵션 · 생성 모델. 로고 노출 위치 9분할 지정.</a:t>
+              <a:t>기본정보 · 이미지 · 스타일 · 텍스트 · 출력 · 모델</a:t>
             </a:r>
             <a:endParaRPr lang="en-US" sz="900" dirty="0"/>
           </a:p>
@@ -13364,7 +12979,7 @@
                 <a:ea typeface="페이퍼로지 4 Regular" pitchFamily="34" charset="-122"/>
                 <a:cs typeface="페이퍼로지 4 Regular" pitchFamily="34" charset="-120"/>
               </a:rPr>
-              <a:t>라이트 — 양식 입력형 / 에디터 — 대화 지시형. 한 줄 요청으로도 시안 생성.</a:t>
+              <a:t>라이트 양식 입력 / 에디터 대화 지시</a:t>
             </a:r>
             <a:endParaRPr lang="en-US" sz="900" dirty="0"/>
           </a:p>
@@ -13511,7 +13126,7 @@
                 <a:ea typeface="페이퍼로지 4 Regular" pitchFamily="34" charset="-122"/>
                 <a:cs typeface="페이퍼로지 4 Regular" pitchFamily="34" charset="-120"/>
               </a:rPr>
-              <a:t>1:1 · 4:3 · 16:9 · 9:16 기본 비율 + 매체 규격 23종 이상. 레이어 분리 후 브라우저 수정.</a:t>
+              <a:t>기본 4비율 + 매체 규격 23종 · 레이어 분리 수정</a:t>
             </a:r>
             <a:endParaRPr lang="en-US" sz="900" dirty="0"/>
           </a:p>
@@ -13658,7 +13273,7 @@
                 <a:ea typeface="페이퍼로지 4 Regular" pitchFamily="34" charset="-122"/>
                 <a:cs typeface="페이퍼로지 4 Regular" pitchFamily="34" charset="-120"/>
               </a:rPr>
-              <a:t>이미지 Gemini(나노 바나나) · ChatGPT 2.0. 완성 시안은 영상 생성 탭으로 연결.</a:t>
+              <a:t>Gemini(나노 바나나) · ChatGPT 2.0 → 영상 생성 연결</a:t>
             </a:r>
             <a:endParaRPr lang="en-US" sz="900" dirty="0"/>
           </a:p>
@@ -14995,7 +14610,7 @@
                 <a:ea typeface="페이퍼로지 4 Regular" pitchFamily="34" charset="-122"/>
                 <a:cs typeface="페이퍼로지 4 Regular" pitchFamily="34" charset="-120"/>
               </a:rPr>
-              <a:t>상황 한 문장 입력 → AI가 질문 자동 완성 → 초안 스토리보드 제시.</a:t>
+              <a:t>문장 하나 → AI가 질문 완성 → 초안 스토리보드</a:t>
             </a:r>
             <a:endParaRPr lang="en-US" sz="900" dirty="0"/>
           </a:p>
@@ -15142,7 +14757,7 @@
                 <a:ea typeface="페이퍼로지 4 Regular" pitchFamily="34" charset="-122"/>
                 <a:cs typeface="페이퍼로지 4 Regular" pitchFamily="34" charset="-120"/>
               </a:rPr>
-              <a:t>아이디어 · 의도 · 표현 · 스토리보드 · 완료. 길이 2컷 / 4컷 / 7컷 선택.</a:t>
+              <a:t>아이디어 → 의도 → 표현 → 스토리보드 → 완료 · 2/4/7컷</a:t>
             </a:r>
             <a:endParaRPr lang="en-US" sz="900" dirty="0"/>
           </a:p>
@@ -15289,7 +14904,7 @@
                 <a:ea typeface="페이퍼로지 4 Regular" pitchFamily="34" charset="-122"/>
                 <a:cs typeface="페이퍼로지 4 Regular" pitchFamily="34" charset="-120"/>
               </a:rPr>
-              <a:t>영상 종류(실사 · 3D · 현실+3D · 웹툰) · 화면 스타일 · 분위기 · 주인공/조연.</a:t>
+              <a:t>영상 종류 · 화면 스타일 · 분위기 · 등장인물 선택</a:t>
             </a:r>
             <a:endParaRPr lang="en-US" sz="900" dirty="0"/>
           </a:p>
@@ -15436,7 +15051,7 @@
                 <a:ea typeface="페이퍼로지 4 Regular" pitchFamily="34" charset="-122"/>
                 <a:cs typeface="페이퍼로지 4 Regular" pitchFamily="34" charset="-120"/>
               </a:rPr>
-              <a:t>컷별 승인 · 재생성 후 VEO 3.1(1080p) 또는 Gemini Omni(720p)로 출력.</a:t>
+              <a:t>컷별 승인·재생성 → VEO 3.1 / Gemini Omni 렌더</a:t>
             </a:r>
             <a:endParaRPr lang="en-US" sz="900" dirty="0"/>
           </a:p>
@@ -16773,7 +16388,7 @@
                 <a:ea typeface="페이퍼로지 4 Regular" pitchFamily="34" charset="-122"/>
                 <a:cs typeface="페이퍼로지 4 Regular" pitchFamily="34" charset="-120"/>
               </a:rPr>
-              <a:t>종합 · SEO · GEO 동시 산출. 자사 사이트 기준 84 / 95 / 72.</a:t>
+              <a:t>종합 · SEO · GEO 동시 산출 — 자사 84 / 95 / 72</a:t>
             </a:r>
             <a:endParaRPr lang="en-US" sz="900" dirty="0"/>
           </a:p>
@@ -16920,7 +16535,7 @@
                 <a:ea typeface="페이퍼로지 4 Regular" pitchFamily="34" charset="-122"/>
                 <a:cs typeface="페이퍼로지 4 Regular" pitchFamily="34" charset="-120"/>
               </a:rPr>
-              <a:t>80점 이상 인용 가능 · 70점대 기본 충족 · 60점 이하 구조 개선 필요.</a:t>
+              <a:t>80↑ 인용 가능 · 70점대 기본 · 60↓ 개선 필요</a:t>
             </a:r>
             <a:endParaRPr lang="en-US" sz="900" dirty="0"/>
           </a:p>
@@ -17067,7 +16682,7 @@
                 <a:ea typeface="페이퍼로지 4 Regular" pitchFamily="34" charset="-122"/>
                 <a:cs typeface="페이퍼로지 4 Regular" pitchFamily="34" charset="-120"/>
               </a:rPr>
-              <a:t>ChatGPT · Gemini · Perplexity · 네이버 AI 브리핑(Yeti · 서치어드바이저).</a:t>
+              <a:t>ChatGPT · Gemini · Perplexity · 네이버 AI 브리핑</a:t>
             </a:r>
             <a:endParaRPr lang="en-US" sz="900" dirty="0"/>
           </a:p>
@@ -17214,7 +16829,7 @@
                 <a:ea typeface="페이퍼로지 4 Regular" pitchFamily="34" charset="-122"/>
                 <a:cs typeface="페이퍼로지 4 Regular" pitchFamily="34" charset="-120"/>
               </a:rPr>
-              <a:t>인용 신뢰도(E-E-A-T 70점 이상) · 통계 포함 · 스키마 · 엔티티 연결성.</a:t>
+              <a:t>인용 신뢰도 · 통계 포함 · 스키마 · 엔티티 연결성</a:t>
             </a:r>
             <a:endParaRPr lang="en-US" sz="900" dirty="0"/>
           </a:p>
@@ -21185,8 +20800,8 @@
         </p:nvSpPr>
         <p:spPr>
           <a:xfrm>
-            <a:off x="533399" y="5333987"/>
-            <a:ext cx="3581391" cy="285749"/>
+            <a:off x="533399" y="5295887"/>
+            <a:ext cx="3581391" cy="323849"/>
           </a:xfrm>
           <a:prstGeom prst="rect">
             <a:avLst/>
@@ -21213,27 +20828,7 @@
                 <a:ea typeface="페이퍼로지 4 Regular" pitchFamily="34" charset="-122"/>
                 <a:cs typeface="페이퍼로지 4 Regular" pitchFamily="34" charset="-120"/>
               </a:rPr>
-              <a:t>화면 — 운영 중 애드리포트 실제 캡처(수치는 캡처 시점 기준, 광고주명·금액 마스킹).</a:t>
-            </a:r>
-            <a:endParaRPr lang="en-US" sz="650" dirty="0"/>
-          </a:p>
-          <a:p>
-            <a:pPr indent="0" marL="0">
-              <a:lnSpc>
-                <a:spcPct val="125000"/>
-              </a:lnSpc>
-              <a:buNone/>
-            </a:pPr>
-            <a:r>
-              <a:rPr lang="en-US" sz="650" dirty="0">
-                <a:solidFill>
-                  <a:srgbClr val="94A3B8"/>
-                </a:solidFill>
-                <a:latin typeface="페이퍼로지 4 Regular" pitchFamily="34" charset="0"/>
-                <a:ea typeface="페이퍼로지 4 Regular" pitchFamily="34" charset="-122"/>
-                <a:cs typeface="페이퍼로지 4 Regular" pitchFamily="34" charset="-120"/>
-              </a:rPr>
-              <a:t>채널·매체별 연동 범위와 집계 주기가 다르며, 판매 매출과 광고 기여 성과는 구분합니다.</a:t>
+              <a:t>화면 — 실제 캡처(캡처 시점 수치 · 광고주명·금액 마스킹) · 채널별 연동 범위와 집계 주기 상이 · 판매 매출과 광고 기여 성과 구분</a:t>
             </a:r>
             <a:endParaRPr lang="en-US" sz="650" dirty="0"/>
           </a:p>
@@ -21491,20 +21086,16 @@
         </p:nvSpPr>
         <p:spPr>
           <a:xfrm>
-            <a:off x="533399" y="5486386"/>
-            <a:ext cx="11125172" cy="590549"/>
-          </a:xfrm>
-          <a:prstGeom prst="roundRect">
-            <a:avLst>
-              <a:gd name="adj" fmla="val 7742"/>
-            </a:avLst>
-          </a:prstGeom>
-          <a:solidFill>
-            <a:srgbClr val="1B468B"/>
-          </a:solidFill>
-          <a:ln w="12700">
-            <a:solidFill>
-              <a:srgbClr val="1B468B"/>
+            <a:off x="533399" y="6400784"/>
+            <a:ext cx="11125172" cy="0"/>
+          </a:xfrm>
+          <a:prstGeom prst="line">
+            <a:avLst/>
+          </a:prstGeom>
+          <a:noFill/>
+          <a:ln w="9525">
+            <a:solidFill>
+              <a:srgbClr val="E3EAF4"/>
             </a:solidFill>
             <a:prstDash val="solid"/>
           </a:ln>
@@ -21518,198 +21109,31 @@
         </p:nvSpPr>
         <p:spPr>
           <a:xfrm>
-            <a:off x="723898" y="5581636"/>
-            <a:ext cx="6667483" cy="209549"/>
-          </a:xfrm>
-          <a:prstGeom prst="rect">
-            <a:avLst/>
-          </a:prstGeom>
-          <a:noFill/>
-          <a:ln/>
-        </p:spPr>
-        <p:txBody>
-          <a:bodyPr wrap="square" lIns="0" tIns="0" rIns="0" bIns="0" rtlCol="0" anchor="ctr"/>
-          <a:lstStyle/>
-          <a:p>
-            <a:pPr indent="0" marL="0">
-              <a:buNone/>
-            </a:pPr>
-            <a:r>
-              <a:rPr lang="en-US" sz="1200" dirty="0">
-                <a:solidFill>
-                  <a:srgbClr val="FFFFFF"/>
-                </a:solidFill>
-                <a:latin typeface="페이퍼로지 8 ExtraBold" pitchFamily="34" charset="0"/>
-                <a:ea typeface="페이퍼로지 8 ExtraBold" pitchFamily="34" charset="-122"/>
-                <a:cs typeface="페이퍼로지 8 ExtraBold" pitchFamily="34" charset="-120"/>
-              </a:rPr>
-              <a:t>도입 3단계 — 진단 → 연동 세팅 → 운영</a:t>
-            </a:r>
-            <a:endParaRPr lang="en-US" sz="1200" dirty="0"/>
-          </a:p>
-        </p:txBody>
-      </p:sp>
-      <p:sp>
-        <p:nvSpPr>
-          <p:cNvPr id="108" name="Text 98"/>
-          <p:cNvSpPr txBox="1"/>
-          <p:nvPr/>
-        </p:nvSpPr>
-        <p:spPr>
-          <a:xfrm>
-            <a:off x="723898" y="5791186"/>
-            <a:ext cx="6667483" cy="190500"/>
-          </a:xfrm>
-          <a:prstGeom prst="rect">
-            <a:avLst/>
-          </a:prstGeom>
-          <a:noFill/>
-          <a:ln/>
-        </p:spPr>
-        <p:txBody>
-          <a:bodyPr wrap="square" lIns="0" tIns="0" rIns="0" bIns="0" rtlCol="0" anchor="ctr"/>
-          <a:lstStyle/>
-          <a:p>
-            <a:pPr indent="0" marL="0">
-              <a:buNone/>
-            </a:pPr>
-            <a:r>
-              <a:rPr lang="en-US" sz="900" dirty="0">
-                <a:solidFill>
-                  <a:srgbClr val="D6E6F7"/>
+            <a:off x="533399" y="6457934"/>
+            <a:ext cx="7619981" cy="190500"/>
+          </a:xfrm>
+          <a:prstGeom prst="rect">
+            <a:avLst/>
+          </a:prstGeom>
+          <a:noFill/>
+          <a:ln/>
+        </p:spPr>
+        <p:txBody>
+          <a:bodyPr wrap="square" lIns="0" tIns="0" rIns="0" bIns="0" rtlCol="0" anchor="ctr"/>
+          <a:lstStyle/>
+          <a:p>
+            <a:pPr indent="0" marL="0">
+              <a:buNone/>
+            </a:pPr>
+            <a:r>
+              <a:rPr lang="en-US" sz="800" dirty="0">
+                <a:solidFill>
+                  <a:srgbClr val="94A3B8"/>
                 </a:solidFill>
                 <a:latin typeface="페이퍼로지 4 Regular" pitchFamily="34" charset="0"/>
                 <a:ea typeface="페이퍼로지 4 Regular" pitchFamily="34" charset="-122"/>
                 <a:cs typeface="페이퍼로지 4 Regular" pitchFamily="34" charset="-120"/>
               </a:rPr>
-              <a:t>광고주 성과 · 대행사 공수 · 1인 기업 인력 대체</a:t>
-            </a:r>
-            <a:endParaRPr lang="en-US" sz="900" dirty="0"/>
-          </a:p>
-        </p:txBody>
-      </p:sp>
-      <p:sp>
-        <p:nvSpPr>
-          <p:cNvPr id="109" name="Shape 99"/>
-          <p:cNvSpPr/>
-          <p:nvPr/>
-        </p:nvSpPr>
-        <p:spPr>
-          <a:xfrm>
-            <a:off x="8953478" y="5619736"/>
-            <a:ext cx="2514594" cy="323849"/>
-          </a:xfrm>
-          <a:prstGeom prst="roundRect">
-            <a:avLst>
-              <a:gd name="adj" fmla="val 28235"/>
-            </a:avLst>
-          </a:prstGeom>
-          <a:solidFill>
-            <a:srgbClr val="FFFFFF"/>
-          </a:solidFill>
-          <a:ln w="12700">
-            <a:solidFill>
-              <a:srgbClr val="FFFFFF"/>
-            </a:solidFill>
-            <a:prstDash val="solid"/>
-          </a:ln>
-        </p:spPr>
-      </p:sp>
-      <p:sp>
-        <p:nvSpPr>
-          <p:cNvPr id="110" name="Text 100"/>
-          <p:cNvSpPr txBox="1"/>
-          <p:nvPr/>
-        </p:nvSpPr>
-        <p:spPr>
-          <a:xfrm>
-            <a:off x="8953478" y="5619736"/>
-            <a:ext cx="2514594" cy="323849"/>
-          </a:xfrm>
-          <a:prstGeom prst="rect">
-            <a:avLst/>
-          </a:prstGeom>
-          <a:noFill/>
-          <a:ln/>
-        </p:spPr>
-        <p:txBody>
-          <a:bodyPr wrap="square" lIns="0" tIns="0" rIns="0" bIns="0" rtlCol="0" anchor="ctr"/>
-          <a:lstStyle/>
-          <a:p>
-            <a:pPr algn="ctr" indent="0" marL="0">
-              <a:buNone/>
-            </a:pPr>
-            <a:r>
-              <a:rPr lang="en-US" sz="900" dirty="0">
-                <a:solidFill>
-                  <a:srgbClr val="1B468B"/>
-                </a:solidFill>
-                <a:latin typeface="페이퍼로지 8 ExtraBold" pitchFamily="34" charset="0"/>
-                <a:ea typeface="페이퍼로지 8 ExtraBold" pitchFamily="34" charset="-122"/>
-                <a:cs typeface="페이퍼로지 8 ExtraBold" pitchFamily="34" charset="-120"/>
-              </a:rPr>
-              <a:t>엠플랜잇 AIU본부 · mplanit.co.kr</a:t>
-            </a:r>
-            <a:endParaRPr lang="en-US" sz="900" dirty="0"/>
-          </a:p>
-        </p:txBody>
-      </p:sp>
-      <p:sp>
-        <p:nvSpPr>
-          <p:cNvPr id="111" name="Shape 101"/>
-          <p:cNvSpPr/>
-          <p:nvPr/>
-        </p:nvSpPr>
-        <p:spPr>
-          <a:xfrm>
-            <a:off x="533399" y="6400784"/>
-            <a:ext cx="11125172" cy="0"/>
-          </a:xfrm>
-          <a:prstGeom prst="line">
-            <a:avLst/>
-          </a:prstGeom>
-          <a:noFill/>
-          <a:ln w="9525">
-            <a:solidFill>
-              <a:srgbClr val="E3EAF4"/>
-            </a:solidFill>
-            <a:prstDash val="solid"/>
-          </a:ln>
-        </p:spPr>
-      </p:sp>
-      <p:sp>
-        <p:nvSpPr>
-          <p:cNvPr id="112" name="Text 102"/>
-          <p:cNvSpPr txBox="1"/>
-          <p:nvPr/>
-        </p:nvSpPr>
-        <p:spPr>
-          <a:xfrm>
-            <a:off x="533399" y="6457934"/>
-            <a:ext cx="7619981" cy="190500"/>
-          </a:xfrm>
-          <a:prstGeom prst="rect">
-            <a:avLst/>
-          </a:prstGeom>
-          <a:noFill/>
-          <a:ln/>
-        </p:spPr>
-        <p:txBody>
-          <a:bodyPr wrap="square" lIns="0" tIns="0" rIns="0" bIns="0" rtlCol="0" anchor="ctr"/>
-          <a:lstStyle/>
-          <a:p>
-            <a:pPr indent="0" marL="0">
-              <a:buNone/>
-            </a:pPr>
-            <a:r>
-              <a:rPr lang="en-US" sz="800" dirty="0">
-                <a:solidFill>
-                  <a:srgbClr val="94A3B8"/>
-                </a:solidFill>
-                <a:latin typeface="페이퍼로지 4 Regular" pitchFamily="34" charset="0"/>
-                <a:ea typeface="페이퍼로지 4 Regular" pitchFamily="34" charset="-122"/>
-                <a:cs typeface="페이퍼로지 4 Regular" pitchFamily="34" charset="-120"/>
-              </a:rPr>
               <a:t>출처 · Similarweb AI Search Stats 2026 · OpenAI(2026.07) · 크몽 숏폼 단가 가이드 · 엠플랜잇 운영 자료(2026.09)</a:t>
             </a:r>
             <a:endParaRPr lang="en-US" sz="800" dirty="0"/>
@@ -21718,7 +21142,7 @@
       </p:sp>
       <p:sp>
         <p:nvSpPr>
-          <p:cNvPr id="113" name="Text 103"/>
+          <p:cNvPr id="108" name="Text 98"/>
           <p:cNvSpPr txBox="1"/>
           <p:nvPr/>
         </p:nvSpPr>
@@ -22188,7 +21612,7 @@
                 <a:ea typeface="페이퍼로지 4 Regular" pitchFamily="34" charset="-122"/>
                 <a:cs typeface="페이퍼로지 4 Regular" pitchFamily="34" charset="-120"/>
               </a:rPr>
-              <a:t>키워드 순위 목표 기반 입찰 조정 · 시간대/요일 규칙 · 예산 소진 제어. 애드몬스터 유형 기능.</a:t>
+              <a:t>순위 목표 기반 입찰 조정 · 시간대 규칙 · 예산 제어</a:t>
             </a:r>
             <a:endParaRPr lang="en-US" sz="900" dirty="0"/>
           </a:p>
@@ -22335,7 +21759,7 @@
                 <a:ea typeface="페이퍼로지 4 Regular" pitchFamily="34" charset="-122"/>
                 <a:cs typeface="페이퍼로지 4 Regular" pitchFamily="34" charset="-120"/>
               </a:rPr>
-              <a:t>다계정 · 다광고주 실적 일괄 수집 · 키워드 단위 대량 추출 · 정기 자동 발송.</a:t>
+              <a:t>다계정 일괄 수집 · 키워드 단위 추출 · 자동 발송</a:t>
             </a:r>
             <a:endParaRPr lang="en-US" sz="900" dirty="0"/>
           </a:p>
@@ -22482,7 +21906,7 @@
                 <a:ea typeface="페이퍼로지 4 Regular" pitchFamily="34" charset="-122"/>
                 <a:cs typeface="페이퍼로지 4 Regular" pitchFamily="34" charset="-120"/>
               </a:rPr>
-              <a:t>매체 광고비 · 마켓 매출 · 전환 데이터를 단일 지표 체계로 결합. 광고주·브랜드·상품 단위 교차 분석.</a:t>
+              <a:t>광고비 · 매출 · 전환을 단일 지표 체계로 결합</a:t>
             </a:r>
             <a:endParaRPr lang="en-US" sz="900" dirty="0"/>
           </a:p>
@@ -22629,7 +22053,7 @@
                 <a:ea typeface="페이퍼로지 4 Regular" pitchFamily="34" charset="-122"/>
                 <a:cs typeface="페이퍼로지 4 Regular" pitchFamily="34" charset="-120"/>
               </a:rPr>
-              <a:t>API 수집 스케줄러 · 정규화 · 적재 · 권한 분리까지 직접 설계·운영. 외부 솔루션 의존 없음.</a:t>
+              <a:t>수집 · 정규화 · 적재 · 권한 분리 직접 설계·운영</a:t>
             </a:r>
             <a:endParaRPr lang="en-US" sz="900" dirty="0"/>
           </a:p>
@@ -22771,8 +22195,8 @@
         </p:nvSpPr>
         <p:spPr>
           <a:xfrm>
-            <a:off x="533399" y="5010137"/>
-            <a:ext cx="3581391" cy="400049"/>
+            <a:off x="533399" y="5029187"/>
+            <a:ext cx="3581391" cy="323849"/>
           </a:xfrm>
           <a:prstGeom prst="rect">
             <a:avLst/>
@@ -22786,7 +22210,7 @@
           <a:p>
             <a:pPr indent="0" marL="0">
               <a:lnSpc>
-                <a:spcPct val="125000"/>
+                <a:spcPct val="130000"/>
               </a:lnSpc>
               <a:buNone/>
             </a:pPr>
@@ -22799,14 +22223,14 @@
                 <a:ea typeface="페이퍼로지 4 Regular" pitchFamily="34" charset="-122"/>
                 <a:cs typeface="페이퍼로지 4 Regular" pitchFamily="34" charset="-120"/>
               </a:rPr>
-              <a:t>MI는 AI 기능이 아닌 운영 자동화·데이터 기술 영역 — 기능 범위·오픈 일정은 내부 확정 후 갱신.</a:t>
+              <a:t>AI 기능이 아닌 운영 자동화·데이터 기술 영역 · 기능 범위·오픈 일정 내부 확정 후 갱신</a:t>
             </a:r>
             <a:endParaRPr lang="en-US" sz="650" dirty="0"/>
           </a:p>
           <a:p>
             <a:pPr indent="0" marL="0">
               <a:lnSpc>
-                <a:spcPct val="125000"/>
+                <a:spcPct val="130000"/>
               </a:lnSpc>
               <a:buNone/>
             </a:pPr>
@@ -22819,27 +22243,7 @@
                 <a:ea typeface="페이퍼로지 4 Regular" pitchFamily="34" charset="-122"/>
                 <a:cs typeface="페이퍼로지 4 Regular" pitchFamily="34" charset="-120"/>
               </a:rPr>
-              <a:t>공식 홈페이지 Solution 페이지에는 M Ai Platform · MARS(통합 리포트 분석 · 리포트 자동화)로 소개되어 있으며,</a:t>
-            </a:r>
-            <a:endParaRPr lang="en-US" sz="650" dirty="0"/>
-          </a:p>
-          <a:p>
-            <a:pPr indent="0" marL="0">
-              <a:lnSpc>
-                <a:spcPct val="125000"/>
-              </a:lnSpc>
-              <a:buNone/>
-            </a:pPr>
-            <a:r>
-              <a:rPr lang="en-US" sz="650" dirty="0">
-                <a:solidFill>
-                  <a:srgbClr val="94A3B8"/>
-                </a:solidFill>
-                <a:latin typeface="페이퍼로지 4 Regular" pitchFamily="34" charset="0"/>
-                <a:ea typeface="페이퍼로지 4 Regular" pitchFamily="34" charset="-122"/>
-                <a:cs typeface="페이퍼로지 4 Regular" pitchFamily="34" charset="-120"/>
-              </a:rPr>
-              <a:t>이 장표의 MI 명칭과 자동입찰 설명은 사내 제공 정보 기준입니다.</a:t>
+              <a:t>공식 Solution 페이지는 M Ai Platform · MARS로 소개 — MI 명칭·자동입찰은 사내 정보 기준</a:t>
             </a:r>
             <a:endParaRPr lang="en-US" sz="650" dirty="0"/>
           </a:p>
@@ -24518,16 +23922,16 @@
         </p:nvSpPr>
         <p:spPr>
           <a:xfrm>
-            <a:off x="533399" y="5219687"/>
-            <a:ext cx="3638541" cy="704848"/>
+            <a:off x="533399" y="5619736"/>
+            <a:ext cx="3638541" cy="361949"/>
           </a:xfrm>
           <a:prstGeom prst="roundRect">
             <a:avLst>
-              <a:gd name="adj" fmla="val 7784"/>
+              <a:gd name="adj" fmla="val 15158"/>
             </a:avLst>
           </a:prstGeom>
           <a:solidFill>
-            <a:srgbClr val="FBFDFF"/>
+            <a:srgbClr val="F5F8FC"/>
           </a:solidFill>
           <a:ln w="9525">
             <a:solidFill>
@@ -24545,24 +23949,24 @@
         </p:nvSpPr>
         <p:spPr>
           <a:xfrm>
-            <a:off x="685798" y="5333987"/>
-            <a:ext cx="3333742" cy="171450"/>
-          </a:xfrm>
-          <a:prstGeom prst="rect">
-            <a:avLst/>
-          </a:prstGeom>
-          <a:noFill/>
-          <a:ln/>
-        </p:spPr>
-        <p:txBody>
-          <a:bodyPr wrap="square" lIns="0" tIns="0" rIns="0" bIns="0" rtlCol="0" anchor="ctr"/>
-          <a:lstStyle/>
-          <a:p>
-            <a:pPr indent="0" marL="0">
-              <a:buNone/>
-            </a:pPr>
-            <a:r>
-              <a:rPr lang="en-US" sz="1000" dirty="0">
+            <a:off x="666748" y="5619736"/>
+            <a:ext cx="3371842" cy="361949"/>
+          </a:xfrm>
+          <a:prstGeom prst="rect">
+            <a:avLst/>
+          </a:prstGeom>
+          <a:noFill/>
+          <a:ln/>
+        </p:spPr>
+        <p:txBody>
+          <a:bodyPr wrap="square" lIns="0" tIns="0" rIns="0" bIns="0" rtlCol="0" anchor="ctr"/>
+          <a:lstStyle/>
+          <a:p>
+            <a:pPr indent="0" marL="0">
+              <a:buNone/>
+            </a:pPr>
+            <a:r>
+              <a:rPr lang="en-US" sz="800" dirty="0">
                 <a:solidFill>
                   <a:srgbClr val="1B468B"/>
                 </a:solidFill>
@@ -24570,37 +23974,9 @@
                 <a:ea typeface="페이퍼로지 8 ExtraBold" pitchFamily="34" charset="-122"/>
                 <a:cs typeface="페이퍼로지 8 ExtraBold" pitchFamily="34" charset="-120"/>
               </a:rPr>
-              <a:t>외부 툴 구독 대체</a:t>
-            </a:r>
-            <a:endParaRPr lang="en-US" sz="1000" dirty="0"/>
-          </a:p>
-        </p:txBody>
-      </p:sp>
-      <p:sp>
-        <p:nvSpPr>
-          <p:cNvPr id="80" name="Text 78"/>
-          <p:cNvSpPr txBox="1"/>
-          <p:nvPr/>
-        </p:nvSpPr>
-        <p:spPr>
-          <a:xfrm>
-            <a:off x="685798" y="5543536"/>
-            <a:ext cx="3333742" cy="304799"/>
-          </a:xfrm>
-          <a:prstGeom prst="rect">
-            <a:avLst/>
-          </a:prstGeom>
-          <a:noFill/>
-          <a:ln/>
-        </p:spPr>
-        <p:txBody>
-          <a:bodyPr wrap="square" lIns="0" tIns="0" rIns="0" bIns="0" rtlCol="0" anchor="ctr"/>
-          <a:lstStyle/>
-          <a:p>
-            <a:pPr indent="0" marL="0">
-              <a:lnSpc>
-                <a:spcPct val="125000"/>
-              </a:lnSpc>
+              <a:t>외부 툴 구독 대체  </a:t>
+            </a:r>
+            <a:pPr indent="0" marL="0">
               <a:buNone/>
             </a:pPr>
             <a:r>
@@ -24612,7 +23988,7 @@
                 <a:ea typeface="페이퍼로지 4 Regular" pitchFamily="34" charset="-122"/>
                 <a:cs typeface="페이퍼로지 4 Regular" pitchFamily="34" charset="-120"/>
               </a:rPr>
-              <a:t>입찰관리 툴 이용료 없이 사내 인프라로 운영</a:t>
+              <a:t>사내 인프라 운영</a:t>
             </a:r>
             <a:endParaRPr lang="en-US" sz="800" dirty="0"/>
           </a:p>
@@ -24620,22 +23996,22 @@
       </p:sp>
       <p:sp>
         <p:nvSpPr>
-          <p:cNvPr id="81" name="Shape 79"/>
-          <p:cNvSpPr/>
-          <p:nvPr/>
-        </p:nvSpPr>
-        <p:spPr>
-          <a:xfrm>
-            <a:off x="4286239" y="5219687"/>
-            <a:ext cx="3638541" cy="704848"/>
+          <p:cNvPr id="80" name="Shape 78"/>
+          <p:cNvSpPr/>
+          <p:nvPr/>
+        </p:nvSpPr>
+        <p:spPr>
+          <a:xfrm>
+            <a:off x="4286239" y="5619736"/>
+            <a:ext cx="3638541" cy="361949"/>
           </a:xfrm>
           <a:prstGeom prst="roundRect">
             <a:avLst>
-              <a:gd name="adj" fmla="val 7784"/>
+              <a:gd name="adj" fmla="val 15158"/>
             </a:avLst>
           </a:prstGeom>
           <a:solidFill>
-            <a:srgbClr val="FBFDFF"/>
+            <a:srgbClr val="F5F8FC"/>
           </a:solidFill>
           <a:ln w="9525">
             <a:solidFill>
@@ -24647,30 +24023,30 @@
       </p:sp>
       <p:sp>
         <p:nvSpPr>
-          <p:cNvPr id="82" name="Text 80"/>
-          <p:cNvSpPr txBox="1"/>
-          <p:nvPr/>
-        </p:nvSpPr>
-        <p:spPr>
-          <a:xfrm>
-            <a:off x="4438639" y="5333987"/>
-            <a:ext cx="3333742" cy="171450"/>
-          </a:xfrm>
-          <a:prstGeom prst="rect">
-            <a:avLst/>
-          </a:prstGeom>
-          <a:noFill/>
-          <a:ln/>
-        </p:spPr>
-        <p:txBody>
-          <a:bodyPr wrap="square" lIns="0" tIns="0" rIns="0" bIns="0" rtlCol="0" anchor="ctr"/>
-          <a:lstStyle/>
-          <a:p>
-            <a:pPr indent="0" marL="0">
-              <a:buNone/>
-            </a:pPr>
-            <a:r>
-              <a:rPr lang="en-US" sz="1000" dirty="0">
+          <p:cNvPr id="81" name="Text 79"/>
+          <p:cNvSpPr txBox="1"/>
+          <p:nvPr/>
+        </p:nvSpPr>
+        <p:spPr>
+          <a:xfrm>
+            <a:off x="4419589" y="5619736"/>
+            <a:ext cx="3371842" cy="361949"/>
+          </a:xfrm>
+          <a:prstGeom prst="rect">
+            <a:avLst/>
+          </a:prstGeom>
+          <a:noFill/>
+          <a:ln/>
+        </p:spPr>
+        <p:txBody>
+          <a:bodyPr wrap="square" lIns="0" tIns="0" rIns="0" bIns="0" rtlCol="0" anchor="ctr"/>
+          <a:lstStyle/>
+          <a:p>
+            <a:pPr indent="0" marL="0">
+              <a:buNone/>
+            </a:pPr>
+            <a:r>
+              <a:rPr lang="en-US" sz="800" dirty="0">
                 <a:solidFill>
                   <a:srgbClr val="1B468B"/>
                 </a:solidFill>
@@ -24678,37 +24054,9 @@
                 <a:ea typeface="페이퍼로지 8 ExtraBold" pitchFamily="34" charset="-122"/>
                 <a:cs typeface="페이퍼로지 8 ExtraBold" pitchFamily="34" charset="-120"/>
               </a:rPr>
-              <a:t>데이터 단절 없음</a:t>
-            </a:r>
-            <a:endParaRPr lang="en-US" sz="1000" dirty="0"/>
-          </a:p>
-        </p:txBody>
-      </p:sp>
-      <p:sp>
-        <p:nvSpPr>
-          <p:cNvPr id="83" name="Text 81"/>
-          <p:cNvSpPr txBox="1"/>
-          <p:nvPr/>
-        </p:nvSpPr>
-        <p:spPr>
-          <a:xfrm>
-            <a:off x="4438639" y="5543536"/>
-            <a:ext cx="3333742" cy="304799"/>
-          </a:xfrm>
-          <a:prstGeom prst="rect">
-            <a:avLst/>
-          </a:prstGeom>
-          <a:noFill/>
-          <a:ln/>
-        </p:spPr>
-        <p:txBody>
-          <a:bodyPr wrap="square" lIns="0" tIns="0" rIns="0" bIns="0" rtlCol="0" anchor="ctr"/>
-          <a:lstStyle/>
-          <a:p>
-            <a:pPr indent="0" marL="0">
-              <a:lnSpc>
-                <a:spcPct val="125000"/>
-              </a:lnSpc>
+              <a:t>데이터 단절 없음  </a:t>
+            </a:r>
+            <a:pPr indent="0" marL="0">
               <a:buNone/>
             </a:pPr>
             <a:r>
@@ -24720,7 +24068,7 @@
                 <a:ea typeface="페이퍼로지 4 Regular" pitchFamily="34" charset="-122"/>
                 <a:cs typeface="페이퍼로지 4 Regular" pitchFamily="34" charset="-120"/>
               </a:rPr>
-              <a:t>입찰 · 리포트 · 매출이 애드리포트/커머스허브와 같은 기준</a:t>
+              <a:t>애드리포트·커머스허브와 같은 기준</a:t>
             </a:r>
             <a:endParaRPr lang="en-US" sz="800" dirty="0"/>
           </a:p>
@@ -24728,22 +24076,22 @@
       </p:sp>
       <p:sp>
         <p:nvSpPr>
-          <p:cNvPr id="84" name="Shape 82"/>
-          <p:cNvSpPr/>
-          <p:nvPr/>
-        </p:nvSpPr>
-        <p:spPr>
-          <a:xfrm>
-            <a:off x="8039080" y="5219687"/>
-            <a:ext cx="3638541" cy="704848"/>
+          <p:cNvPr id="82" name="Shape 80"/>
+          <p:cNvSpPr/>
+          <p:nvPr/>
+        </p:nvSpPr>
+        <p:spPr>
+          <a:xfrm>
+            <a:off x="8039080" y="5619736"/>
+            <a:ext cx="3638541" cy="361949"/>
           </a:xfrm>
           <a:prstGeom prst="roundRect">
             <a:avLst>
-              <a:gd name="adj" fmla="val 7784"/>
+              <a:gd name="adj" fmla="val 15158"/>
             </a:avLst>
           </a:prstGeom>
           <a:solidFill>
-            <a:srgbClr val="FBFDFF"/>
+            <a:srgbClr val="F5F8FC"/>
           </a:solidFill>
           <a:ln w="9525">
             <a:solidFill>
@@ -24755,30 +24103,30 @@
       </p:sp>
       <p:sp>
         <p:nvSpPr>
-          <p:cNvPr id="85" name="Text 83"/>
-          <p:cNvSpPr txBox="1"/>
-          <p:nvPr/>
-        </p:nvSpPr>
-        <p:spPr>
-          <a:xfrm>
-            <a:off x="8191480" y="5333987"/>
-            <a:ext cx="3333742" cy="171450"/>
-          </a:xfrm>
-          <a:prstGeom prst="rect">
-            <a:avLst/>
-          </a:prstGeom>
-          <a:noFill/>
-          <a:ln/>
-        </p:spPr>
-        <p:txBody>
-          <a:bodyPr wrap="square" lIns="0" tIns="0" rIns="0" bIns="0" rtlCol="0" anchor="ctr"/>
-          <a:lstStyle/>
-          <a:p>
-            <a:pPr indent="0" marL="0">
-              <a:buNone/>
-            </a:pPr>
-            <a:r>
-              <a:rPr lang="en-US" sz="1000" dirty="0">
+          <p:cNvPr id="83" name="Text 81"/>
+          <p:cNvSpPr txBox="1"/>
+          <p:nvPr/>
+        </p:nvSpPr>
+        <p:spPr>
+          <a:xfrm>
+            <a:off x="8172430" y="5619736"/>
+            <a:ext cx="3371842" cy="361949"/>
+          </a:xfrm>
+          <a:prstGeom prst="rect">
+            <a:avLst/>
+          </a:prstGeom>
+          <a:noFill/>
+          <a:ln/>
+        </p:spPr>
+        <p:txBody>
+          <a:bodyPr wrap="square" lIns="0" tIns="0" rIns="0" bIns="0" rtlCol="0" anchor="ctr"/>
+          <a:lstStyle/>
+          <a:p>
+            <a:pPr indent="0" marL="0">
+              <a:buNone/>
+            </a:pPr>
+            <a:r>
+              <a:rPr lang="en-US" sz="800" dirty="0">
                 <a:solidFill>
                   <a:srgbClr val="1B468B"/>
                 </a:solidFill>
@@ -24786,37 +24134,9 @@
                 <a:ea typeface="페이퍼로지 8 ExtraBold" pitchFamily="34" charset="-122"/>
                 <a:cs typeface="페이퍼로지 8 ExtraBold" pitchFamily="34" charset="-120"/>
               </a:rPr>
-              <a:t>확장 기반</a:t>
-            </a:r>
-            <a:endParaRPr lang="en-US" sz="1000" dirty="0"/>
-          </a:p>
-        </p:txBody>
-      </p:sp>
-      <p:sp>
-        <p:nvSpPr>
-          <p:cNvPr id="86" name="Text 84"/>
-          <p:cNvSpPr txBox="1"/>
-          <p:nvPr/>
-        </p:nvSpPr>
-        <p:spPr>
-          <a:xfrm>
-            <a:off x="8191480" y="5543536"/>
-            <a:ext cx="3333742" cy="304799"/>
-          </a:xfrm>
-          <a:prstGeom prst="rect">
-            <a:avLst/>
-          </a:prstGeom>
-          <a:noFill/>
-          <a:ln/>
-        </p:spPr>
-        <p:txBody>
-          <a:bodyPr wrap="square" lIns="0" tIns="0" rIns="0" bIns="0" rtlCol="0" anchor="ctr"/>
-          <a:lstStyle/>
-          <a:p>
-            <a:pPr indent="0" marL="0">
-              <a:lnSpc>
-                <a:spcPct val="125000"/>
-              </a:lnSpc>
+              <a:t>확장 기반  </a:t>
+            </a:r>
+            <a:pPr indent="0" marL="0">
               <a:buNone/>
             </a:pPr>
             <a:r>
@@ -24828,7 +24148,7 @@
                 <a:ea typeface="페이퍼로지 4 Regular" pitchFamily="34" charset="-122"/>
                 <a:cs typeface="페이퍼로지 4 Regular" pitchFamily="34" charset="-120"/>
               </a:rPr>
-              <a:t>새 매체·마켓 추가 시 수집 계층만 붙이면 전 솔루션에 반영</a:t>
+              <a:t>수집 계층만 추가하면 전 솔루션 반영</a:t>
             </a:r>
             <a:endParaRPr lang="en-US" sz="800" dirty="0"/>
           </a:p>
@@ -24836,7 +24156,7 @@
       </p:sp>
       <p:sp>
         <p:nvSpPr>
-          <p:cNvPr id="87" name="Shape 85"/>
+          <p:cNvPr id="84" name="Shape 82"/>
           <p:cNvSpPr/>
           <p:nvPr/>
         </p:nvSpPr>
@@ -24859,7 +24179,7 @@
       </p:sp>
       <p:sp>
         <p:nvSpPr>
-          <p:cNvPr id="88" name="Text 86"/>
+          <p:cNvPr id="85" name="Text 83"/>
           <p:cNvSpPr txBox="1"/>
           <p:nvPr/>
         </p:nvSpPr>
@@ -24898,7 +24218,7 @@
       </p:sp>
       <p:sp>
         <p:nvSpPr>
-          <p:cNvPr id="89" name="Text 87"/>
+          <p:cNvPr id="86" name="Text 84"/>
           <p:cNvSpPr txBox="1"/>
           <p:nvPr/>
         </p:nvSpPr>
@@ -26399,12 +25719,252 @@
         </p:nvSpPr>
         <p:spPr>
           <a:xfrm>
-            <a:off x="533399" y="5010137"/>
-            <a:ext cx="11125172" cy="590549"/>
+            <a:off x="533399" y="4972038"/>
+            <a:ext cx="3638541" cy="342899"/>
           </a:xfrm>
           <a:prstGeom prst="roundRect">
             <a:avLst>
-              <a:gd name="adj" fmla="val 7742"/>
+              <a:gd name="adj" fmla="val 16000"/>
+            </a:avLst>
+          </a:prstGeom>
+          <a:solidFill>
+            <a:srgbClr val="F5F8FC"/>
+          </a:solidFill>
+          <a:ln w="9525">
+            <a:solidFill>
+              <a:srgbClr val="E3EAF4"/>
+            </a:solidFill>
+            <a:prstDash val="solid"/>
+          </a:ln>
+        </p:spPr>
+      </p:sp>
+      <p:sp>
+        <p:nvSpPr>
+          <p:cNvPr id="30" name="Text 28"/>
+          <p:cNvSpPr txBox="1"/>
+          <p:nvPr/>
+        </p:nvSpPr>
+        <p:spPr>
+          <a:xfrm>
+            <a:off x="666748" y="4972038"/>
+            <a:ext cx="3371842" cy="342899"/>
+          </a:xfrm>
+          <a:prstGeom prst="rect">
+            <a:avLst/>
+          </a:prstGeom>
+          <a:noFill/>
+          <a:ln/>
+        </p:spPr>
+        <p:txBody>
+          <a:bodyPr wrap="square" lIns="0" tIns="0" rIns="0" bIns="0" rtlCol="0" anchor="ctr"/>
+          <a:lstStyle/>
+          <a:p>
+            <a:pPr indent="0" marL="0">
+              <a:buNone/>
+            </a:pPr>
+            <a:r>
+              <a:rPr lang="en-US" sz="750" dirty="0">
+                <a:solidFill>
+                  <a:srgbClr val="1B468B"/>
+                </a:solidFill>
+                <a:latin typeface="페이퍼로지 8 ExtraBold" pitchFamily="34" charset="0"/>
+                <a:ea typeface="페이퍼로지 8 ExtraBold" pitchFamily="34" charset="-122"/>
+                <a:cs typeface="페이퍼로지 8 ExtraBold" pitchFamily="34" charset="-120"/>
+              </a:rPr>
+              <a:t>주간 10억 명  </a:t>
+            </a:r>
+            <a:pPr indent="0" marL="0">
+              <a:buNone/>
+            </a:pPr>
+            <a:r>
+              <a:rPr lang="en-US" sz="750" dirty="0">
+                <a:solidFill>
+                  <a:srgbClr val="334155"/>
+                </a:solidFill>
+                <a:latin typeface="페이퍼로지 4 Regular" pitchFamily="34" charset="0"/>
+                <a:ea typeface="페이퍼로지 4 Regular" pitchFamily="34" charset="-122"/>
+                <a:cs typeface="페이퍼로지 4 Regular" pitchFamily="34" charset="-120"/>
+              </a:rPr>
+              <a:t>ChatGPT 주간 활성 이용자(OpenAI, 2026.07)</a:t>
+            </a:r>
+            <a:endParaRPr lang="en-US" sz="750" dirty="0"/>
+          </a:p>
+        </p:txBody>
+      </p:sp>
+      <p:sp>
+        <p:nvSpPr>
+          <p:cNvPr id="31" name="Shape 29"/>
+          <p:cNvSpPr/>
+          <p:nvPr/>
+        </p:nvSpPr>
+        <p:spPr>
+          <a:xfrm>
+            <a:off x="4286239" y="4972038"/>
+            <a:ext cx="3638541" cy="342899"/>
+          </a:xfrm>
+          <a:prstGeom prst="roundRect">
+            <a:avLst>
+              <a:gd name="adj" fmla="val 16000"/>
+            </a:avLst>
+          </a:prstGeom>
+          <a:solidFill>
+            <a:srgbClr val="F5F8FC"/>
+          </a:solidFill>
+          <a:ln w="9525">
+            <a:solidFill>
+              <a:srgbClr val="E3EAF4"/>
+            </a:solidFill>
+            <a:prstDash val="solid"/>
+          </a:ln>
+        </p:spPr>
+      </p:sp>
+      <p:sp>
+        <p:nvSpPr>
+          <p:cNvPr id="32" name="Text 30"/>
+          <p:cNvSpPr txBox="1"/>
+          <p:nvPr/>
+        </p:nvSpPr>
+        <p:spPr>
+          <a:xfrm>
+            <a:off x="4419589" y="4972038"/>
+            <a:ext cx="3371842" cy="342899"/>
+          </a:xfrm>
+          <a:prstGeom prst="rect">
+            <a:avLst/>
+          </a:prstGeom>
+          <a:noFill/>
+          <a:ln/>
+        </p:spPr>
+        <p:txBody>
+          <a:bodyPr wrap="square" lIns="0" tIns="0" rIns="0" bIns="0" rtlCol="0" anchor="ctr"/>
+          <a:lstStyle/>
+          <a:p>
+            <a:pPr indent="0" marL="0">
+              <a:buNone/>
+            </a:pPr>
+            <a:r>
+              <a:rPr lang="en-US" sz="750" dirty="0">
+                <a:solidFill>
+                  <a:srgbClr val="1B468B"/>
+                </a:solidFill>
+                <a:latin typeface="페이퍼로지 8 ExtraBold" pitchFamily="34" charset="0"/>
+                <a:ea typeface="페이퍼로지 8 ExtraBold" pitchFamily="34" charset="-122"/>
+                <a:cs typeface="페이퍼로지 8 ExtraBold" pitchFamily="34" charset="-120"/>
+              </a:rPr>
+              <a:t>약 40%  </a:t>
+            </a:r>
+            <a:pPr indent="0" marL="0">
+              <a:buNone/>
+            </a:pPr>
+            <a:r>
+              <a:rPr lang="en-US" sz="750" dirty="0">
+                <a:solidFill>
+                  <a:srgbClr val="334155"/>
+                </a:solidFill>
+                <a:latin typeface="페이퍼로지 4 Regular" pitchFamily="34" charset="0"/>
+                <a:ea typeface="페이퍼로지 4 Regular" pitchFamily="34" charset="-122"/>
+                <a:cs typeface="페이퍼로지 4 Regular" pitchFamily="34" charset="-120"/>
+              </a:rPr>
+              <a:t>2026년 AI 제작 디지털 광고 비중 전망</a:t>
+            </a:r>
+            <a:endParaRPr lang="en-US" sz="750" dirty="0"/>
+          </a:p>
+        </p:txBody>
+      </p:sp>
+      <p:sp>
+        <p:nvSpPr>
+          <p:cNvPr id="33" name="Shape 31"/>
+          <p:cNvSpPr/>
+          <p:nvPr/>
+        </p:nvSpPr>
+        <p:spPr>
+          <a:xfrm>
+            <a:off x="8039080" y="4972038"/>
+            <a:ext cx="3638541" cy="342899"/>
+          </a:xfrm>
+          <a:prstGeom prst="roundRect">
+            <a:avLst>
+              <a:gd name="adj" fmla="val 16000"/>
+            </a:avLst>
+          </a:prstGeom>
+          <a:solidFill>
+            <a:srgbClr val="F5F8FC"/>
+          </a:solidFill>
+          <a:ln w="9525">
+            <a:solidFill>
+              <a:srgbClr val="E3EAF4"/>
+            </a:solidFill>
+            <a:prstDash val="solid"/>
+          </a:ln>
+        </p:spPr>
+      </p:sp>
+      <p:sp>
+        <p:nvSpPr>
+          <p:cNvPr id="34" name="Text 32"/>
+          <p:cNvSpPr txBox="1"/>
+          <p:nvPr/>
+        </p:nvSpPr>
+        <p:spPr>
+          <a:xfrm>
+            <a:off x="8172430" y="4972038"/>
+            <a:ext cx="3371842" cy="342899"/>
+          </a:xfrm>
+          <a:prstGeom prst="rect">
+            <a:avLst/>
+          </a:prstGeom>
+          <a:noFill/>
+          <a:ln/>
+        </p:spPr>
+        <p:txBody>
+          <a:bodyPr wrap="square" lIns="0" tIns="0" rIns="0" bIns="0" rtlCol="0" anchor="ctr"/>
+          <a:lstStyle/>
+          <a:p>
+            <a:pPr indent="0" marL="0">
+              <a:buNone/>
+            </a:pPr>
+            <a:r>
+              <a:rPr lang="en-US" sz="750" dirty="0">
+                <a:solidFill>
+                  <a:srgbClr val="1B468B"/>
+                </a:solidFill>
+                <a:latin typeface="페이퍼로지 8 ExtraBold" pitchFamily="34" charset="0"/>
+                <a:ea typeface="페이퍼로지 8 ExtraBold" pitchFamily="34" charset="-122"/>
+                <a:cs typeface="페이퍼로지 8 ExtraBold" pitchFamily="34" charset="-120"/>
+              </a:rPr>
+              <a:t>0.8~1.3%  </a:t>
+            </a:r>
+            <a:pPr indent="0" marL="0">
+              <a:buNone/>
+            </a:pPr>
+            <a:r>
+              <a:rPr lang="en-US" sz="750" dirty="0">
+                <a:solidFill>
+                  <a:srgbClr val="334155"/>
+                </a:solidFill>
+                <a:latin typeface="페이퍼로지 4 Regular" pitchFamily="34" charset="0"/>
+                <a:ea typeface="페이퍼로지 4 Regular" pitchFamily="34" charset="-122"/>
+                <a:cs typeface="페이퍼로지 4 Regular" pitchFamily="34" charset="-120"/>
+              </a:rPr>
+              <a:t>AI 검색 클릭률(구글 약 29%) — Similarweb 2026</a:t>
+            </a:r>
+            <a:endParaRPr lang="en-US" sz="750" dirty="0"/>
+          </a:p>
+        </p:txBody>
+      </p:sp>
+      <p:sp>
+        <p:nvSpPr>
+          <p:cNvPr id="35" name="Shape 33"/>
+          <p:cNvSpPr/>
+          <p:nvPr/>
+        </p:nvSpPr>
+        <p:spPr>
+          <a:xfrm>
+            <a:off x="533399" y="5429236"/>
+            <a:ext cx="11125172" cy="552449"/>
+          </a:xfrm>
+          <a:prstGeom prst="roundRect">
+            <a:avLst>
+              <a:gd name="adj" fmla="val 8276"/>
             </a:avLst>
           </a:prstGeom>
           <a:solidFill>
@@ -26420,13 +25980,13 @@
       </p:sp>
       <p:sp>
         <p:nvSpPr>
-          <p:cNvPr id="30" name="Text 28"/>
-          <p:cNvSpPr txBox="1"/>
-          <p:nvPr/>
-        </p:nvSpPr>
-        <p:spPr>
-          <a:xfrm>
-            <a:off x="723898" y="5105387"/>
+          <p:cNvPr id="36" name="Text 34"/>
+          <p:cNvSpPr txBox="1"/>
+          <p:nvPr/>
+        </p:nvSpPr>
+        <p:spPr>
+          <a:xfrm>
+            <a:off x="723898" y="5524486"/>
             <a:ext cx="6667483" cy="209549"/>
           </a:xfrm>
           <a:prstGeom prst="rect">
@@ -26459,13 +26019,13 @@
       </p:sp>
       <p:sp>
         <p:nvSpPr>
-          <p:cNvPr id="31" name="Text 29"/>
-          <p:cNvSpPr txBox="1"/>
-          <p:nvPr/>
-        </p:nvSpPr>
-        <p:spPr>
-          <a:xfrm>
-            <a:off x="723898" y="5314937"/>
+          <p:cNvPr id="37" name="Text 35"/>
+          <p:cNvSpPr txBox="1"/>
+          <p:nvPr/>
+        </p:nvSpPr>
+        <p:spPr>
+          <a:xfrm>
+            <a:off x="723898" y="5734036"/>
             <a:ext cx="6667483" cy="190500"/>
           </a:xfrm>
           <a:prstGeom prst="rect">
@@ -26498,13 +26058,13 @@
       </p:sp>
       <p:sp>
         <p:nvSpPr>
-          <p:cNvPr id="32" name="Shape 30"/>
-          <p:cNvSpPr/>
-          <p:nvPr/>
-        </p:nvSpPr>
-        <p:spPr>
-          <a:xfrm>
-            <a:off x="9143977" y="5143487"/>
+          <p:cNvPr id="38" name="Shape 36"/>
+          <p:cNvSpPr/>
+          <p:nvPr/>
+        </p:nvSpPr>
+        <p:spPr>
+          <a:xfrm>
+            <a:off x="9143977" y="5543536"/>
             <a:ext cx="2324094" cy="323849"/>
           </a:xfrm>
           <a:prstGeom prst="roundRect">
@@ -26525,13 +26085,13 @@
       </p:sp>
       <p:sp>
         <p:nvSpPr>
-          <p:cNvPr id="33" name="Text 31"/>
-          <p:cNvSpPr txBox="1"/>
-          <p:nvPr/>
-        </p:nvSpPr>
-        <p:spPr>
-          <a:xfrm>
-            <a:off x="9143977" y="5143487"/>
+          <p:cNvPr id="39" name="Text 37"/>
+          <p:cNvSpPr txBox="1"/>
+          <p:nvPr/>
+        </p:nvSpPr>
+        <p:spPr>
+          <a:xfrm>
+            <a:off x="9143977" y="5543536"/>
             <a:ext cx="2324094" cy="323849"/>
           </a:xfrm>
           <a:prstGeom prst="rect">
@@ -26564,7 +26124,7 @@
       </p:sp>
       <p:sp>
         <p:nvSpPr>
-          <p:cNvPr id="34" name="Shape 32"/>
+          <p:cNvPr id="40" name="Shape 38"/>
           <p:cNvSpPr/>
           <p:nvPr/>
         </p:nvSpPr>
@@ -26587,7 +26147,7 @@
       </p:sp>
       <p:sp>
         <p:nvSpPr>
-          <p:cNvPr id="35" name="Text 33"/>
+          <p:cNvPr id="41" name="Text 39"/>
           <p:cNvSpPr txBox="1"/>
           <p:nvPr/>
         </p:nvSpPr>
@@ -26626,7 +26186,7 @@
       </p:sp>
       <p:sp>
         <p:nvSpPr>
-          <p:cNvPr id="36" name="Text 34"/>
+          <p:cNvPr id="42" name="Text 40"/>
           <p:cNvSpPr txBox="1"/>
           <p:nvPr/>
         </p:nvSpPr>

</xml_diff>

<commit_message>
Fix media chip text wrapping inside chips
- 좁은 칸(07장 애드리포트 패널)에서 칩이 줄어들며 "카카오모먼 트", "크리테 오"처럼
  글자가 칩 안에서 줄바꿈되던 문제 수정
  · .m 칩에 white-space:nowrap + flex:0 0 auto 적용(축소 금지)
  · 패널 안 칩은 글자 10.5px로 한 단계 축소
- PPTX도 동일 위험 제거: 칩 폭을 글자 종류별(한글 10.2px / 라틴 5.6px)로 계산하고
  텍스트 상자에 wrap:false 지정
- 검증: 전 장표 칩 줄바꿈 0건, 넘침 0건, PPTX 폭 부족 0건

Co-Authored-By: Claude Opus 5 <noreply@anthropic.com>
Claude-Session: https://claude.ai/code/session_011X2s4AJGYKPxJHXCXs5Aou
</commit_message>
<xml_diff>
--- a/ai-solution/mplanit-ai-solution.pptx
+++ b/ai-solution/mplanit-ai-solution.pptx
@@ -4045,7 +4045,7 @@
         <p:spPr>
           <a:xfrm>
             <a:off x="533399" y="5124437"/>
-            <a:ext cx="851533" cy="209549"/>
+            <a:ext cx="925828" cy="209549"/>
           </a:xfrm>
           <a:prstGeom prst="rect">
             <a:avLst/>
@@ -4083,8 +4083,8 @@
         </p:nvSpPr>
         <p:spPr>
           <a:xfrm>
-            <a:off x="1423031" y="5124437"/>
-            <a:ext cx="720088" cy="209549"/>
+            <a:off x="1497326" y="5124437"/>
+            <a:ext cx="843913" cy="209549"/>
           </a:xfrm>
           <a:prstGeom prst="roundRect">
             <a:avLst>
@@ -4118,7 +4118,7 @@
         </p:blipFill>
         <p:spPr>
           <a:xfrm>
-            <a:off x="1489706" y="5176825"/>
+            <a:off x="1564001" y="5176825"/>
             <a:ext cx="104775" cy="104775"/>
           </a:xfrm>
           <a:prstGeom prst="rect">
@@ -4134,17 +4134,17 @@
         </p:nvSpPr>
         <p:spPr>
           <a:xfrm>
-            <a:off x="1623056" y="5124437"/>
-            <a:ext cx="472439" cy="209549"/>
-          </a:xfrm>
-          <a:prstGeom prst="rect">
-            <a:avLst/>
-          </a:prstGeom>
-          <a:noFill/>
-          <a:ln/>
-        </p:spPr>
-        <p:txBody>
-          <a:bodyPr wrap="square" lIns="0" tIns="0" rIns="0" bIns="0" rtlCol="0" anchor="ctr"/>
+            <a:off x="1687826" y="5124437"/>
+            <a:ext cx="634363" cy="209549"/>
+          </a:xfrm>
+          <a:prstGeom prst="rect">
+            <a:avLst/>
+          </a:prstGeom>
+          <a:noFill/>
+          <a:ln/>
+        </p:spPr>
+        <p:txBody>
+          <a:bodyPr wrap="none" lIns="0" tIns="0" rIns="0" bIns="0" rtlCol="0" anchor="ctr"/>
           <a:lstStyle/>
           <a:p>
             <a:pPr indent="0" marL="0">
@@ -4173,8 +4173,8 @@
         </p:nvSpPr>
         <p:spPr>
           <a:xfrm>
-            <a:off x="2200269" y="5124437"/>
-            <a:ext cx="445769" cy="209549"/>
+            <a:off x="2398389" y="5124437"/>
+            <a:ext cx="407669" cy="209549"/>
           </a:xfrm>
           <a:prstGeom prst="roundRect">
             <a:avLst>
@@ -4200,7 +4200,7 @@
         </p:nvSpPr>
         <p:spPr>
           <a:xfrm>
-            <a:off x="2276469" y="5200637"/>
+            <a:off x="2474589" y="5200637"/>
             <a:ext cx="57150" cy="57150"/>
           </a:xfrm>
           <a:prstGeom prst="ellipse">
@@ -4225,7 +4225,7 @@
         </p:nvSpPr>
         <p:spPr>
           <a:xfrm>
-            <a:off x="2371719" y="5124437"/>
+            <a:off x="2560314" y="5124437"/>
             <a:ext cx="217169" cy="209549"/>
           </a:xfrm>
           <a:prstGeom prst="rect">
@@ -4235,7 +4235,7 @@
           <a:ln/>
         </p:spPr>
         <p:txBody>
-          <a:bodyPr wrap="square" lIns="0" tIns="0" rIns="0" bIns="0" rtlCol="0" anchor="ctr"/>
+          <a:bodyPr wrap="none" lIns="0" tIns="0" rIns="0" bIns="0" rtlCol="0" anchor="ctr"/>
           <a:lstStyle/>
           <a:p>
             <a:pPr indent="0" marL="0">
@@ -4264,8 +4264,8 @@
         </p:nvSpPr>
         <p:spPr>
           <a:xfrm>
-            <a:off x="2703188" y="5124437"/>
-            <a:ext cx="518159" cy="209549"/>
+            <a:off x="2863208" y="5124437"/>
+            <a:ext cx="461009" cy="209549"/>
           </a:xfrm>
           <a:prstGeom prst="roundRect">
             <a:avLst>
@@ -4291,7 +4291,7 @@
         </p:nvSpPr>
         <p:spPr>
           <a:xfrm>
-            <a:off x="2779388" y="5200637"/>
+            <a:off x="2939408" y="5200637"/>
             <a:ext cx="57150" cy="57150"/>
           </a:xfrm>
           <a:prstGeom prst="ellipse">
@@ -4316,17 +4316,17 @@
         </p:nvSpPr>
         <p:spPr>
           <a:xfrm>
-            <a:off x="2874638" y="5124437"/>
-            <a:ext cx="289559" cy="209549"/>
-          </a:xfrm>
-          <a:prstGeom prst="rect">
-            <a:avLst/>
-          </a:prstGeom>
-          <a:noFill/>
-          <a:ln/>
-        </p:spPr>
-        <p:txBody>
-          <a:bodyPr wrap="square" lIns="0" tIns="0" rIns="0" bIns="0" rtlCol="0" anchor="ctr"/>
+            <a:off x="3025132" y="5124437"/>
+            <a:ext cx="270509" cy="209549"/>
+          </a:xfrm>
+          <a:prstGeom prst="rect">
+            <a:avLst/>
+          </a:prstGeom>
+          <a:noFill/>
+          <a:ln/>
+        </p:spPr>
+        <p:txBody>
+          <a:bodyPr wrap="none" lIns="0" tIns="0" rIns="0" bIns="0" rtlCol="0" anchor="ctr"/>
           <a:lstStyle/>
           <a:p>
             <a:pPr indent="0" marL="0">
@@ -4355,8 +4355,8 @@
         </p:nvSpPr>
         <p:spPr>
           <a:xfrm>
-            <a:off x="3278497" y="5124437"/>
-            <a:ext cx="662938" cy="209549"/>
+            <a:off x="3381367" y="5124437"/>
+            <a:ext cx="830578" cy="209549"/>
           </a:xfrm>
           <a:prstGeom prst="roundRect">
             <a:avLst>
@@ -4382,7 +4382,7 @@
         </p:nvSpPr>
         <p:spPr>
           <a:xfrm>
-            <a:off x="3354697" y="5200637"/>
+            <a:off x="3457566" y="5200637"/>
             <a:ext cx="57150" cy="57150"/>
           </a:xfrm>
           <a:prstGeom prst="ellipse">
@@ -4407,17 +4407,17 @@
         </p:nvSpPr>
         <p:spPr>
           <a:xfrm>
-            <a:off x="3449946" y="5124437"/>
-            <a:ext cx="434339" cy="209549"/>
-          </a:xfrm>
-          <a:prstGeom prst="rect">
-            <a:avLst/>
-          </a:prstGeom>
-          <a:noFill/>
-          <a:ln/>
-        </p:spPr>
-        <p:txBody>
-          <a:bodyPr wrap="square" lIns="0" tIns="0" rIns="0" bIns="0" rtlCol="0" anchor="ctr"/>
+            <a:off x="3543291" y="5124437"/>
+            <a:ext cx="640078" cy="209549"/>
+          </a:xfrm>
+          <a:prstGeom prst="rect">
+            <a:avLst/>
+          </a:prstGeom>
+          <a:noFill/>
+          <a:ln/>
+        </p:spPr>
+        <p:txBody>
+          <a:bodyPr wrap="none" lIns="0" tIns="0" rIns="0" bIns="0" rtlCol="0" anchor="ctr"/>
           <a:lstStyle/>
           <a:p>
             <a:pPr indent="0" marL="0">
@@ -4446,8 +4446,8 @@
         </p:nvSpPr>
         <p:spPr>
           <a:xfrm>
-            <a:off x="3998585" y="5124437"/>
-            <a:ext cx="590549" cy="209549"/>
+            <a:off x="4269094" y="5124437"/>
+            <a:ext cx="733423" cy="209549"/>
           </a:xfrm>
           <a:prstGeom prst="roundRect">
             <a:avLst>
@@ -4473,7 +4473,7 @@
         </p:nvSpPr>
         <p:spPr>
           <a:xfrm>
-            <a:off x="4074785" y="5200637"/>
+            <a:off x="4345294" y="5200637"/>
             <a:ext cx="57150" cy="57150"/>
           </a:xfrm>
           <a:prstGeom prst="ellipse">
@@ -4498,17 +4498,17 @@
         </p:nvSpPr>
         <p:spPr>
           <a:xfrm>
-            <a:off x="4170035" y="5124437"/>
-            <a:ext cx="361949" cy="209549"/>
-          </a:xfrm>
-          <a:prstGeom prst="rect">
-            <a:avLst/>
-          </a:prstGeom>
-          <a:noFill/>
-          <a:ln/>
-        </p:spPr>
-        <p:txBody>
-          <a:bodyPr wrap="square" lIns="0" tIns="0" rIns="0" bIns="0" rtlCol="0" anchor="ctr"/>
+            <a:off x="4431019" y="5124437"/>
+            <a:ext cx="542924" cy="209549"/>
+          </a:xfrm>
+          <a:prstGeom prst="rect">
+            <a:avLst/>
+          </a:prstGeom>
+          <a:noFill/>
+          <a:ln/>
+        </p:spPr>
+        <p:txBody>
+          <a:bodyPr wrap="none" lIns="0" tIns="0" rIns="0" bIns="0" rtlCol="0" anchor="ctr"/>
           <a:lstStyle/>
           <a:p>
             <a:pPr indent="0" marL="0">
@@ -4537,8 +4537,8 @@
         </p:nvSpPr>
         <p:spPr>
           <a:xfrm>
-            <a:off x="4646283" y="5124437"/>
-            <a:ext cx="1009647" cy="209549"/>
+            <a:off x="5059667" y="5124437"/>
+            <a:ext cx="838198" cy="209549"/>
           </a:xfrm>
           <a:prstGeom prst="roundRect">
             <a:avLst>
@@ -4572,7 +4572,7 @@
         </p:blipFill>
         <p:spPr>
           <a:xfrm>
-            <a:off x="4712958" y="5176825"/>
+            <a:off x="5126342" y="5176825"/>
             <a:ext cx="104775" cy="104775"/>
           </a:xfrm>
           <a:prstGeom prst="rect">
@@ -4588,17 +4588,17 @@
         </p:nvSpPr>
         <p:spPr>
           <a:xfrm>
-            <a:off x="4846308" y="5124437"/>
-            <a:ext cx="761998" cy="209549"/>
-          </a:xfrm>
-          <a:prstGeom prst="rect">
-            <a:avLst/>
-          </a:prstGeom>
-          <a:noFill/>
-          <a:ln/>
-        </p:spPr>
-        <p:txBody>
-          <a:bodyPr wrap="square" lIns="0" tIns="0" rIns="0" bIns="0" rtlCol="0" anchor="ctr"/>
+            <a:off x="5250167" y="5124437"/>
+            <a:ext cx="628648" cy="209549"/>
+          </a:xfrm>
+          <a:prstGeom prst="rect">
+            <a:avLst/>
+          </a:prstGeom>
+          <a:noFill/>
+          <a:ln/>
+        </p:spPr>
+        <p:txBody>
+          <a:bodyPr wrap="none" lIns="0" tIns="0" rIns="0" bIns="0" rtlCol="0" anchor="ctr"/>
           <a:lstStyle/>
           <a:p>
             <a:pPr indent="0" marL="0">
@@ -4627,8 +4627,8 @@
         </p:nvSpPr>
         <p:spPr>
           <a:xfrm>
-            <a:off x="5713081" y="5124437"/>
-            <a:ext cx="430529" cy="209549"/>
+            <a:off x="5955015" y="5124437"/>
+            <a:ext cx="499109" cy="209549"/>
           </a:xfrm>
           <a:prstGeom prst="roundRect">
             <a:avLst>
@@ -4662,7 +4662,7 @@
         </p:blipFill>
         <p:spPr>
           <a:xfrm>
-            <a:off x="5779756" y="5176825"/>
+            <a:off x="6021690" y="5176825"/>
             <a:ext cx="104775" cy="104775"/>
           </a:xfrm>
           <a:prstGeom prst="rect">
@@ -4678,17 +4678,17 @@
         </p:nvSpPr>
         <p:spPr>
           <a:xfrm>
-            <a:off x="5913105" y="5124437"/>
-            <a:ext cx="182880" cy="209549"/>
-          </a:xfrm>
-          <a:prstGeom prst="rect">
-            <a:avLst/>
-          </a:prstGeom>
-          <a:noFill/>
-          <a:ln/>
-        </p:spPr>
-        <p:txBody>
-          <a:bodyPr wrap="square" lIns="0" tIns="0" rIns="0" bIns="0" rtlCol="0" anchor="ctr"/>
+            <a:off x="6145515" y="5124437"/>
+            <a:ext cx="289559" cy="209549"/>
+          </a:xfrm>
+          <a:prstGeom prst="rect">
+            <a:avLst/>
+          </a:prstGeom>
+          <a:noFill/>
+          <a:ln/>
+        </p:spPr>
+        <p:txBody>
+          <a:bodyPr wrap="none" lIns="0" tIns="0" rIns="0" bIns="0" rtlCol="0" anchor="ctr"/>
           <a:lstStyle/>
           <a:p>
             <a:pPr indent="0" marL="0">
@@ -4717,8 +4717,8 @@
         </p:nvSpPr>
         <p:spPr>
           <a:xfrm>
-            <a:off x="6200759" y="5124437"/>
-            <a:ext cx="430529" cy="209549"/>
+            <a:off x="6511274" y="5124437"/>
+            <a:ext cx="499109" cy="209549"/>
           </a:xfrm>
           <a:prstGeom prst="roundRect">
             <a:avLst>
@@ -4752,7 +4752,7 @@
         </p:blipFill>
         <p:spPr>
           <a:xfrm>
-            <a:off x="6267434" y="5176825"/>
+            <a:off x="6577949" y="5176825"/>
             <a:ext cx="104775" cy="104775"/>
           </a:xfrm>
           <a:prstGeom prst="rect">
@@ -4768,17 +4768,17 @@
         </p:nvSpPr>
         <p:spPr>
           <a:xfrm>
-            <a:off x="6400784" y="5124437"/>
-            <a:ext cx="182880" cy="209549"/>
-          </a:xfrm>
-          <a:prstGeom prst="rect">
-            <a:avLst/>
-          </a:prstGeom>
-          <a:noFill/>
-          <a:ln/>
-        </p:spPr>
-        <p:txBody>
-          <a:bodyPr wrap="square" lIns="0" tIns="0" rIns="0" bIns="0" rtlCol="0" anchor="ctr"/>
+            <a:off x="6701773" y="5124437"/>
+            <a:ext cx="289559" cy="209549"/>
+          </a:xfrm>
+          <a:prstGeom prst="rect">
+            <a:avLst/>
+          </a:prstGeom>
+          <a:noFill/>
+          <a:ln/>
+        </p:spPr>
+        <p:txBody>
+          <a:bodyPr wrap="none" lIns="0" tIns="0" rIns="0" bIns="0" rtlCol="0" anchor="ctr"/>
           <a:lstStyle/>
           <a:p>
             <a:pPr indent="0" marL="0">
@@ -4807,8 +4807,8 @@
         </p:nvSpPr>
         <p:spPr>
           <a:xfrm>
-            <a:off x="6688438" y="5124437"/>
-            <a:ext cx="518159" cy="209549"/>
+            <a:off x="7067532" y="5124437"/>
+            <a:ext cx="636268" cy="209549"/>
           </a:xfrm>
           <a:prstGeom prst="roundRect">
             <a:avLst>
@@ -4834,7 +4834,7 @@
         </p:nvSpPr>
         <p:spPr>
           <a:xfrm>
-            <a:off x="6764638" y="5200637"/>
+            <a:off x="7143732" y="5200637"/>
             <a:ext cx="57150" cy="57150"/>
           </a:xfrm>
           <a:prstGeom prst="ellipse">
@@ -4859,17 +4859,17 @@
         </p:nvSpPr>
         <p:spPr>
           <a:xfrm>
-            <a:off x="6859888" y="5124437"/>
-            <a:ext cx="289559" cy="209549"/>
-          </a:xfrm>
-          <a:prstGeom prst="rect">
-            <a:avLst/>
-          </a:prstGeom>
-          <a:noFill/>
-          <a:ln/>
-        </p:spPr>
-        <p:txBody>
-          <a:bodyPr wrap="square" lIns="0" tIns="0" rIns="0" bIns="0" rtlCol="0" anchor="ctr"/>
+            <a:off x="7229457" y="5124437"/>
+            <a:ext cx="445769" cy="209549"/>
+          </a:xfrm>
+          <a:prstGeom prst="rect">
+            <a:avLst/>
+          </a:prstGeom>
+          <a:noFill/>
+          <a:ln/>
+        </p:spPr>
+        <p:txBody>
+          <a:bodyPr wrap="none" lIns="0" tIns="0" rIns="0" bIns="0" rtlCol="0" anchor="ctr"/>
           <a:lstStyle/>
           <a:p>
             <a:pPr indent="0" marL="0">
@@ -4898,8 +4898,8 @@
         </p:nvSpPr>
         <p:spPr>
           <a:xfrm>
-            <a:off x="7263747" y="5124437"/>
-            <a:ext cx="445769" cy="209549"/>
+            <a:off x="7760951" y="5124437"/>
+            <a:ext cx="539114" cy="209549"/>
           </a:xfrm>
           <a:prstGeom prst="roundRect">
             <a:avLst>
@@ -4925,7 +4925,7 @@
         </p:nvSpPr>
         <p:spPr>
           <a:xfrm>
-            <a:off x="7339947" y="5200637"/>
+            <a:off x="7837150" y="5200637"/>
             <a:ext cx="57150" cy="57150"/>
           </a:xfrm>
           <a:prstGeom prst="ellipse">
@@ -4950,17 +4950,17 @@
         </p:nvSpPr>
         <p:spPr>
           <a:xfrm>
-            <a:off x="7435196" y="5124437"/>
-            <a:ext cx="217169" cy="209549"/>
-          </a:xfrm>
-          <a:prstGeom prst="rect">
-            <a:avLst/>
-          </a:prstGeom>
-          <a:noFill/>
-          <a:ln/>
-        </p:spPr>
-        <p:txBody>
-          <a:bodyPr wrap="square" lIns="0" tIns="0" rIns="0" bIns="0" rtlCol="0" anchor="ctr"/>
+            <a:off x="7922875" y="5124437"/>
+            <a:ext cx="348614" cy="209549"/>
+          </a:xfrm>
+          <a:prstGeom prst="rect">
+            <a:avLst/>
+          </a:prstGeom>
+          <a:noFill/>
+          <a:ln/>
+        </p:spPr>
+        <p:txBody>
+          <a:bodyPr wrap="none" lIns="0" tIns="0" rIns="0" bIns="0" rtlCol="0" anchor="ctr"/>
           <a:lstStyle/>
           <a:p>
             <a:pPr indent="0" marL="0">
@@ -4989,8 +4989,8 @@
         </p:nvSpPr>
         <p:spPr>
           <a:xfrm>
-            <a:off x="7766666" y="5124437"/>
-            <a:ext cx="937258" cy="209549"/>
+            <a:off x="8357214" y="5124437"/>
+            <a:ext cx="784858" cy="209549"/>
           </a:xfrm>
           <a:prstGeom prst="roundRect">
             <a:avLst>
@@ -5024,7 +5024,7 @@
         </p:blipFill>
         <p:spPr>
           <a:xfrm>
-            <a:off x="7833340" y="5176825"/>
+            <a:off x="8423889" y="5176825"/>
             <a:ext cx="104775" cy="104775"/>
           </a:xfrm>
           <a:prstGeom prst="rect">
@@ -5040,17 +5040,17 @@
         </p:nvSpPr>
         <p:spPr>
           <a:xfrm>
-            <a:off x="7966690" y="5124437"/>
-            <a:ext cx="689608" cy="209549"/>
-          </a:xfrm>
-          <a:prstGeom prst="rect">
-            <a:avLst/>
-          </a:prstGeom>
-          <a:noFill/>
-          <a:ln/>
-        </p:spPr>
-        <p:txBody>
-          <a:bodyPr wrap="square" lIns="0" tIns="0" rIns="0" bIns="0" rtlCol="0" anchor="ctr"/>
+            <a:off x="8547714" y="5124437"/>
+            <a:ext cx="575309" cy="209549"/>
+          </a:xfrm>
+          <a:prstGeom prst="rect">
+            <a:avLst/>
+          </a:prstGeom>
+          <a:noFill/>
+          <a:ln/>
+        </p:spPr>
+        <p:txBody>
+          <a:bodyPr wrap="none" lIns="0" tIns="0" rIns="0" bIns="0" rtlCol="0" anchor="ctr"/>
           <a:lstStyle/>
           <a:p>
             <a:pPr indent="0" marL="0">
@@ -5079,8 +5079,8 @@
         </p:nvSpPr>
         <p:spPr>
           <a:xfrm>
-            <a:off x="8761073" y="5124437"/>
-            <a:ext cx="373379" cy="209549"/>
+            <a:off x="9199222" y="5124437"/>
+            <a:ext cx="441959" cy="209549"/>
           </a:xfrm>
           <a:prstGeom prst="roundRect">
             <a:avLst>
@@ -5106,7 +5106,7 @@
         </p:nvSpPr>
         <p:spPr>
           <a:xfrm>
-            <a:off x="8837273" y="5200637"/>
+            <a:off x="9275422" y="5200637"/>
             <a:ext cx="57150" cy="57150"/>
           </a:xfrm>
           <a:prstGeom prst="ellipse">
@@ -5131,17 +5131,17 @@
         </p:nvSpPr>
         <p:spPr>
           <a:xfrm>
-            <a:off x="8932523" y="5124437"/>
-            <a:ext cx="144780" cy="209549"/>
-          </a:xfrm>
-          <a:prstGeom prst="rect">
-            <a:avLst/>
-          </a:prstGeom>
-          <a:noFill/>
-          <a:ln/>
-        </p:spPr>
-        <p:txBody>
-          <a:bodyPr wrap="square" lIns="0" tIns="0" rIns="0" bIns="0" rtlCol="0" anchor="ctr"/>
+            <a:off x="9361147" y="5124437"/>
+            <a:ext cx="251459" cy="209549"/>
+          </a:xfrm>
+          <a:prstGeom prst="rect">
+            <a:avLst/>
+          </a:prstGeom>
+          <a:noFill/>
+          <a:ln/>
+        </p:spPr>
+        <p:txBody>
+          <a:bodyPr wrap="none" lIns="0" tIns="0" rIns="0" bIns="0" rtlCol="0" anchor="ctr"/>
           <a:lstStyle/>
           <a:p>
             <a:pPr indent="0" marL="0">
@@ -5170,8 +5170,8 @@
         </p:nvSpPr>
         <p:spPr>
           <a:xfrm>
-            <a:off x="9191602" y="5124437"/>
-            <a:ext cx="445769" cy="209549"/>
+            <a:off x="9698331" y="5124437"/>
+            <a:ext cx="539114" cy="209549"/>
           </a:xfrm>
           <a:prstGeom prst="roundRect">
             <a:avLst>
@@ -5197,7 +5197,7 @@
         </p:nvSpPr>
         <p:spPr>
           <a:xfrm>
-            <a:off x="9267802" y="5200637"/>
+            <a:off x="9774531" y="5200637"/>
             <a:ext cx="57150" cy="57150"/>
           </a:xfrm>
           <a:prstGeom prst="ellipse">
@@ -5222,17 +5222,17 @@
         </p:nvSpPr>
         <p:spPr>
           <a:xfrm>
-            <a:off x="9363052" y="5124437"/>
-            <a:ext cx="217169" cy="209549"/>
-          </a:xfrm>
-          <a:prstGeom prst="rect">
-            <a:avLst/>
-          </a:prstGeom>
-          <a:noFill/>
-          <a:ln/>
-        </p:spPr>
-        <p:txBody>
-          <a:bodyPr wrap="square" lIns="0" tIns="0" rIns="0" bIns="0" rtlCol="0" anchor="ctr"/>
+            <a:off x="9860255" y="5124437"/>
+            <a:ext cx="348614" cy="209549"/>
+          </a:xfrm>
+          <a:prstGeom prst="rect">
+            <a:avLst/>
+          </a:prstGeom>
+          <a:noFill/>
+          <a:ln/>
+        </p:spPr>
+        <p:txBody>
+          <a:bodyPr wrap="none" lIns="0" tIns="0" rIns="0" bIns="0" rtlCol="0" anchor="ctr"/>
           <a:lstStyle/>
           <a:p>
             <a:pPr indent="0" marL="0">
@@ -5261,8 +5261,8 @@
         </p:nvSpPr>
         <p:spPr>
           <a:xfrm>
-            <a:off x="9694521" y="5124437"/>
-            <a:ext cx="518159" cy="209549"/>
+            <a:off x="10294594" y="5124437"/>
+            <a:ext cx="636268" cy="209549"/>
           </a:xfrm>
           <a:prstGeom prst="roundRect">
             <a:avLst>
@@ -5288,7 +5288,7 @@
         </p:nvSpPr>
         <p:spPr>
           <a:xfrm>
-            <a:off x="9770721" y="5200637"/>
+            <a:off x="10370794" y="5200637"/>
             <a:ext cx="57150" cy="57150"/>
           </a:xfrm>
           <a:prstGeom prst="ellipse">
@@ -5313,17 +5313,17 @@
         </p:nvSpPr>
         <p:spPr>
           <a:xfrm>
-            <a:off x="9865970" y="5124437"/>
-            <a:ext cx="289559" cy="209549"/>
-          </a:xfrm>
-          <a:prstGeom prst="rect">
-            <a:avLst/>
-          </a:prstGeom>
-          <a:noFill/>
-          <a:ln/>
-        </p:spPr>
-        <p:txBody>
-          <a:bodyPr wrap="square" lIns="0" tIns="0" rIns="0" bIns="0" rtlCol="0" anchor="ctr"/>
+            <a:off x="10456519" y="5124437"/>
+            <a:ext cx="445769" cy="209549"/>
+          </a:xfrm>
+          <a:prstGeom prst="rect">
+            <a:avLst/>
+          </a:prstGeom>
+          <a:noFill/>
+          <a:ln/>
+        </p:spPr>
+        <p:txBody>
+          <a:bodyPr wrap="none" lIns="0" tIns="0" rIns="0" bIns="0" rtlCol="0" anchor="ctr"/>
           <a:lstStyle/>
           <a:p>
             <a:pPr indent="0" marL="0">
@@ -5352,8 +5352,8 @@
         </p:nvSpPr>
         <p:spPr>
           <a:xfrm>
-            <a:off x="10269829" y="5124437"/>
-            <a:ext cx="569594" cy="209549"/>
+            <a:off x="10988013" y="5124437"/>
+            <a:ext cx="624838" cy="209549"/>
           </a:xfrm>
           <a:prstGeom prst="rect">
             <a:avLst/>
@@ -5391,8 +5391,8 @@
         </p:nvSpPr>
         <p:spPr>
           <a:xfrm>
-            <a:off x="10877523" y="5124437"/>
-            <a:ext cx="720088" cy="209549"/>
+            <a:off x="533399" y="5391137"/>
+            <a:ext cx="887728" cy="209549"/>
           </a:xfrm>
           <a:prstGeom prst="roundRect">
             <a:avLst>
@@ -5426,7 +5426,7 @@
         </p:blipFill>
         <p:spPr>
           <a:xfrm>
-            <a:off x="10944198" y="5176825"/>
+            <a:off x="600073" y="5443524"/>
             <a:ext cx="104775" cy="104775"/>
           </a:xfrm>
           <a:prstGeom prst="rect">
@@ -5442,17 +5442,17 @@
         </p:nvSpPr>
         <p:spPr>
           <a:xfrm>
-            <a:off x="11077547" y="5124437"/>
-            <a:ext cx="472439" cy="209549"/>
-          </a:xfrm>
-          <a:prstGeom prst="rect">
-            <a:avLst/>
-          </a:prstGeom>
-          <a:noFill/>
-          <a:ln/>
-        </p:spPr>
-        <p:txBody>
-          <a:bodyPr wrap="square" lIns="0" tIns="0" rIns="0" bIns="0" rtlCol="0" anchor="ctr"/>
+            <a:off x="723898" y="5391137"/>
+            <a:ext cx="678178" cy="209549"/>
+          </a:xfrm>
+          <a:prstGeom prst="rect">
+            <a:avLst/>
+          </a:prstGeom>
+          <a:noFill/>
+          <a:ln/>
+        </p:spPr>
+        <p:txBody>
+          <a:bodyPr wrap="none" lIns="0" tIns="0" rIns="0" bIns="0" rtlCol="0" anchor="ctr"/>
           <a:lstStyle/>
           <a:p>
             <a:pPr indent="0" marL="0">
@@ -5481,8 +5481,8 @@
         </p:nvSpPr>
         <p:spPr>
           <a:xfrm>
-            <a:off x="533399" y="5391137"/>
-            <a:ext cx="373379" cy="209549"/>
+            <a:off x="1478276" y="5391137"/>
+            <a:ext cx="441959" cy="209549"/>
           </a:xfrm>
           <a:prstGeom prst="roundRect">
             <a:avLst>
@@ -5508,7 +5508,7 @@
         </p:nvSpPr>
         <p:spPr>
           <a:xfrm>
-            <a:off x="609598" y="5467336"/>
+            <a:off x="1554476" y="5467336"/>
             <a:ext cx="57150" cy="57150"/>
           </a:xfrm>
           <a:prstGeom prst="ellipse">
@@ -5533,17 +5533,17 @@
         </p:nvSpPr>
         <p:spPr>
           <a:xfrm>
-            <a:off x="704848" y="5391137"/>
-            <a:ext cx="144780" cy="209549"/>
-          </a:xfrm>
-          <a:prstGeom prst="rect">
-            <a:avLst/>
-          </a:prstGeom>
-          <a:noFill/>
-          <a:ln/>
-        </p:spPr>
-        <p:txBody>
-          <a:bodyPr wrap="square" lIns="0" tIns="0" rIns="0" bIns="0" rtlCol="0" anchor="ctr"/>
+            <a:off x="1640201" y="5391137"/>
+            <a:ext cx="251459" cy="209549"/>
+          </a:xfrm>
+          <a:prstGeom prst="rect">
+            <a:avLst/>
+          </a:prstGeom>
+          <a:noFill/>
+          <a:ln/>
+        </p:spPr>
+        <p:txBody>
+          <a:bodyPr wrap="none" lIns="0" tIns="0" rIns="0" bIns="0" rtlCol="0" anchor="ctr"/>
           <a:lstStyle/>
           <a:p>
             <a:pPr indent="0" marL="0">
@@ -5572,8 +5572,8 @@
         </p:nvSpPr>
         <p:spPr>
           <a:xfrm>
-            <a:off x="963928" y="5391137"/>
-            <a:ext cx="518159" cy="209549"/>
+            <a:off x="1977385" y="5391137"/>
+            <a:ext cx="548639" cy="209549"/>
           </a:xfrm>
           <a:prstGeom prst="roundRect">
             <a:avLst>
@@ -5599,7 +5599,7 @@
         </p:nvSpPr>
         <p:spPr>
           <a:xfrm>
-            <a:off x="1040127" y="5467336"/>
+            <a:off x="2053585" y="5467336"/>
             <a:ext cx="57150" cy="57150"/>
           </a:xfrm>
           <a:prstGeom prst="ellipse">
@@ -5624,17 +5624,17 @@
         </p:nvSpPr>
         <p:spPr>
           <a:xfrm>
-            <a:off x="1135377" y="5391137"/>
-            <a:ext cx="289559" cy="209549"/>
-          </a:xfrm>
-          <a:prstGeom prst="rect">
-            <a:avLst/>
-          </a:prstGeom>
-          <a:noFill/>
-          <a:ln/>
-        </p:spPr>
-        <p:txBody>
-          <a:bodyPr wrap="square" lIns="0" tIns="0" rIns="0" bIns="0" rtlCol="0" anchor="ctr"/>
+            <a:off x="2139310" y="5391137"/>
+            <a:ext cx="358139" cy="209549"/>
+          </a:xfrm>
+          <a:prstGeom prst="rect">
+            <a:avLst/>
+          </a:prstGeom>
+          <a:noFill/>
+          <a:ln/>
+        </p:spPr>
+        <p:txBody>
+          <a:bodyPr wrap="none" lIns="0" tIns="0" rIns="0" bIns="0" rtlCol="0" anchor="ctr"/>
           <a:lstStyle/>
           <a:p>
             <a:pPr indent="0" marL="0">
@@ -5663,8 +5663,8 @@
         </p:nvSpPr>
         <p:spPr>
           <a:xfrm>
-            <a:off x="1539236" y="5391137"/>
-            <a:ext cx="518159" cy="209549"/>
+            <a:off x="2583174" y="5391137"/>
+            <a:ext cx="548639" cy="209549"/>
           </a:xfrm>
           <a:prstGeom prst="roundRect">
             <a:avLst>
@@ -5690,7 +5690,7 @@
         </p:nvSpPr>
         <p:spPr>
           <a:xfrm>
-            <a:off x="1615436" y="5467336"/>
+            <a:off x="2659373" y="5467336"/>
             <a:ext cx="57150" cy="57150"/>
           </a:xfrm>
           <a:prstGeom prst="ellipse">
@@ -5715,17 +5715,17 @@
         </p:nvSpPr>
         <p:spPr>
           <a:xfrm>
-            <a:off x="1710686" y="5391137"/>
-            <a:ext cx="289559" cy="209549"/>
-          </a:xfrm>
-          <a:prstGeom prst="rect">
-            <a:avLst/>
-          </a:prstGeom>
-          <a:noFill/>
-          <a:ln/>
-        </p:spPr>
-        <p:txBody>
-          <a:bodyPr wrap="square" lIns="0" tIns="0" rIns="0" bIns="0" rtlCol="0" anchor="ctr"/>
+            <a:off x="2745098" y="5391137"/>
+            <a:ext cx="358139" cy="209549"/>
+          </a:xfrm>
+          <a:prstGeom prst="rect">
+            <a:avLst/>
+          </a:prstGeom>
+          <a:noFill/>
+          <a:ln/>
+        </p:spPr>
+        <p:txBody>
+          <a:bodyPr wrap="none" lIns="0" tIns="0" rIns="0" bIns="0" rtlCol="0" anchor="ctr"/>
           <a:lstStyle/>
           <a:p>
             <a:pPr indent="0" marL="0">
@@ -5754,8 +5754,8 @@
         </p:nvSpPr>
         <p:spPr>
           <a:xfrm>
-            <a:off x="2114545" y="5391137"/>
-            <a:ext cx="518159" cy="209549"/>
+            <a:off x="3188962" y="5391137"/>
+            <a:ext cx="636268" cy="209549"/>
           </a:xfrm>
           <a:prstGeom prst="roundRect">
             <a:avLst>
@@ -5781,7 +5781,7 @@
         </p:nvSpPr>
         <p:spPr>
           <a:xfrm>
-            <a:off x="2190745" y="5467336"/>
+            <a:off x="3265162" y="5467336"/>
             <a:ext cx="57150" cy="57150"/>
           </a:xfrm>
           <a:prstGeom prst="ellipse">
@@ -5806,17 +5806,17 @@
         </p:nvSpPr>
         <p:spPr>
           <a:xfrm>
-            <a:off x="2285994" y="5391137"/>
-            <a:ext cx="289559" cy="209549"/>
-          </a:xfrm>
-          <a:prstGeom prst="rect">
-            <a:avLst/>
-          </a:prstGeom>
-          <a:noFill/>
-          <a:ln/>
-        </p:spPr>
-        <p:txBody>
-          <a:bodyPr wrap="square" lIns="0" tIns="0" rIns="0" bIns="0" rtlCol="0" anchor="ctr"/>
+            <a:off x="3350887" y="5391137"/>
+            <a:ext cx="445769" cy="209549"/>
+          </a:xfrm>
+          <a:prstGeom prst="rect">
+            <a:avLst/>
+          </a:prstGeom>
+          <a:noFill/>
+          <a:ln/>
+        </p:spPr>
+        <p:txBody>
+          <a:bodyPr wrap="none" lIns="0" tIns="0" rIns="0" bIns="0" rtlCol="0" anchor="ctr"/>
           <a:lstStyle/>
           <a:p>
             <a:pPr indent="0" marL="0">
@@ -5845,8 +5845,8 @@
         </p:nvSpPr>
         <p:spPr>
           <a:xfrm>
-            <a:off x="2689853" y="5391137"/>
-            <a:ext cx="662938" cy="209549"/>
+            <a:off x="3882380" y="5391137"/>
+            <a:ext cx="742948" cy="209549"/>
           </a:xfrm>
           <a:prstGeom prst="roundRect">
             <a:avLst>
@@ -5872,7 +5872,7 @@
         </p:nvSpPr>
         <p:spPr>
           <a:xfrm>
-            <a:off x="2766053" y="5467336"/>
+            <a:off x="3958580" y="5467336"/>
             <a:ext cx="57150" cy="57150"/>
           </a:xfrm>
           <a:prstGeom prst="ellipse">
@@ -5897,17 +5897,17 @@
         </p:nvSpPr>
         <p:spPr>
           <a:xfrm>
-            <a:off x="2861303" y="5391137"/>
-            <a:ext cx="434339" cy="209549"/>
-          </a:xfrm>
-          <a:prstGeom prst="rect">
-            <a:avLst/>
-          </a:prstGeom>
-          <a:noFill/>
-          <a:ln/>
-        </p:spPr>
-        <p:txBody>
-          <a:bodyPr wrap="square" lIns="0" tIns="0" rIns="0" bIns="0" rtlCol="0" anchor="ctr"/>
+            <a:off x="4044305" y="5391137"/>
+            <a:ext cx="552449" cy="209549"/>
+          </a:xfrm>
+          <a:prstGeom prst="rect">
+            <a:avLst/>
+          </a:prstGeom>
+          <a:noFill/>
+          <a:ln/>
+        </p:spPr>
+        <p:txBody>
+          <a:bodyPr wrap="none" lIns="0" tIns="0" rIns="0" bIns="0" rtlCol="0" anchor="ctr"/>
           <a:lstStyle/>
           <a:p>
             <a:pPr indent="0" marL="0">
@@ -5936,8 +5936,8 @@
         </p:nvSpPr>
         <p:spPr>
           <a:xfrm>
-            <a:off x="3409941" y="5391137"/>
-            <a:ext cx="1097277" cy="209549"/>
+            <a:off x="4682478" y="5391137"/>
+            <a:ext cx="1238247" cy="209549"/>
           </a:xfrm>
           <a:prstGeom prst="roundRect">
             <a:avLst>
@@ -5963,7 +5963,7 @@
         </p:nvSpPr>
         <p:spPr>
           <a:xfrm>
-            <a:off x="3486141" y="5467336"/>
+            <a:off x="4758678" y="5467336"/>
             <a:ext cx="57150" cy="57150"/>
           </a:xfrm>
           <a:prstGeom prst="ellipse">
@@ -5988,17 +5988,17 @@
         </p:nvSpPr>
         <p:spPr>
           <a:xfrm>
-            <a:off x="3581391" y="5391137"/>
-            <a:ext cx="868678" cy="209549"/>
-          </a:xfrm>
-          <a:prstGeom prst="rect">
-            <a:avLst/>
-          </a:prstGeom>
-          <a:noFill/>
-          <a:ln/>
-        </p:spPr>
-        <p:txBody>
-          <a:bodyPr wrap="square" lIns="0" tIns="0" rIns="0" bIns="0" rtlCol="0" anchor="ctr"/>
+            <a:off x="4844403" y="5391137"/>
+            <a:ext cx="1047747" cy="209549"/>
+          </a:xfrm>
+          <a:prstGeom prst="rect">
+            <a:avLst/>
+          </a:prstGeom>
+          <a:noFill/>
+          <a:ln/>
+        </p:spPr>
+        <p:txBody>
+          <a:bodyPr wrap="none" lIns="0" tIns="0" rIns="0" bIns="0" rtlCol="0" anchor="ctr"/>
           <a:lstStyle/>
           <a:p>
             <a:pPr indent="0" marL="0">
@@ -18366,8 +18366,8 @@
         </p:nvSpPr>
         <p:spPr>
           <a:xfrm>
-            <a:off x="685798" y="2266944"/>
-            <a:ext cx="720088" cy="209549"/>
+            <a:off x="666748" y="2266944"/>
+            <a:ext cx="887728" cy="209549"/>
           </a:xfrm>
           <a:prstGeom prst="roundRect">
             <a:avLst>
@@ -18401,7 +18401,7 @@
         </p:blipFill>
         <p:spPr>
           <a:xfrm>
-            <a:off x="752473" y="2319332"/>
+            <a:off x="733423" y="2319332"/>
             <a:ext cx="104775" cy="104775"/>
           </a:xfrm>
           <a:prstGeom prst="rect">
@@ -18417,17 +18417,17 @@
         </p:nvSpPr>
         <p:spPr>
           <a:xfrm>
-            <a:off x="885823" y="2266944"/>
-            <a:ext cx="472439" cy="209549"/>
-          </a:xfrm>
-          <a:prstGeom prst="rect">
-            <a:avLst/>
-          </a:prstGeom>
-          <a:noFill/>
-          <a:ln/>
-        </p:spPr>
-        <p:txBody>
-          <a:bodyPr wrap="square" lIns="0" tIns="0" rIns="0" bIns="0" rtlCol="0" anchor="ctr"/>
+            <a:off x="857248" y="2266944"/>
+            <a:ext cx="678178" cy="209549"/>
+          </a:xfrm>
+          <a:prstGeom prst="rect">
+            <a:avLst/>
+          </a:prstGeom>
+          <a:noFill/>
+          <a:ln/>
+        </p:spPr>
+        <p:txBody>
+          <a:bodyPr wrap="none" lIns="0" tIns="0" rIns="0" bIns="0" rtlCol="0" anchor="ctr"/>
           <a:lstStyle/>
           <a:p>
             <a:pPr indent="0" marL="0">
@@ -18456,8 +18456,8 @@
         </p:nvSpPr>
         <p:spPr>
           <a:xfrm>
-            <a:off x="1463036" y="2266944"/>
-            <a:ext cx="373379" cy="209549"/>
+            <a:off x="1611626" y="2266944"/>
+            <a:ext cx="441959" cy="209549"/>
           </a:xfrm>
           <a:prstGeom prst="roundRect">
             <a:avLst>
@@ -18483,7 +18483,7 @@
         </p:nvSpPr>
         <p:spPr>
           <a:xfrm>
-            <a:off x="1539236" y="2343144"/>
+            <a:off x="1687826" y="2343144"/>
             <a:ext cx="57150" cy="57150"/>
           </a:xfrm>
           <a:prstGeom prst="ellipse">
@@ -18508,17 +18508,17 @@
         </p:nvSpPr>
         <p:spPr>
           <a:xfrm>
-            <a:off x="1634486" y="2266944"/>
-            <a:ext cx="144780" cy="209549"/>
-          </a:xfrm>
-          <a:prstGeom prst="rect">
-            <a:avLst/>
-          </a:prstGeom>
-          <a:noFill/>
-          <a:ln/>
-        </p:spPr>
-        <p:txBody>
-          <a:bodyPr wrap="square" lIns="0" tIns="0" rIns="0" bIns="0" rtlCol="0" anchor="ctr"/>
+            <a:off x="1773551" y="2266944"/>
+            <a:ext cx="251459" cy="209549"/>
+          </a:xfrm>
+          <a:prstGeom prst="rect">
+            <a:avLst/>
+          </a:prstGeom>
+          <a:noFill/>
+          <a:ln/>
+        </p:spPr>
+        <p:txBody>
+          <a:bodyPr wrap="none" lIns="0" tIns="0" rIns="0" bIns="0" rtlCol="0" anchor="ctr"/>
           <a:lstStyle/>
           <a:p>
             <a:pPr indent="0" marL="0">
@@ -18547,8 +18547,8 @@
         </p:nvSpPr>
         <p:spPr>
           <a:xfrm>
-            <a:off x="1893565" y="2266944"/>
-            <a:ext cx="518159" cy="209549"/>
+            <a:off x="2110735" y="2266944"/>
+            <a:ext cx="548639" cy="209549"/>
           </a:xfrm>
           <a:prstGeom prst="roundRect">
             <a:avLst>
@@ -18574,7 +18574,7 @@
         </p:nvSpPr>
         <p:spPr>
           <a:xfrm>
-            <a:off x="1969765" y="2343144"/>
+            <a:off x="2186935" y="2343144"/>
             <a:ext cx="57150" cy="57150"/>
           </a:xfrm>
           <a:prstGeom prst="ellipse">
@@ -18599,17 +18599,17 @@
         </p:nvSpPr>
         <p:spPr>
           <a:xfrm>
-            <a:off x="2065015" y="2266944"/>
-            <a:ext cx="289559" cy="209549"/>
-          </a:xfrm>
-          <a:prstGeom prst="rect">
-            <a:avLst/>
-          </a:prstGeom>
-          <a:noFill/>
-          <a:ln/>
-        </p:spPr>
-        <p:txBody>
-          <a:bodyPr wrap="square" lIns="0" tIns="0" rIns="0" bIns="0" rtlCol="0" anchor="ctr"/>
+            <a:off x="2272659" y="2266944"/>
+            <a:ext cx="358139" cy="209549"/>
+          </a:xfrm>
+          <a:prstGeom prst="rect">
+            <a:avLst/>
+          </a:prstGeom>
+          <a:noFill/>
+          <a:ln/>
+        </p:spPr>
+        <p:txBody>
+          <a:bodyPr wrap="none" lIns="0" tIns="0" rIns="0" bIns="0" rtlCol="0" anchor="ctr"/>
           <a:lstStyle/>
           <a:p>
             <a:pPr indent="0" marL="0">
@@ -18638,8 +18638,8 @@
         </p:nvSpPr>
         <p:spPr>
           <a:xfrm>
-            <a:off x="2468874" y="2266944"/>
-            <a:ext cx="518159" cy="209549"/>
+            <a:off x="2716523" y="2266944"/>
+            <a:ext cx="548639" cy="209549"/>
           </a:xfrm>
           <a:prstGeom prst="roundRect">
             <a:avLst>
@@ -18665,7 +18665,7 @@
         </p:nvSpPr>
         <p:spPr>
           <a:xfrm>
-            <a:off x="2545074" y="2343144"/>
+            <a:off x="2792723" y="2343144"/>
             <a:ext cx="57150" cy="57150"/>
           </a:xfrm>
           <a:prstGeom prst="ellipse">
@@ -18690,17 +18690,17 @@
         </p:nvSpPr>
         <p:spPr>
           <a:xfrm>
-            <a:off x="2640323" y="2266944"/>
-            <a:ext cx="289559" cy="209549"/>
-          </a:xfrm>
-          <a:prstGeom prst="rect">
-            <a:avLst/>
-          </a:prstGeom>
-          <a:noFill/>
-          <a:ln/>
-        </p:spPr>
-        <p:txBody>
-          <a:bodyPr wrap="square" lIns="0" tIns="0" rIns="0" bIns="0" rtlCol="0" anchor="ctr"/>
+            <a:off x="2878448" y="2266944"/>
+            <a:ext cx="358139" cy="209549"/>
+          </a:xfrm>
+          <a:prstGeom prst="rect">
+            <a:avLst/>
+          </a:prstGeom>
+          <a:noFill/>
+          <a:ln/>
+        </p:spPr>
+        <p:txBody>
+          <a:bodyPr wrap="none" lIns="0" tIns="0" rIns="0" bIns="0" rtlCol="0" anchor="ctr"/>
           <a:lstStyle/>
           <a:p>
             <a:pPr indent="0" marL="0">
@@ -18729,8 +18729,8 @@
         </p:nvSpPr>
         <p:spPr>
           <a:xfrm>
-            <a:off x="3044182" y="2266944"/>
-            <a:ext cx="518159" cy="209549"/>
+            <a:off x="3322312" y="2266944"/>
+            <a:ext cx="636268" cy="209549"/>
           </a:xfrm>
           <a:prstGeom prst="roundRect">
             <a:avLst>
@@ -18756,7 +18756,7 @@
         </p:nvSpPr>
         <p:spPr>
           <a:xfrm>
-            <a:off x="3120382" y="2343144"/>
+            <a:off x="3398512" y="2343144"/>
             <a:ext cx="57150" cy="57150"/>
           </a:xfrm>
           <a:prstGeom prst="ellipse">
@@ -18781,17 +18781,17 @@
         </p:nvSpPr>
         <p:spPr>
           <a:xfrm>
-            <a:off x="3215632" y="2266944"/>
-            <a:ext cx="289559" cy="209549"/>
-          </a:xfrm>
-          <a:prstGeom prst="rect">
-            <a:avLst/>
-          </a:prstGeom>
-          <a:noFill/>
-          <a:ln/>
-        </p:spPr>
-        <p:txBody>
-          <a:bodyPr wrap="square" lIns="0" tIns="0" rIns="0" bIns="0" rtlCol="0" anchor="ctr"/>
+            <a:off x="3484236" y="2266944"/>
+            <a:ext cx="445769" cy="209549"/>
+          </a:xfrm>
+          <a:prstGeom prst="rect">
+            <a:avLst/>
+          </a:prstGeom>
+          <a:noFill/>
+          <a:ln/>
+        </p:spPr>
+        <p:txBody>
+          <a:bodyPr wrap="none" lIns="0" tIns="0" rIns="0" bIns="0" rtlCol="0" anchor="ctr"/>
           <a:lstStyle/>
           <a:p>
             <a:pPr indent="0" marL="0">
@@ -18820,8 +18820,8 @@
         </p:nvSpPr>
         <p:spPr>
           <a:xfrm>
-            <a:off x="685798" y="2533644"/>
-            <a:ext cx="662938" cy="209549"/>
+            <a:off x="666748" y="2533644"/>
+            <a:ext cx="742948" cy="209549"/>
           </a:xfrm>
           <a:prstGeom prst="roundRect">
             <a:avLst>
@@ -18847,7 +18847,7 @@
         </p:nvSpPr>
         <p:spPr>
           <a:xfrm>
-            <a:off x="761998" y="2609843"/>
+            <a:off x="742948" y="2609843"/>
             <a:ext cx="57150" cy="57150"/>
           </a:xfrm>
           <a:prstGeom prst="ellipse">
@@ -18872,17 +18872,17 @@
         </p:nvSpPr>
         <p:spPr>
           <a:xfrm>
-            <a:off x="857248" y="2533644"/>
-            <a:ext cx="434339" cy="209549"/>
-          </a:xfrm>
-          <a:prstGeom prst="rect">
-            <a:avLst/>
-          </a:prstGeom>
-          <a:noFill/>
-          <a:ln/>
-        </p:spPr>
-        <p:txBody>
-          <a:bodyPr wrap="square" lIns="0" tIns="0" rIns="0" bIns="0" rtlCol="0" anchor="ctr"/>
+            <a:off x="828673" y="2533644"/>
+            <a:ext cx="552449" cy="209549"/>
+          </a:xfrm>
+          <a:prstGeom prst="rect">
+            <a:avLst/>
+          </a:prstGeom>
+          <a:noFill/>
+          <a:ln/>
+        </p:spPr>
+        <p:txBody>
+          <a:bodyPr wrap="none" lIns="0" tIns="0" rIns="0" bIns="0" rtlCol="0" anchor="ctr"/>
           <a:lstStyle/>
           <a:p>
             <a:pPr indent="0" marL="0">
@@ -18911,8 +18911,8 @@
         </p:nvSpPr>
         <p:spPr>
           <a:xfrm>
-            <a:off x="1405886" y="2533644"/>
-            <a:ext cx="1097277" cy="209549"/>
+            <a:off x="1466846" y="2533644"/>
+            <a:ext cx="1238247" cy="209549"/>
           </a:xfrm>
           <a:prstGeom prst="roundRect">
             <a:avLst>
@@ -18938,7 +18938,7 @@
         </p:nvSpPr>
         <p:spPr>
           <a:xfrm>
-            <a:off x="1482086" y="2609843"/>
+            <a:off x="1543046" y="2609843"/>
             <a:ext cx="57150" cy="57150"/>
           </a:xfrm>
           <a:prstGeom prst="ellipse">
@@ -18963,17 +18963,17 @@
         </p:nvSpPr>
         <p:spPr>
           <a:xfrm>
-            <a:off x="1577336" y="2533644"/>
-            <a:ext cx="868678" cy="209549"/>
-          </a:xfrm>
-          <a:prstGeom prst="rect">
-            <a:avLst/>
-          </a:prstGeom>
-          <a:noFill/>
-          <a:ln/>
-        </p:spPr>
-        <p:txBody>
-          <a:bodyPr wrap="square" lIns="0" tIns="0" rIns="0" bIns="0" rtlCol="0" anchor="ctr"/>
+            <a:off x="1628771" y="2533644"/>
+            <a:ext cx="1047747" cy="209549"/>
+          </a:xfrm>
+          <a:prstGeom prst="rect">
+            <a:avLst/>
+          </a:prstGeom>
+          <a:noFill/>
+          <a:ln/>
+        </p:spPr>
+        <p:txBody>
+          <a:bodyPr wrap="none" lIns="0" tIns="0" rIns="0" bIns="0" rtlCol="0" anchor="ctr"/>
           <a:lstStyle/>
           <a:p>
             <a:pPr indent="0" marL="0">
@@ -19464,8 +19464,8 @@
         </p:nvSpPr>
         <p:spPr>
           <a:xfrm>
-            <a:off x="685798" y="4076690"/>
-            <a:ext cx="720088" cy="209549"/>
+            <a:off x="666748" y="4076690"/>
+            <a:ext cx="843913" cy="209549"/>
           </a:xfrm>
           <a:prstGeom prst="roundRect">
             <a:avLst>
@@ -19499,7 +19499,7 @@
         </p:blipFill>
         <p:spPr>
           <a:xfrm>
-            <a:off x="752473" y="4129077"/>
+            <a:off x="733423" y="4129077"/>
             <a:ext cx="104775" cy="104775"/>
           </a:xfrm>
           <a:prstGeom prst="rect">
@@ -19515,17 +19515,17 @@
         </p:nvSpPr>
         <p:spPr>
           <a:xfrm>
-            <a:off x="885823" y="4076690"/>
-            <a:ext cx="472439" cy="209549"/>
-          </a:xfrm>
-          <a:prstGeom prst="rect">
-            <a:avLst/>
-          </a:prstGeom>
-          <a:noFill/>
-          <a:ln/>
-        </p:spPr>
-        <p:txBody>
-          <a:bodyPr wrap="square" lIns="0" tIns="0" rIns="0" bIns="0" rtlCol="0" anchor="ctr"/>
+            <a:off x="857248" y="4076690"/>
+            <a:ext cx="634363" cy="209549"/>
+          </a:xfrm>
+          <a:prstGeom prst="rect">
+            <a:avLst/>
+          </a:prstGeom>
+          <a:noFill/>
+          <a:ln/>
+        </p:spPr>
+        <p:txBody>
+          <a:bodyPr wrap="none" lIns="0" tIns="0" rIns="0" bIns="0" rtlCol="0" anchor="ctr"/>
           <a:lstStyle/>
           <a:p>
             <a:pPr indent="0" marL="0">
@@ -19554,8 +19554,8 @@
         </p:nvSpPr>
         <p:spPr>
           <a:xfrm>
-            <a:off x="1463036" y="4076690"/>
-            <a:ext cx="445769" cy="209549"/>
+            <a:off x="1567811" y="4076690"/>
+            <a:ext cx="407669" cy="209549"/>
           </a:xfrm>
           <a:prstGeom prst="roundRect">
             <a:avLst>
@@ -19581,7 +19581,7 @@
         </p:nvSpPr>
         <p:spPr>
           <a:xfrm>
-            <a:off x="1539236" y="4152890"/>
+            <a:off x="1644011" y="4152890"/>
             <a:ext cx="57150" cy="57150"/>
           </a:xfrm>
           <a:prstGeom prst="ellipse">
@@ -19606,7 +19606,7 @@
         </p:nvSpPr>
         <p:spPr>
           <a:xfrm>
-            <a:off x="1634486" y="4076690"/>
+            <a:off x="1729736" y="4076690"/>
             <a:ext cx="217169" cy="209549"/>
           </a:xfrm>
           <a:prstGeom prst="rect">
@@ -19616,7 +19616,7 @@
           <a:ln/>
         </p:spPr>
         <p:txBody>
-          <a:bodyPr wrap="square" lIns="0" tIns="0" rIns="0" bIns="0" rtlCol="0" anchor="ctr"/>
+          <a:bodyPr wrap="none" lIns="0" tIns="0" rIns="0" bIns="0" rtlCol="0" anchor="ctr"/>
           <a:lstStyle/>
           <a:p>
             <a:pPr indent="0" marL="0">
@@ -19645,8 +19645,8 @@
         </p:nvSpPr>
         <p:spPr>
           <a:xfrm>
-            <a:off x="1965955" y="4076690"/>
-            <a:ext cx="518159" cy="209549"/>
+            <a:off x="2032630" y="4076690"/>
+            <a:ext cx="461009" cy="209549"/>
           </a:xfrm>
           <a:prstGeom prst="roundRect">
             <a:avLst>
@@ -19672,7 +19672,7 @@
         </p:nvSpPr>
         <p:spPr>
           <a:xfrm>
-            <a:off x="2042155" y="4152890"/>
+            <a:off x="2108830" y="4152890"/>
             <a:ext cx="57150" cy="57150"/>
           </a:xfrm>
           <a:prstGeom prst="ellipse">
@@ -19697,17 +19697,17 @@
         </p:nvSpPr>
         <p:spPr>
           <a:xfrm>
-            <a:off x="2137405" y="4076690"/>
-            <a:ext cx="289559" cy="209549"/>
-          </a:xfrm>
-          <a:prstGeom prst="rect">
-            <a:avLst/>
-          </a:prstGeom>
-          <a:noFill/>
-          <a:ln/>
-        </p:spPr>
-        <p:txBody>
-          <a:bodyPr wrap="square" lIns="0" tIns="0" rIns="0" bIns="0" rtlCol="0" anchor="ctr"/>
+            <a:off x="2194555" y="4076690"/>
+            <a:ext cx="270509" cy="209549"/>
+          </a:xfrm>
+          <a:prstGeom prst="rect">
+            <a:avLst/>
+          </a:prstGeom>
+          <a:noFill/>
+          <a:ln/>
+        </p:spPr>
+        <p:txBody>
+          <a:bodyPr wrap="none" lIns="0" tIns="0" rIns="0" bIns="0" rtlCol="0" anchor="ctr"/>
           <a:lstStyle/>
           <a:p>
             <a:pPr indent="0" marL="0">
@@ -19736,8 +19736,8 @@
         </p:nvSpPr>
         <p:spPr>
           <a:xfrm>
-            <a:off x="2541264" y="4076690"/>
-            <a:ext cx="662938" cy="209549"/>
+            <a:off x="2550789" y="4076690"/>
+            <a:ext cx="830578" cy="209549"/>
           </a:xfrm>
           <a:prstGeom prst="roundRect">
             <a:avLst>
@@ -19763,7 +19763,7 @@
         </p:nvSpPr>
         <p:spPr>
           <a:xfrm>
-            <a:off x="2617463" y="4152890"/>
+            <a:off x="2626988" y="4152890"/>
             <a:ext cx="57150" cy="57150"/>
           </a:xfrm>
           <a:prstGeom prst="ellipse">
@@ -19789,16 +19789,16 @@
         <p:spPr>
           <a:xfrm>
             <a:off x="2712713" y="4076690"/>
-            <a:ext cx="434339" cy="209549"/>
-          </a:xfrm>
-          <a:prstGeom prst="rect">
-            <a:avLst/>
-          </a:prstGeom>
-          <a:noFill/>
-          <a:ln/>
-        </p:spPr>
-        <p:txBody>
-          <a:bodyPr wrap="square" lIns="0" tIns="0" rIns="0" bIns="0" rtlCol="0" anchor="ctr"/>
+            <a:ext cx="640078" cy="209549"/>
+          </a:xfrm>
+          <a:prstGeom prst="rect">
+            <a:avLst/>
+          </a:prstGeom>
+          <a:noFill/>
+          <a:ln/>
+        </p:spPr>
+        <p:txBody>
+          <a:bodyPr wrap="none" lIns="0" tIns="0" rIns="0" bIns="0" rtlCol="0" anchor="ctr"/>
           <a:lstStyle/>
           <a:p>
             <a:pPr indent="0" marL="0">
@@ -19827,8 +19827,8 @@
         </p:nvSpPr>
         <p:spPr>
           <a:xfrm>
-            <a:off x="3261352" y="4076690"/>
-            <a:ext cx="590549" cy="209549"/>
+            <a:off x="666748" y="4343389"/>
+            <a:ext cx="733423" cy="209549"/>
           </a:xfrm>
           <a:prstGeom prst="roundRect">
             <a:avLst>
@@ -19854,7 +19854,7 @@
         </p:nvSpPr>
         <p:spPr>
           <a:xfrm>
-            <a:off x="3337552" y="4152890"/>
+            <a:off x="742948" y="4419589"/>
             <a:ext cx="57150" cy="57150"/>
           </a:xfrm>
           <a:prstGeom prst="ellipse">
@@ -19879,17 +19879,17 @@
         </p:nvSpPr>
         <p:spPr>
           <a:xfrm>
-            <a:off x="3432801" y="4076690"/>
-            <a:ext cx="361949" cy="209549"/>
-          </a:xfrm>
-          <a:prstGeom prst="rect">
-            <a:avLst/>
-          </a:prstGeom>
-          <a:noFill/>
-          <a:ln/>
-        </p:spPr>
-        <p:txBody>
-          <a:bodyPr wrap="square" lIns="0" tIns="0" rIns="0" bIns="0" rtlCol="0" anchor="ctr"/>
+            <a:off x="828673" y="4343389"/>
+            <a:ext cx="542924" cy="209549"/>
+          </a:xfrm>
+          <a:prstGeom prst="rect">
+            <a:avLst/>
+          </a:prstGeom>
+          <a:noFill/>
+          <a:ln/>
+        </p:spPr>
+        <p:txBody>
+          <a:bodyPr wrap="none" lIns="0" tIns="0" rIns="0" bIns="0" rtlCol="0" anchor="ctr"/>
           <a:lstStyle/>
           <a:p>
             <a:pPr indent="0" marL="0">
@@ -19918,8 +19918,8 @@
         </p:nvSpPr>
         <p:spPr>
           <a:xfrm>
-            <a:off x="685798" y="4343389"/>
-            <a:ext cx="1009647" cy="209549"/>
+            <a:off x="1457321" y="4343389"/>
+            <a:ext cx="838198" cy="209549"/>
           </a:xfrm>
           <a:prstGeom prst="roundRect">
             <a:avLst>
@@ -19953,7 +19953,7 @@
         </p:blipFill>
         <p:spPr>
           <a:xfrm>
-            <a:off x="752473" y="4395777"/>
+            <a:off x="1523996" y="4395777"/>
             <a:ext cx="104775" cy="104775"/>
           </a:xfrm>
           <a:prstGeom prst="rect">
@@ -19969,17 +19969,17 @@
         </p:nvSpPr>
         <p:spPr>
           <a:xfrm>
-            <a:off x="885823" y="4343389"/>
-            <a:ext cx="761998" cy="209549"/>
-          </a:xfrm>
-          <a:prstGeom prst="rect">
-            <a:avLst/>
-          </a:prstGeom>
-          <a:noFill/>
-          <a:ln/>
-        </p:spPr>
-        <p:txBody>
-          <a:bodyPr wrap="square" lIns="0" tIns="0" rIns="0" bIns="0" rtlCol="0" anchor="ctr"/>
+            <a:off x="1647821" y="4343389"/>
+            <a:ext cx="628648" cy="209549"/>
+          </a:xfrm>
+          <a:prstGeom prst="rect">
+            <a:avLst/>
+          </a:prstGeom>
+          <a:noFill/>
+          <a:ln/>
+        </p:spPr>
+        <p:txBody>
+          <a:bodyPr wrap="none" lIns="0" tIns="0" rIns="0" bIns="0" rtlCol="0" anchor="ctr"/>
           <a:lstStyle/>
           <a:p>
             <a:pPr indent="0" marL="0">
@@ -20008,8 +20008,8 @@
         </p:nvSpPr>
         <p:spPr>
           <a:xfrm>
-            <a:off x="1752596" y="4343389"/>
-            <a:ext cx="430529" cy="209549"/>
+            <a:off x="2352669" y="4343389"/>
+            <a:ext cx="499109" cy="209549"/>
           </a:xfrm>
           <a:prstGeom prst="roundRect">
             <a:avLst>
@@ -20043,7 +20043,7 @@
         </p:blipFill>
         <p:spPr>
           <a:xfrm>
-            <a:off x="1819270" y="4395777"/>
+            <a:off x="2419344" y="4395777"/>
             <a:ext cx="104775" cy="104775"/>
           </a:xfrm>
           <a:prstGeom prst="rect">
@@ -20059,17 +20059,17 @@
         </p:nvSpPr>
         <p:spPr>
           <a:xfrm>
-            <a:off x="1952620" y="4343389"/>
-            <a:ext cx="182880" cy="209549"/>
-          </a:xfrm>
-          <a:prstGeom prst="rect">
-            <a:avLst/>
-          </a:prstGeom>
-          <a:noFill/>
-          <a:ln/>
-        </p:spPr>
-        <p:txBody>
-          <a:bodyPr wrap="square" lIns="0" tIns="0" rIns="0" bIns="0" rtlCol="0" anchor="ctr"/>
+            <a:off x="2543169" y="4343389"/>
+            <a:ext cx="289559" cy="209549"/>
+          </a:xfrm>
+          <a:prstGeom prst="rect">
+            <a:avLst/>
+          </a:prstGeom>
+          <a:noFill/>
+          <a:ln/>
+        </p:spPr>
+        <p:txBody>
+          <a:bodyPr wrap="none" lIns="0" tIns="0" rIns="0" bIns="0" rtlCol="0" anchor="ctr"/>
           <a:lstStyle/>
           <a:p>
             <a:pPr indent="0" marL="0">
@@ -20098,8 +20098,8 @@
         </p:nvSpPr>
         <p:spPr>
           <a:xfrm>
-            <a:off x="2240274" y="4343389"/>
-            <a:ext cx="430529" cy="209549"/>
+            <a:off x="2908928" y="4343389"/>
+            <a:ext cx="499109" cy="209549"/>
           </a:xfrm>
           <a:prstGeom prst="roundRect">
             <a:avLst>
@@ -20133,7 +20133,7 @@
         </p:blipFill>
         <p:spPr>
           <a:xfrm>
-            <a:off x="2306949" y="4395777"/>
+            <a:off x="2975603" y="4395777"/>
             <a:ext cx="104775" cy="104775"/>
           </a:xfrm>
           <a:prstGeom prst="rect">
@@ -20149,17 +20149,17 @@
         </p:nvSpPr>
         <p:spPr>
           <a:xfrm>
-            <a:off x="2440299" y="4343389"/>
-            <a:ext cx="182880" cy="209549"/>
-          </a:xfrm>
-          <a:prstGeom prst="rect">
-            <a:avLst/>
-          </a:prstGeom>
-          <a:noFill/>
-          <a:ln/>
-        </p:spPr>
-        <p:txBody>
-          <a:bodyPr wrap="square" lIns="0" tIns="0" rIns="0" bIns="0" rtlCol="0" anchor="ctr"/>
+            <a:off x="3099427" y="4343389"/>
+            <a:ext cx="289559" cy="209549"/>
+          </a:xfrm>
+          <a:prstGeom prst="rect">
+            <a:avLst/>
+          </a:prstGeom>
+          <a:noFill/>
+          <a:ln/>
+        </p:spPr>
+        <p:txBody>
+          <a:bodyPr wrap="none" lIns="0" tIns="0" rIns="0" bIns="0" rtlCol="0" anchor="ctr"/>
           <a:lstStyle/>
           <a:p>
             <a:pPr indent="0" marL="0">
@@ -20188,8 +20188,8 @@
         </p:nvSpPr>
         <p:spPr>
           <a:xfrm>
-            <a:off x="2727953" y="4343389"/>
-            <a:ext cx="518159" cy="209549"/>
+            <a:off x="666748" y="4610088"/>
+            <a:ext cx="636268" cy="209549"/>
           </a:xfrm>
           <a:prstGeom prst="roundRect">
             <a:avLst>
@@ -20215,7 +20215,7 @@
         </p:nvSpPr>
         <p:spPr>
           <a:xfrm>
-            <a:off x="2804153" y="4419589"/>
+            <a:off x="742948" y="4686288"/>
             <a:ext cx="57150" cy="57150"/>
           </a:xfrm>
           <a:prstGeom prst="ellipse">
@@ -20240,17 +20240,17 @@
         </p:nvSpPr>
         <p:spPr>
           <a:xfrm>
-            <a:off x="2899403" y="4343389"/>
-            <a:ext cx="289559" cy="209549"/>
-          </a:xfrm>
-          <a:prstGeom prst="rect">
-            <a:avLst/>
-          </a:prstGeom>
-          <a:noFill/>
-          <a:ln/>
-        </p:spPr>
-        <p:txBody>
-          <a:bodyPr wrap="square" lIns="0" tIns="0" rIns="0" bIns="0" rtlCol="0" anchor="ctr"/>
+            <a:off x="828673" y="4610088"/>
+            <a:ext cx="445769" cy="209549"/>
+          </a:xfrm>
+          <a:prstGeom prst="rect">
+            <a:avLst/>
+          </a:prstGeom>
+          <a:noFill/>
+          <a:ln/>
+        </p:spPr>
+        <p:txBody>
+          <a:bodyPr wrap="none" lIns="0" tIns="0" rIns="0" bIns="0" rtlCol="0" anchor="ctr"/>
           <a:lstStyle/>
           <a:p>
             <a:pPr indent="0" marL="0">
@@ -20279,8 +20279,8 @@
         </p:nvSpPr>
         <p:spPr>
           <a:xfrm>
-            <a:off x="3303262" y="4343389"/>
-            <a:ext cx="445769" cy="209549"/>
+            <a:off x="1360167" y="4610088"/>
+            <a:ext cx="539114" cy="209549"/>
           </a:xfrm>
           <a:prstGeom prst="roundRect">
             <a:avLst>
@@ -20306,7 +20306,7 @@
         </p:nvSpPr>
         <p:spPr>
           <a:xfrm>
-            <a:off x="3379462" y="4419589"/>
+            <a:off x="1436366" y="4686288"/>
             <a:ext cx="57150" cy="57150"/>
           </a:xfrm>
           <a:prstGeom prst="ellipse">
@@ -20331,17 +20331,17 @@
         </p:nvSpPr>
         <p:spPr>
           <a:xfrm>
-            <a:off x="3474711" y="4343389"/>
-            <a:ext cx="217169" cy="209549"/>
-          </a:xfrm>
-          <a:prstGeom prst="rect">
-            <a:avLst/>
-          </a:prstGeom>
-          <a:noFill/>
-          <a:ln/>
-        </p:spPr>
-        <p:txBody>
-          <a:bodyPr wrap="square" lIns="0" tIns="0" rIns="0" bIns="0" rtlCol="0" anchor="ctr"/>
+            <a:off x="1522091" y="4610088"/>
+            <a:ext cx="348614" cy="209549"/>
+          </a:xfrm>
+          <a:prstGeom prst="rect">
+            <a:avLst/>
+          </a:prstGeom>
+          <a:noFill/>
+          <a:ln/>
+        </p:spPr>
+        <p:txBody>
+          <a:bodyPr wrap="none" lIns="0" tIns="0" rIns="0" bIns="0" rtlCol="0" anchor="ctr"/>
           <a:lstStyle/>
           <a:p>
             <a:pPr indent="0" marL="0">
@@ -20370,8 +20370,8 @@
         </p:nvSpPr>
         <p:spPr>
           <a:xfrm>
-            <a:off x="685798" y="4610088"/>
-            <a:ext cx="937258" cy="209549"/>
+            <a:off x="1956430" y="4610088"/>
+            <a:ext cx="784858" cy="209549"/>
           </a:xfrm>
           <a:prstGeom prst="roundRect">
             <a:avLst>
@@ -20405,7 +20405,7 @@
         </p:blipFill>
         <p:spPr>
           <a:xfrm>
-            <a:off x="752473" y="4662476"/>
+            <a:off x="2023105" y="4662476"/>
             <a:ext cx="104775" cy="104775"/>
           </a:xfrm>
           <a:prstGeom prst="rect">
@@ -20421,17 +20421,17 @@
         </p:nvSpPr>
         <p:spPr>
           <a:xfrm>
-            <a:off x="885823" y="4610088"/>
-            <a:ext cx="689608" cy="209549"/>
-          </a:xfrm>
-          <a:prstGeom prst="rect">
-            <a:avLst/>
-          </a:prstGeom>
-          <a:noFill/>
-          <a:ln/>
-        </p:spPr>
-        <p:txBody>
-          <a:bodyPr wrap="square" lIns="0" tIns="0" rIns="0" bIns="0" rtlCol="0" anchor="ctr"/>
+            <a:off x="2146930" y="4610088"/>
+            <a:ext cx="575309" cy="209549"/>
+          </a:xfrm>
+          <a:prstGeom prst="rect">
+            <a:avLst/>
+          </a:prstGeom>
+          <a:noFill/>
+          <a:ln/>
+        </p:spPr>
+        <p:txBody>
+          <a:bodyPr wrap="none" lIns="0" tIns="0" rIns="0" bIns="0" rtlCol="0" anchor="ctr"/>
           <a:lstStyle/>
           <a:p>
             <a:pPr indent="0" marL="0">
@@ -20460,8 +20460,8 @@
         </p:nvSpPr>
         <p:spPr>
           <a:xfrm>
-            <a:off x="1680206" y="4610088"/>
-            <a:ext cx="373379" cy="209549"/>
+            <a:off x="2798438" y="4610088"/>
+            <a:ext cx="441959" cy="209549"/>
           </a:xfrm>
           <a:prstGeom prst="roundRect">
             <a:avLst>
@@ -20487,7 +20487,7 @@
         </p:nvSpPr>
         <p:spPr>
           <a:xfrm>
-            <a:off x="1756406" y="4686288"/>
+            <a:off x="2874638" y="4686288"/>
             <a:ext cx="57150" cy="57150"/>
           </a:xfrm>
           <a:prstGeom prst="ellipse">
@@ -20512,17 +20512,17 @@
         </p:nvSpPr>
         <p:spPr>
           <a:xfrm>
-            <a:off x="1851655" y="4610088"/>
-            <a:ext cx="144780" cy="209549"/>
-          </a:xfrm>
-          <a:prstGeom prst="rect">
-            <a:avLst/>
-          </a:prstGeom>
-          <a:noFill/>
-          <a:ln/>
-        </p:spPr>
-        <p:txBody>
-          <a:bodyPr wrap="square" lIns="0" tIns="0" rIns="0" bIns="0" rtlCol="0" anchor="ctr"/>
+            <a:off x="2960363" y="4610088"/>
+            <a:ext cx="251459" cy="209549"/>
+          </a:xfrm>
+          <a:prstGeom prst="rect">
+            <a:avLst/>
+          </a:prstGeom>
+          <a:noFill/>
+          <a:ln/>
+        </p:spPr>
+        <p:txBody>
+          <a:bodyPr wrap="none" lIns="0" tIns="0" rIns="0" bIns="0" rtlCol="0" anchor="ctr"/>
           <a:lstStyle/>
           <a:p>
             <a:pPr indent="0" marL="0">
@@ -20551,8 +20551,8 @@
         </p:nvSpPr>
         <p:spPr>
           <a:xfrm>
-            <a:off x="2110735" y="4610088"/>
-            <a:ext cx="445769" cy="209549"/>
+            <a:off x="3297547" y="4610088"/>
+            <a:ext cx="539114" cy="209549"/>
           </a:xfrm>
           <a:prstGeom prst="roundRect">
             <a:avLst>
@@ -20578,7 +20578,7 @@
         </p:nvSpPr>
         <p:spPr>
           <a:xfrm>
-            <a:off x="2186935" y="4686288"/>
+            <a:off x="3373747" y="4686288"/>
             <a:ext cx="57150" cy="57150"/>
           </a:xfrm>
           <a:prstGeom prst="ellipse">
@@ -20603,17 +20603,17 @@
         </p:nvSpPr>
         <p:spPr>
           <a:xfrm>
-            <a:off x="2282184" y="4610088"/>
-            <a:ext cx="217169" cy="209549"/>
-          </a:xfrm>
-          <a:prstGeom prst="rect">
-            <a:avLst/>
-          </a:prstGeom>
-          <a:noFill/>
-          <a:ln/>
-        </p:spPr>
-        <p:txBody>
-          <a:bodyPr wrap="square" lIns="0" tIns="0" rIns="0" bIns="0" rtlCol="0" anchor="ctr"/>
+            <a:off x="3459471" y="4610088"/>
+            <a:ext cx="348614" cy="209549"/>
+          </a:xfrm>
+          <a:prstGeom prst="rect">
+            <a:avLst/>
+          </a:prstGeom>
+          <a:noFill/>
+          <a:ln/>
+        </p:spPr>
+        <p:txBody>
+          <a:bodyPr wrap="none" lIns="0" tIns="0" rIns="0" bIns="0" rtlCol="0" anchor="ctr"/>
           <a:lstStyle/>
           <a:p>
             <a:pPr indent="0" marL="0">
@@ -20642,8 +20642,8 @@
         </p:nvSpPr>
         <p:spPr>
           <a:xfrm>
-            <a:off x="2613653" y="4610088"/>
-            <a:ext cx="518159" cy="209549"/>
+            <a:off x="666748" y="4876788"/>
+            <a:ext cx="636268" cy="209549"/>
           </a:xfrm>
           <a:prstGeom prst="roundRect">
             <a:avLst>
@@ -20669,7 +20669,7 @@
         </p:nvSpPr>
         <p:spPr>
           <a:xfrm>
-            <a:off x="2689853" y="4686288"/>
+            <a:off x="742948" y="4952988"/>
             <a:ext cx="57150" cy="57150"/>
           </a:xfrm>
           <a:prstGeom prst="ellipse">
@@ -20694,17 +20694,17 @@
         </p:nvSpPr>
         <p:spPr>
           <a:xfrm>
-            <a:off x="2785103" y="4610088"/>
-            <a:ext cx="289559" cy="209549"/>
-          </a:xfrm>
-          <a:prstGeom prst="rect">
-            <a:avLst/>
-          </a:prstGeom>
-          <a:noFill/>
-          <a:ln/>
-        </p:spPr>
-        <p:txBody>
-          <a:bodyPr wrap="square" lIns="0" tIns="0" rIns="0" bIns="0" rtlCol="0" anchor="ctr"/>
+            <a:off x="828673" y="4876788"/>
+            <a:ext cx="445769" cy="209549"/>
+          </a:xfrm>
+          <a:prstGeom prst="rect">
+            <a:avLst/>
+          </a:prstGeom>
+          <a:noFill/>
+          <a:ln/>
+        </p:spPr>
+        <p:txBody>
+          <a:bodyPr wrap="none" lIns="0" tIns="0" rIns="0" bIns="0" rtlCol="0" anchor="ctr"/>
           <a:lstStyle/>
           <a:p>
             <a:pPr indent="0" marL="0">
@@ -20733,7 +20733,7 @@
         </p:nvSpPr>
         <p:spPr>
           <a:xfrm>
-            <a:off x="685798" y="4895838"/>
+            <a:off x="685798" y="5162537"/>
             <a:ext cx="3276592" cy="190500"/>
           </a:xfrm>
           <a:prstGeom prst="rect">

</xml_diff>

<commit_message>
Adopt owner deck wording, drop appendix slide (9 → 8 slides)
담당자 제안 장표(흥국화재 TM 0917 V2.1) 기준으로 특장점 문구 교체
- Banner Fit: 한 번 입력으로 즉시 생성 / 매체 규격 자동 대응(23종+·안전 영역·텍스트 비율) /
  디자이너 워크플로 연결(분리 PSD → 포토샵) / 레이어 분해 편집
- Reels Studio: 프롬프트 없이 시작 / 초안 스토리보드 자동 생성 /
  컷 단위 승인형 디렉팅(키프레임 선확정 → 컷 간 일관성) / 승인한 만큼만 비용
- GEO: 담당자 고객용 4단 구성으로 교체 — AI 가독성 진단 / 네이버 AI 브리핑 대응 /
  브랜드 신뢰도 분석 / 개선 가이드 제공, 제목·정의 문구도 원문 반영
- 모델명·비율·컷수 등 사양은 칩으로 내려 설명 줄 유지

- 마지막 장(부록) 제거 → 8장. 표기 기준 중 핵심은 해당 장 각주로 유지
  (자동 통합 아님/점수 자체 기준/캡처 시점·마스킹/매출·광고 기여 구분/MI 명칭 근거)
- 04장 중복 인용 블록 제거
- HTML · 단일 HTML · PDF 8페이지 · PPTX 8장 재생성, 넘침 0건·경계 밖 0건 확인

Co-Authored-By: Claude Opus 5 <noreply@anthropic.com>
Claude-Session: https://claude.ai/code/session_011X2s4AJGYKPxJHXCXs5Aou
</commit_message>
<xml_diff>
--- a/ai-solution/mplanit-ai-solution.pptx
+++ b/ai-solution/mplanit-ai-solution.pptx
@@ -13,10 +13,9 @@
     <p:sldId id="261" r:id="rId7"/>
     <p:sldId id="262" r:id="rId8"/>
     <p:sldId id="263" r:id="rId9"/>
-    <p:sldId id="264" r:id="rId10"/>
   </p:sldIdLst>
   <p:notesMasterIdLst>
-    <p:notesMasterId r:id="rId11"/>
+    <p:notesMasterId r:id="rId10"/>
   </p:notesMasterIdLst>
   <p:sldSz cx="12192000" cy="6858000"/>
   <p:notesSz cx="6858000" cy="12192000"/>
@@ -1168,94 +1167,6 @@
 </p:notes>
 </file>
 
-<file path=ppt/notesSlides/notesSlide9.xml><?xml version="1.0" encoding="utf-8"?>
-<p:notes xmlns:a="http://schemas.openxmlformats.org/drawingml/2006/main" xmlns:r="http://schemas.openxmlformats.org/officeDocument/2006/relationships" xmlns:p="http://schemas.openxmlformats.org/presentationml/2006/main">
-  <p:cSld>
-    <p:spTree>
-      <p:nvGrpSpPr>
-        <p:cNvPr id="1" name=""/>
-        <p:cNvGrpSpPr/>
-        <p:nvPr/>
-      </p:nvGrpSpPr>
-      <p:grpSpPr>
-        <a:xfrm>
-          <a:off x="0" y="0"/>
-          <a:ext cx="0" cy="0"/>
-          <a:chOff x="0" y="0"/>
-          <a:chExt cx="0" cy="0"/>
-        </a:xfrm>
-      </p:grpSpPr>
-      <p:sp>
-        <p:nvSpPr>
-          <p:cNvPr id="2" name="Slide Image Placeholder 1"/>
-          <p:cNvSpPr>
-            <a:spLocks noGrp="1" noRot="1" noChangeAspect="1"/>
-          </p:cNvSpPr>
-          <p:nvPr>
-            <p:ph type="sldImg"/>
-          </p:nvPr>
-        </p:nvSpPr>
-        <p:spPr/>
-      </p:sp>
-      <p:sp>
-        <p:nvSpPr>
-          <p:cNvPr id="3" name="Notes Placeholder 2"/>
-          <p:cNvSpPr>
-            <a:spLocks noGrp="1"/>
-          </p:cNvSpPr>
-          <p:nvPr>
-            <p:ph type="body" idx="1"/>
-          </p:nvPr>
-        </p:nvSpPr>
-        <p:spPr/>
-        <p:txBody>
-          <a:bodyPr/>
-          <a:lstStyle/>
-          <a:p>
-            <a:r>
-              <a:rPr lang="en-US" dirty="0"/>
-              <a:t/>
-            </a:r>
-            <a:endParaRPr lang="en-US" dirty="0"/>
-          </a:p>
-        </p:txBody>
-      </p:sp>
-      <p:sp>
-        <p:nvSpPr>
-          <p:cNvPr id="4" name="Slide Number Placeholder 3"/>
-          <p:cNvSpPr>
-            <a:spLocks noGrp="1"/>
-          </p:cNvSpPr>
-          <p:nvPr>
-            <p:ph type="sldNum" sz="quarter" idx="10"/>
-          </p:nvPr>
-        </p:nvSpPr>
-        <p:spPr/>
-        <p:txBody>
-          <a:bodyPr/>
-          <a:lstStyle/>
-          <a:p>
-            <a:fld id="{F7021451-1387-4CA6-816F-3879F97B5CBC}" type="slidenum">
-              <a:rPr lang="en-US"/>
-              <a:t>9</a:t>
-            </a:fld>
-            <a:endParaRPr lang="en-US"/>
-          </a:p>
-        </p:txBody>
-      </p:sp>
-    </p:spTree>
-    <p:extLst>
-      <p:ext uri="{BB962C8B-B14F-4D97-AF65-F5344CB8AC3E}">
-        <p14:creationId xmlns:p14="http://schemas.microsoft.com/office/powerpoint/2010/main" val="1024086991"/>
-      </p:ext>
-    </p:extLst>
-  </p:cSld>
-  <p:clrMapOvr>
-    <a:masterClrMapping/>
-  </p:clrMapOvr>
-</p:notes>
-</file>
-
 <file path=ppt/slideLayouts/slideLayout1.xml><?xml version="1.0" encoding="utf-8"?>
 <p:sldLayout xmlns:a="http://schemas.openxmlformats.org/drawingml/2006/main" xmlns:r="http://schemas.openxmlformats.org/officeDocument/2006/relationships" xmlns:p="http://schemas.openxmlformats.org/presentationml/2006/main" preserve="1">
   <p:cSld name="DEFAULT">
@@ -6195,7 +6106,7 @@
                 <a:ea typeface="페이퍼로지 4 Regular" pitchFamily="34" charset="-122"/>
                 <a:cs typeface="페이퍼로지 4 Regular" pitchFamily="34" charset="-120"/>
               </a:rPr>
-              <a:t>01 / 09</a:t>
+              <a:t>01 / 08</a:t>
             </a:r>
             <a:endParaRPr lang="en-US" sz="800" dirty="0"/>
           </a:p>
@@ -10107,7 +10018,7 @@
         </p:nvSpPr>
         <p:spPr>
           <a:xfrm>
-            <a:off x="533399" y="5143487"/>
+            <a:off x="533399" y="5105387"/>
             <a:ext cx="11125172" cy="457199"/>
           </a:xfrm>
           <a:prstGeom prst="rect">
@@ -10132,7 +10043,7 @@
         </p:nvSpPr>
         <p:spPr>
           <a:xfrm>
-            <a:off x="533399" y="5143487"/>
+            <a:off x="533399" y="5105387"/>
             <a:ext cx="28575" cy="457199"/>
           </a:xfrm>
           <a:prstGeom prst="rect">
@@ -10157,7 +10068,7 @@
         </p:nvSpPr>
         <p:spPr>
           <a:xfrm>
-            <a:off x="666748" y="5210162"/>
+            <a:off x="666748" y="5172062"/>
             <a:ext cx="10877523" cy="171450"/>
           </a:xfrm>
           <a:prstGeom prst="rect">
@@ -10196,7 +10107,7 @@
         </p:nvSpPr>
         <p:spPr>
           <a:xfrm>
-            <a:off x="666748" y="5391137"/>
+            <a:off x="666748" y="5353037"/>
             <a:ext cx="10877523" cy="152400"/>
           </a:xfrm>
           <a:prstGeom prst="rect">
@@ -10221,96 +10132,74 @@
                 <a:ea typeface="페이퍼로지 4 Regular" pitchFamily="34" charset="-122"/>
                 <a:cs typeface="페이퍼로지 4 Regular" pitchFamily="34" charset="-120"/>
               </a:rPr>
-              <a:t>채널마다 접속·다운로드·옮겨적기 없이, 주문과 광고비가 같은 기준으로 합쳐집니다 · 카카오쇼핑 API 연동 신청 자료(2026.09)</a:t>
+              <a:t>채널마다 접속·다운로드·옮겨적기 없이, 주문과 광고비가 같은 기준으로 합쳐집니다</a:t>
             </a:r>
             <a:endParaRPr lang="en-US" sz="750" dirty="0"/>
           </a:p>
-        </p:txBody>
-      </p:sp>
-      <p:sp>
-        <p:nvSpPr>
-          <p:cNvPr id="121" name="Shape 119"/>
-          <p:cNvSpPr/>
-          <p:nvPr/>
-        </p:nvSpPr>
-        <p:spPr>
-          <a:xfrm>
-            <a:off x="533399" y="6400784"/>
-            <a:ext cx="11125172" cy="0"/>
-          </a:xfrm>
-          <a:prstGeom prst="line">
-            <a:avLst/>
-          </a:prstGeom>
-          <a:noFill/>
-          <a:ln w="9525">
-            <a:solidFill>
-              <a:srgbClr val="E3EAF4"/>
-            </a:solidFill>
-            <a:prstDash val="solid"/>
-          </a:ln>
-        </p:spPr>
-      </p:sp>
-      <p:sp>
-        <p:nvSpPr>
-          <p:cNvPr id="122" name="Text 120"/>
-          <p:cNvSpPr txBox="1"/>
-          <p:nvPr/>
-        </p:nvSpPr>
-        <p:spPr>
-          <a:xfrm>
-            <a:off x="533399" y="6457934"/>
-            <a:ext cx="7619981" cy="190500"/>
-          </a:xfrm>
-          <a:prstGeom prst="rect">
-            <a:avLst/>
-          </a:prstGeom>
-          <a:noFill/>
-          <a:ln/>
-        </p:spPr>
-        <p:txBody>
-          <a:bodyPr wrap="square" lIns="0" tIns="0" rIns="0" bIns="0" rtlCol="0" anchor="ctr"/>
-          <a:lstStyle/>
-          <a:p>
-            <a:pPr indent="0" marL="0">
-              <a:buNone/>
-            </a:pPr>
-            <a:r>
-              <a:rPr lang="en-US" sz="800" dirty="0">
-                <a:solidFill>
-                  <a:srgbClr val="94A3B8"/>
+          <a:p>
+            <a:pPr indent="0" marL="0">
+              <a:buNone/>
+            </a:pPr>
+            <a:r>
+              <a:rPr lang="en-US" sz="750" dirty="0">
+                <a:solidFill>
+                  <a:srgbClr val="64748B"/>
                 </a:solidFill>
                 <a:latin typeface="페이퍼로지 4 Regular" pitchFamily="34" charset="0"/>
                 <a:ea typeface="페이퍼로지 4 Regular" pitchFamily="34" charset="-122"/>
                 <a:cs typeface="페이퍼로지 4 Regular" pitchFamily="34" charset="-120"/>
               </a:rPr>
-              <a:t>Solution Architecture · 통합 구조 요약</a:t>
-            </a:r>
-            <a:endParaRPr lang="en-US" sz="800" dirty="0"/>
-          </a:p>
-        </p:txBody>
-      </p:sp>
-      <p:sp>
-        <p:nvSpPr>
-          <p:cNvPr id="123" name="Text 121"/>
-          <p:cNvSpPr txBox="1"/>
-          <p:nvPr/>
-        </p:nvSpPr>
-        <p:spPr>
-          <a:xfrm>
-            <a:off x="9524976" y="6457934"/>
-            <a:ext cx="2133595" cy="190500"/>
-          </a:xfrm>
-          <a:prstGeom prst="rect">
-            <a:avLst/>
-          </a:prstGeom>
-          <a:noFill/>
-          <a:ln/>
-        </p:spPr>
-        <p:txBody>
-          <a:bodyPr wrap="square" lIns="0" tIns="0" rIns="0" bIns="0" rtlCol="0" anchor="ctr"/>
-          <a:lstStyle/>
-          <a:p>
-            <a:pPr algn="r" indent="0" marL="0">
+              <a:t>※ 서비스 포트폴리오 구성도이며 솔루션 간 자동 통합 아키텍처를 뜻하지 않습니다</a:t>
+            </a:r>
+            <a:endParaRPr lang="en-US" sz="750" dirty="0"/>
+          </a:p>
+        </p:txBody>
+      </p:sp>
+      <p:sp>
+        <p:nvSpPr>
+          <p:cNvPr id="121" name="Shape 119"/>
+          <p:cNvSpPr/>
+          <p:nvPr/>
+        </p:nvSpPr>
+        <p:spPr>
+          <a:xfrm>
+            <a:off x="533399" y="6400784"/>
+            <a:ext cx="11125172" cy="0"/>
+          </a:xfrm>
+          <a:prstGeom prst="line">
+            <a:avLst/>
+          </a:prstGeom>
+          <a:noFill/>
+          <a:ln w="9525">
+            <a:solidFill>
+              <a:srgbClr val="E3EAF4"/>
+            </a:solidFill>
+            <a:prstDash val="solid"/>
+          </a:ln>
+        </p:spPr>
+      </p:sp>
+      <p:sp>
+        <p:nvSpPr>
+          <p:cNvPr id="122" name="Text 120"/>
+          <p:cNvSpPr txBox="1"/>
+          <p:nvPr/>
+        </p:nvSpPr>
+        <p:spPr>
+          <a:xfrm>
+            <a:off x="533399" y="6457934"/>
+            <a:ext cx="7619981" cy="190500"/>
+          </a:xfrm>
+          <a:prstGeom prst="rect">
+            <a:avLst/>
+          </a:prstGeom>
+          <a:noFill/>
+          <a:ln/>
+        </p:spPr>
+        <p:txBody>
+          <a:bodyPr wrap="square" lIns="0" tIns="0" rIns="0" bIns="0" rtlCol="0" anchor="ctr"/>
+          <a:lstStyle/>
+          <a:p>
+            <a:pPr indent="0" marL="0">
               <a:buNone/>
             </a:pPr>
             <a:r>
@@ -10322,7 +10211,46 @@
                 <a:ea typeface="페이퍼로지 4 Regular" pitchFamily="34" charset="-122"/>
                 <a:cs typeface="페이퍼로지 4 Regular" pitchFamily="34" charset="-120"/>
               </a:rPr>
-              <a:t>02 / 09</a:t>
+              <a:t>Solution Architecture · 통합 구조 요약</a:t>
+            </a:r>
+            <a:endParaRPr lang="en-US" sz="800" dirty="0"/>
+          </a:p>
+        </p:txBody>
+      </p:sp>
+      <p:sp>
+        <p:nvSpPr>
+          <p:cNvPr id="123" name="Text 121"/>
+          <p:cNvSpPr txBox="1"/>
+          <p:nvPr/>
+        </p:nvSpPr>
+        <p:spPr>
+          <a:xfrm>
+            <a:off x="9524976" y="6457934"/>
+            <a:ext cx="2133595" cy="190500"/>
+          </a:xfrm>
+          <a:prstGeom prst="rect">
+            <a:avLst/>
+          </a:prstGeom>
+          <a:noFill/>
+          <a:ln/>
+        </p:spPr>
+        <p:txBody>
+          <a:bodyPr wrap="square" lIns="0" tIns="0" rIns="0" bIns="0" rtlCol="0" anchor="ctr"/>
+          <a:lstStyle/>
+          <a:p>
+            <a:pPr algn="r" indent="0" marL="0">
+              <a:buNone/>
+            </a:pPr>
+            <a:r>
+              <a:rPr lang="en-US" sz="800" dirty="0">
+                <a:solidFill>
+                  <a:srgbClr val="94A3B8"/>
+                </a:solidFill>
+                <a:latin typeface="페이퍼로지 4 Regular" pitchFamily="34" charset="0"/>
+                <a:ea typeface="페이퍼로지 4 Regular" pitchFamily="34" charset="-122"/>
+                <a:cs typeface="페이퍼로지 4 Regular" pitchFamily="34" charset="-120"/>
+              </a:rPr>
+              <a:t>02 / 08</a:t>
             </a:r>
             <a:endParaRPr lang="en-US" sz="800" dirty="0"/>
           </a:p>
@@ -12393,7 +12321,7 @@
                 <a:ea typeface="페이퍼로지 4 Regular" pitchFamily="34" charset="-122"/>
                 <a:cs typeface="페이퍼로지 4 Regular" pitchFamily="34" charset="-120"/>
               </a:rPr>
-              <a:t>03 / 09</a:t>
+              <a:t>03 / 08</a:t>
             </a:r>
             <a:endParaRPr lang="en-US" sz="800" dirty="0"/>
           </a:p>
@@ -12790,7 +12718,7 @@
                 <a:ea typeface="페이퍼로지 8 ExtraBold" pitchFamily="34" charset="-122"/>
                 <a:cs typeface="페이퍼로지 8 ExtraBold" pitchFamily="34" charset="-120"/>
               </a:rPr>
-              <a:t>입력 6단계</a:t>
+              <a:t>한 번 입력으로 즉시 생성</a:t>
             </a:r>
             <a:endParaRPr lang="en-US" sz="1100" dirty="0"/>
           </a:p>
@@ -12832,7 +12760,7 @@
                 <a:ea typeface="페이퍼로지 4 Regular" pitchFamily="34" charset="-122"/>
                 <a:cs typeface="페이퍼로지 4 Regular" pitchFamily="34" charset="-120"/>
               </a:rPr>
-              <a:t>기본정보 · 이미지 · 스타일 · 텍스트 · 출력 · 모델</a:t>
+              <a:t>이미지 + 요청 한 줄 → 배경 · 카피 · 레이아웃 동시 산출</a:t>
             </a:r>
             <a:endParaRPr lang="en-US" sz="900" dirty="0"/>
           </a:p>
@@ -12937,7 +12865,7 @@
                 <a:ea typeface="페이퍼로지 8 ExtraBold" pitchFamily="34" charset="-122"/>
                 <a:cs typeface="페이퍼로지 8 ExtraBold" pitchFamily="34" charset="-120"/>
               </a:rPr>
-              <a:t>2가지 작업 모드</a:t>
+              <a:t>매체 규격 자동 대응</a:t>
             </a:r>
             <a:endParaRPr lang="en-US" sz="1100" dirty="0"/>
           </a:p>
@@ -12979,7 +12907,7 @@
                 <a:ea typeface="페이퍼로지 4 Regular" pitchFamily="34" charset="-122"/>
                 <a:cs typeface="페이퍼로지 4 Regular" pitchFamily="34" charset="-120"/>
               </a:rPr>
-              <a:t>라이트 양식 입력 / 에디터 대화 지시</a:t>
+              <a:t>23개 이상 매체 규격 · 안전 영역 · 텍스트 비율 내장</a:t>
             </a:r>
             <a:endParaRPr lang="en-US" sz="900" dirty="0"/>
           </a:p>
@@ -13084,7 +13012,7 @@
                 <a:ea typeface="페이퍼로지 8 ExtraBold" pitchFamily="34" charset="-122"/>
                 <a:cs typeface="페이퍼로지 8 ExtraBold" pitchFamily="34" charset="-120"/>
               </a:rPr>
-              <a:t>규격 변형 · 레이어 편집</a:t>
+              <a:t>디자이너 워크플로 연결</a:t>
             </a:r>
             <a:endParaRPr lang="en-US" sz="1100" dirty="0"/>
           </a:p>
@@ -13126,7 +13054,7 @@
                 <a:ea typeface="페이퍼로지 4 Regular" pitchFamily="34" charset="-122"/>
                 <a:cs typeface="페이퍼로지 4 Regular" pitchFamily="34" charset="-120"/>
               </a:rPr>
-              <a:t>기본 4비율 + 매체 규격 23종 · 레이어 분리 수정</a:t>
+              <a:t>텍스트 · 로고 · 배경 분리 PSD → 포토샵에서 바로 수정</a:t>
             </a:r>
             <a:endParaRPr lang="en-US" sz="900" dirty="0"/>
           </a:p>
@@ -13231,7 +13159,7 @@
                 <a:ea typeface="페이퍼로지 8 ExtraBold" pitchFamily="34" charset="-122"/>
                 <a:cs typeface="페이퍼로지 8 ExtraBold" pitchFamily="34" charset="-120"/>
               </a:rPr>
-              <a:t>생성 모델 선택</a:t>
+              <a:t>레이어 분해 편집</a:t>
             </a:r>
             <a:endParaRPr lang="en-US" sz="1100" dirty="0"/>
           </a:p>
@@ -13273,7 +13201,7 @@
                 <a:ea typeface="페이퍼로지 4 Regular" pitchFamily="34" charset="-122"/>
                 <a:cs typeface="페이퍼로지 4 Regular" pitchFamily="34" charset="-120"/>
               </a:rPr>
-              <a:t>Gemini(나노 바나나) · ChatGPT 2.0 → 영상 생성 연결</a:t>
+              <a:t>피사체 · 텍스트 자동 분리 → 브라우저에서 재배치</a:t>
             </a:r>
             <a:endParaRPr lang="en-US" sz="900" dirty="0"/>
           </a:p>
@@ -13287,8 +13215,8 @@
         </p:nvSpPr>
         <p:spPr>
           <a:xfrm>
-            <a:off x="533399" y="4514839"/>
-            <a:ext cx="929638" cy="209549"/>
+            <a:off x="533399" y="4552939"/>
+            <a:ext cx="1249677" cy="209549"/>
           </a:xfrm>
           <a:prstGeom prst="roundRect">
             <a:avLst>
@@ -13314,8 +13242,8 @@
         </p:nvSpPr>
         <p:spPr>
           <a:xfrm>
-            <a:off x="533399" y="4514839"/>
-            <a:ext cx="929638" cy="209549"/>
+            <a:off x="533399" y="4552939"/>
+            <a:ext cx="1249677" cy="209549"/>
           </a:xfrm>
           <a:prstGeom prst="rect">
             <a:avLst/>
@@ -13339,7 +13267,7 @@
                 <a:ea typeface="페이퍼로지 8 ExtraBold" pitchFamily="34" charset="-122"/>
                 <a:cs typeface="페이퍼로지 8 ExtraBold" pitchFamily="34" charset="-120"/>
               </a:rPr>
-              <a:t>크리에이티브 생성</a:t>
+              <a:t>라이트 · 에디터 2모드</a:t>
             </a:r>
             <a:endParaRPr lang="en-US" sz="800" dirty="0"/>
           </a:p>
@@ -13353,8 +13281,8 @@
         </p:nvSpPr>
         <p:spPr>
           <a:xfrm>
-            <a:off x="1520186" y="4514839"/>
-            <a:ext cx="929638" cy="209549"/>
+            <a:off x="1840225" y="4552939"/>
+            <a:ext cx="2449824" cy="209549"/>
           </a:xfrm>
           <a:prstGeom prst="roundRect">
             <a:avLst>
@@ -13380,8 +13308,8 @@
         </p:nvSpPr>
         <p:spPr>
           <a:xfrm>
-            <a:off x="1520186" y="4514839"/>
-            <a:ext cx="929638" cy="209549"/>
+            <a:off x="1840225" y="4552939"/>
+            <a:ext cx="2449824" cy="209549"/>
           </a:xfrm>
           <a:prstGeom prst="rect">
             <a:avLst/>
@@ -13405,7 +13333,7 @@
                 <a:ea typeface="페이퍼로지 8 ExtraBold" pitchFamily="34" charset="-122"/>
                 <a:cs typeface="페이퍼로지 8 ExtraBold" pitchFamily="34" charset="-120"/>
               </a:rPr>
-              <a:t>소재 사이즈 변형</a:t>
+              <a:t>Gemini(나노 바나나) · ChatGPT 2.0</a:t>
             </a:r>
             <a:endParaRPr lang="en-US" sz="800" dirty="0"/>
           </a:p>
@@ -13419,8 +13347,8 @@
         </p:nvSpPr>
         <p:spPr>
           <a:xfrm>
-            <a:off x="2506974" y="4514839"/>
-            <a:ext cx="609598" cy="209549"/>
+            <a:off x="533399" y="4838688"/>
+            <a:ext cx="2289804" cy="209549"/>
           </a:xfrm>
           <a:prstGeom prst="roundRect">
             <a:avLst>
@@ -13428,11 +13356,11 @@
             </a:avLst>
           </a:prstGeom>
           <a:solidFill>
-            <a:srgbClr val="EAF1FC"/>
+            <a:srgbClr val="F5F8FC"/>
           </a:solidFill>
           <a:ln w="6350">
             <a:solidFill>
-              <a:srgbClr val="EAF1FC"/>
+              <a:srgbClr val="E3EAF4"/>
             </a:solidFill>
             <a:prstDash val="solid"/>
           </a:ln>
@@ -13446,8 +13374,8 @@
         </p:nvSpPr>
         <p:spPr>
           <a:xfrm>
-            <a:off x="2506974" y="4514839"/>
-            <a:ext cx="609598" cy="209549"/>
+            <a:off x="533399" y="4838688"/>
+            <a:ext cx="2289804" cy="209549"/>
           </a:xfrm>
           <a:prstGeom prst="rect">
             <a:avLst/>
@@ -13465,13 +13393,13 @@
             <a:r>
               <a:rPr lang="en-US" sz="800" dirty="0">
                 <a:solidFill>
-                  <a:srgbClr val="1B468B"/>
-                </a:solidFill>
-                <a:latin typeface="페이퍼로지 8 ExtraBold" pitchFamily="34" charset="0"/>
-                <a:ea typeface="페이퍼로지 8 ExtraBold" pitchFamily="34" charset="-122"/>
-                <a:cs typeface="페이퍼로지 8 ExtraBold" pitchFamily="34" charset="-120"/>
-              </a:rPr>
-              <a:t>영상 생성</a:t>
+                  <a:srgbClr val="64748B"/>
+                </a:solidFill>
+                <a:latin typeface="페이퍼로지 8 ExtraBold" pitchFamily="34" charset="0"/>
+                <a:ea typeface="페이퍼로지 8 ExtraBold" pitchFamily="34" charset="-122"/>
+                <a:cs typeface="페이퍼로지 8 ExtraBold" pitchFamily="34" charset="-120"/>
+              </a:rPr>
+              <a:t>크리에이티브 생성 · 사이즈 변형 · 영상 생성</a:t>
             </a:r>
             <a:endParaRPr lang="en-US" sz="800" dirty="0"/>
           </a:p>
@@ -13479,231 +13407,37 @@
       </p:sp>
       <p:sp>
         <p:nvSpPr>
-          <p:cNvPr id="32" name="Shape 30"/>
-          <p:cNvSpPr/>
-          <p:nvPr/>
-        </p:nvSpPr>
-        <p:spPr>
-          <a:xfrm>
-            <a:off x="533399" y="4800588"/>
-            <a:ext cx="1089657" cy="209549"/>
-          </a:xfrm>
-          <a:prstGeom prst="roundRect">
-            <a:avLst>
-              <a:gd name="adj" fmla="val 43637"/>
-            </a:avLst>
-          </a:prstGeom>
-          <a:solidFill>
-            <a:srgbClr val="F5F8FC"/>
-          </a:solidFill>
-          <a:ln w="6350">
-            <a:solidFill>
-              <a:srgbClr val="E3EAF4"/>
-            </a:solidFill>
-            <a:prstDash val="solid"/>
-          </a:ln>
-        </p:spPr>
-      </p:sp>
-      <p:sp>
-        <p:nvSpPr>
-          <p:cNvPr id="33" name="Text 31"/>
-          <p:cNvSpPr txBox="1"/>
-          <p:nvPr/>
-        </p:nvSpPr>
-        <p:spPr>
-          <a:xfrm>
-            <a:off x="533399" y="4800588"/>
-            <a:ext cx="1089657" cy="209549"/>
-          </a:xfrm>
-          <a:prstGeom prst="rect">
-            <a:avLst/>
-          </a:prstGeom>
-          <a:noFill/>
-          <a:ln/>
-        </p:spPr>
-        <p:txBody>
-          <a:bodyPr wrap="square" lIns="0" tIns="0" rIns="0" bIns="0" rtlCol="0" anchor="ctr"/>
-          <a:lstStyle/>
-          <a:p>
-            <a:pPr algn="ctr" indent="0" marL="0">
-              <a:buNone/>
-            </a:pPr>
-            <a:r>
-              <a:rPr lang="en-US" sz="800" dirty="0">
-                <a:solidFill>
-                  <a:srgbClr val="64748B"/>
-                </a:solidFill>
-                <a:latin typeface="페이퍼로지 8 ExtraBold" pitchFamily="34" charset="0"/>
-                <a:ea typeface="페이퍼로지 8 ExtraBold" pitchFamily="34" charset="-122"/>
-                <a:cs typeface="페이퍼로지 8 ExtraBold" pitchFamily="34" charset="-120"/>
-              </a:rPr>
-              <a:t>편집하기 · 프로젝트</a:t>
-            </a:r>
-            <a:endParaRPr lang="en-US" sz="800" dirty="0"/>
-          </a:p>
-        </p:txBody>
-      </p:sp>
-      <p:sp>
-        <p:nvSpPr>
-          <p:cNvPr id="34" name="Shape 32"/>
-          <p:cNvSpPr/>
-          <p:nvPr/>
-        </p:nvSpPr>
-        <p:spPr>
-          <a:xfrm>
-            <a:off x="533399" y="5105387"/>
-            <a:ext cx="3581391" cy="457199"/>
-          </a:xfrm>
-          <a:prstGeom prst="rect">
-            <a:avLst/>
-          </a:prstGeom>
-          <a:solidFill>
-            <a:srgbClr val="F5F8FC"/>
-          </a:solidFill>
-          <a:ln w="12700">
-            <a:solidFill>
-              <a:srgbClr val="F5F8FC"/>
-            </a:solidFill>
-            <a:prstDash val="solid"/>
-          </a:ln>
-        </p:spPr>
-      </p:sp>
-      <p:sp>
-        <p:nvSpPr>
-          <p:cNvPr id="35" name="Shape 33"/>
-          <p:cNvSpPr/>
-          <p:nvPr/>
-        </p:nvSpPr>
-        <p:spPr>
-          <a:xfrm>
-            <a:off x="533399" y="5105387"/>
-            <a:ext cx="28575" cy="457199"/>
-          </a:xfrm>
-          <a:prstGeom prst="rect">
-            <a:avLst/>
-          </a:prstGeom>
-          <a:solidFill>
-            <a:srgbClr val="1B468B"/>
-          </a:solidFill>
-          <a:ln w="12700">
-            <a:solidFill>
-              <a:srgbClr val="1B468B"/>
-            </a:solidFill>
-            <a:prstDash val="solid"/>
-          </a:ln>
-        </p:spPr>
-      </p:sp>
-      <p:sp>
-        <p:nvSpPr>
-          <p:cNvPr id="36" name="Text 34"/>
-          <p:cNvSpPr txBox="1"/>
-          <p:nvPr/>
-        </p:nvSpPr>
-        <p:spPr>
-          <a:xfrm>
-            <a:off x="666748" y="5172062"/>
-            <a:ext cx="3333742" cy="171450"/>
-          </a:xfrm>
-          <a:prstGeom prst="rect">
-            <a:avLst/>
-          </a:prstGeom>
-          <a:noFill/>
-          <a:ln/>
-        </p:spPr>
-        <p:txBody>
-          <a:bodyPr wrap="square" lIns="0" tIns="0" rIns="0" bIns="0" rtlCol="0" anchor="ctr"/>
-          <a:lstStyle/>
-          <a:p>
-            <a:pPr indent="0" marL="0">
-              <a:buNone/>
-            </a:pPr>
-            <a:r>
-              <a:rPr lang="en-US" sz="1000" dirty="0">
-                <a:solidFill>
-                  <a:srgbClr val="1B468B"/>
-                </a:solidFill>
-                <a:latin typeface="페이퍼로지 8 ExtraBold" pitchFamily="34" charset="0"/>
-                <a:ea typeface="페이퍼로지 8 ExtraBold" pitchFamily="34" charset="-122"/>
-                <a:cs typeface="페이퍼로지 8 ExtraBold" pitchFamily="34" charset="-120"/>
-              </a:rPr>
-              <a:t>한 번 입력으로 즉시 생성</a:t>
-            </a:r>
-            <a:endParaRPr lang="en-US" sz="1000" dirty="0"/>
-          </a:p>
-        </p:txBody>
-      </p:sp>
-      <p:sp>
-        <p:nvSpPr>
-          <p:cNvPr id="37" name="Text 35"/>
-          <p:cNvSpPr txBox="1"/>
-          <p:nvPr/>
-        </p:nvSpPr>
-        <p:spPr>
-          <a:xfrm>
-            <a:off x="666748" y="5353037"/>
-            <a:ext cx="3333742" cy="152400"/>
-          </a:xfrm>
-          <a:prstGeom prst="rect">
-            <a:avLst/>
-          </a:prstGeom>
-          <a:noFill/>
-          <a:ln/>
-        </p:spPr>
-        <p:txBody>
-          <a:bodyPr wrap="square" lIns="0" tIns="0" rIns="0" bIns="0" rtlCol="0" anchor="ctr"/>
-          <a:lstStyle/>
-          <a:p>
-            <a:pPr indent="0" marL="0">
-              <a:buNone/>
-            </a:pPr>
-            <a:r>
-              <a:rPr lang="en-US" sz="750" dirty="0">
-                <a:solidFill>
-                  <a:srgbClr val="64748B"/>
+          <p:cNvPr id="32" name="Text 30"/>
+          <p:cNvSpPr txBox="1"/>
+          <p:nvPr/>
+        </p:nvSpPr>
+        <p:spPr>
+          <a:xfrm>
+            <a:off x="533399" y="5219687"/>
+            <a:ext cx="3581391" cy="247649"/>
+          </a:xfrm>
+          <a:prstGeom prst="rect">
+            <a:avLst/>
+          </a:prstGeom>
+          <a:noFill/>
+          <a:ln/>
+        </p:spPr>
+        <p:txBody>
+          <a:bodyPr wrap="square" lIns="0" tIns="0" rIns="0" bIns="0" rtlCol="0" anchor="ctr"/>
+          <a:lstStyle/>
+          <a:p>
+            <a:pPr indent="0" marL="0">
+              <a:buNone/>
+            </a:pPr>
+            <a:r>
+              <a:rPr lang="en-US" sz="700" dirty="0">
+                <a:solidFill>
+                  <a:srgbClr val="94A3B8"/>
                 </a:solidFill>
                 <a:latin typeface="페이퍼로지 4 Regular" pitchFamily="34" charset="0"/>
                 <a:ea typeface="페이퍼로지 4 Regular" pitchFamily="34" charset="-122"/>
                 <a:cs typeface="페이퍼로지 4 Regular" pitchFamily="34" charset="-120"/>
               </a:rPr>
-              <a:t>이미지 업로드와 요청 한 줄 → 배경 · 카피 · 레이아웃 시안 동시 산출</a:t>
-            </a:r>
-            <a:endParaRPr lang="en-US" sz="750" dirty="0"/>
-          </a:p>
-        </p:txBody>
-      </p:sp>
-      <p:sp>
-        <p:nvSpPr>
-          <p:cNvPr id="38" name="Text 36"/>
-          <p:cNvSpPr txBox="1"/>
-          <p:nvPr/>
-        </p:nvSpPr>
-        <p:spPr>
-          <a:xfrm>
-            <a:off x="533399" y="5619736"/>
-            <a:ext cx="3581391" cy="247649"/>
-          </a:xfrm>
-          <a:prstGeom prst="rect">
-            <a:avLst/>
-          </a:prstGeom>
-          <a:noFill/>
-          <a:ln/>
-        </p:spPr>
-        <p:txBody>
-          <a:bodyPr wrap="square" lIns="0" tIns="0" rIns="0" bIns="0" rtlCol="0" anchor="ctr"/>
-          <a:lstStyle/>
-          <a:p>
-            <a:pPr indent="0" marL="0">
-              <a:buNone/>
-            </a:pPr>
-            <a:r>
-              <a:rPr lang="en-US" sz="700" dirty="0">
-                <a:solidFill>
-                  <a:srgbClr val="94A3B8"/>
-                </a:solidFill>
-                <a:latin typeface="페이퍼로지 4 Regular" pitchFamily="34" charset="0"/>
-                <a:ea typeface="페이퍼로지 4 Regular" pitchFamily="34" charset="-122"/>
-                <a:cs typeface="페이퍼로지 4 Regular" pitchFamily="34" charset="-120"/>
-              </a:rPr>
               <a:t>화면 — 운영 중 Banner Fit 실제 캡처. 편집 화면 시안은 당사 집행 소재.</a:t>
             </a:r>
             <a:endParaRPr lang="en-US" sz="700" dirty="0"/>
@@ -13712,7 +13446,7 @@
       </p:sp>
       <p:sp>
         <p:nvSpPr>
-          <p:cNvPr id="39" name="Shape 37"/>
+          <p:cNvPr id="33" name="Shape 31"/>
           <p:cNvSpPr/>
           <p:nvPr/>
         </p:nvSpPr>
@@ -13746,7 +13480,7 @@
       </p:sp>
       <p:pic>
         <p:nvPicPr>
-          <p:cNvPr id="40" name="Image 0" descr="/home/user/mplanit/ai-solution/assets/png/bannerfit-form.png">    </p:cNvPr>
+          <p:cNvPr id="34" name="Image 0" descr="/home/user/mplanit/ai-solution/assets/png/bannerfit-form.png">    </p:cNvPr>
           <p:cNvPicPr>
             <a:picLocks noChangeAspect="1"/>
           </p:cNvPicPr>
@@ -13770,7 +13504,7 @@
       </p:pic>
       <p:sp>
         <p:nvSpPr>
-          <p:cNvPr id="41" name="Shape 38"/>
+          <p:cNvPr id="35" name="Shape 32"/>
           <p:cNvSpPr/>
           <p:nvPr/>
         </p:nvSpPr>
@@ -13795,7 +13529,7 @@
       </p:sp>
       <p:sp>
         <p:nvSpPr>
-          <p:cNvPr id="42" name="Text 39"/>
+          <p:cNvPr id="36" name="Text 33"/>
           <p:cNvSpPr txBox="1"/>
           <p:nvPr/>
         </p:nvSpPr>
@@ -13834,7 +13568,7 @@
       </p:sp>
       <p:sp>
         <p:nvSpPr>
-          <p:cNvPr id="43" name="Shape 40"/>
+          <p:cNvPr id="37" name="Shape 34"/>
           <p:cNvSpPr/>
           <p:nvPr/>
         </p:nvSpPr>
@@ -13868,7 +13602,7 @@
       </p:sp>
       <p:pic>
         <p:nvPicPr>
-          <p:cNvPr id="44" name="Image 1" descr="/home/user/mplanit/ai-solution/assets/png/bannerfit-chat.png">    </p:cNvPr>
+          <p:cNvPr id="38" name="Image 1" descr="/home/user/mplanit/ai-solution/assets/png/bannerfit-chat.png">    </p:cNvPr>
           <p:cNvPicPr>
             <a:picLocks noChangeAspect="1"/>
           </p:cNvPicPr>
@@ -13892,7 +13626,7 @@
       </p:pic>
       <p:sp>
         <p:nvSpPr>
-          <p:cNvPr id="45" name="Shape 41"/>
+          <p:cNvPr id="39" name="Shape 35"/>
           <p:cNvSpPr/>
           <p:nvPr/>
         </p:nvSpPr>
@@ -13917,7 +13651,7 @@
       </p:sp>
       <p:sp>
         <p:nvSpPr>
-          <p:cNvPr id="46" name="Text 42"/>
+          <p:cNvPr id="40" name="Text 36"/>
           <p:cNvSpPr txBox="1"/>
           <p:nvPr/>
         </p:nvSpPr>
@@ -13956,7 +13690,7 @@
       </p:sp>
       <p:sp>
         <p:nvSpPr>
-          <p:cNvPr id="47" name="Shape 43"/>
+          <p:cNvPr id="41" name="Shape 37"/>
           <p:cNvSpPr/>
           <p:nvPr/>
         </p:nvSpPr>
@@ -13990,7 +13724,7 @@
       </p:sp>
       <p:pic>
         <p:nvPicPr>
-          <p:cNvPr id="48" name="Image 2" descr="/home/user/mplanit/ai-solution/assets/png/bannerfit-editor.png">    </p:cNvPr>
+          <p:cNvPr id="42" name="Image 2" descr="/home/user/mplanit/ai-solution/assets/png/bannerfit-editor.png">    </p:cNvPr>
           <p:cNvPicPr>
             <a:picLocks noChangeAspect="1"/>
           </p:cNvPicPr>
@@ -14014,7 +13748,7 @@
       </p:pic>
       <p:sp>
         <p:nvSpPr>
-          <p:cNvPr id="49" name="Shape 44"/>
+          <p:cNvPr id="43" name="Shape 38"/>
           <p:cNvSpPr/>
           <p:nvPr/>
         </p:nvSpPr>
@@ -14039,7 +13773,7 @@
       </p:sp>
       <p:sp>
         <p:nvSpPr>
-          <p:cNvPr id="50" name="Text 45"/>
+          <p:cNvPr id="44" name="Text 39"/>
           <p:cNvSpPr txBox="1"/>
           <p:nvPr/>
         </p:nvSpPr>
@@ -14078,7 +13812,7 @@
       </p:sp>
       <p:sp>
         <p:nvSpPr>
-          <p:cNvPr id="51" name="Shape 46"/>
+          <p:cNvPr id="45" name="Shape 40"/>
           <p:cNvSpPr/>
           <p:nvPr/>
         </p:nvSpPr>
@@ -14101,7 +13835,7 @@
       </p:sp>
       <p:sp>
         <p:nvSpPr>
-          <p:cNvPr id="52" name="Text 47"/>
+          <p:cNvPr id="46" name="Text 41"/>
           <p:cNvSpPr txBox="1"/>
           <p:nvPr/>
         </p:nvSpPr>
@@ -14140,7 +13874,7 @@
       </p:sp>
       <p:sp>
         <p:nvSpPr>
-          <p:cNvPr id="53" name="Text 48"/>
+          <p:cNvPr id="47" name="Text 42"/>
           <p:cNvSpPr txBox="1"/>
           <p:nvPr/>
         </p:nvSpPr>
@@ -14171,7 +13905,7 @@
                 <a:ea typeface="페이퍼로지 4 Regular" pitchFamily="34" charset="-122"/>
                 <a:cs typeface="페이퍼로지 4 Regular" pitchFamily="34" charset="-120"/>
               </a:rPr>
-              <a:t>04 / 09</a:t>
+              <a:t>04 / 08</a:t>
             </a:r>
             <a:endParaRPr lang="en-US" sz="800" dirty="0"/>
           </a:p>
@@ -14568,7 +14302,7 @@
                 <a:ea typeface="페이퍼로지 8 ExtraBold" pitchFamily="34" charset="-122"/>
                 <a:cs typeface="페이퍼로지 8 ExtraBold" pitchFamily="34" charset="-120"/>
               </a:rPr>
-              <a:t>한 줄 입력</a:t>
+              <a:t>프롬프트 없이 시작</a:t>
             </a:r>
             <a:endParaRPr lang="en-US" sz="1100" dirty="0"/>
           </a:p>
@@ -14610,7 +14344,7 @@
                 <a:ea typeface="페이퍼로지 4 Regular" pitchFamily="34" charset="-122"/>
                 <a:cs typeface="페이퍼로지 4 Regular" pitchFamily="34" charset="-120"/>
               </a:rPr>
-              <a:t>문장 하나 → AI가 질문 완성 → 초안 스토리보드</a:t>
+              <a:t>대상 · 목적 · 메시지 질문형 대화 → 스타일 · 컷 구성은 AI</a:t>
             </a:r>
             <a:endParaRPr lang="en-US" sz="900" dirty="0"/>
           </a:p>
@@ -14715,7 +14449,7 @@
                 <a:ea typeface="페이퍼로지 8 ExtraBold" pitchFamily="34" charset="-122"/>
                 <a:cs typeface="페이퍼로지 8 ExtraBold" pitchFamily="34" charset="-120"/>
               </a:rPr>
-              <a:t>기획 5단계</a:t>
+              <a:t>초안 스토리보드 자동 생성</a:t>
             </a:r>
             <a:endParaRPr lang="en-US" sz="1100" dirty="0"/>
           </a:p>
@@ -14757,7 +14491,7 @@
                 <a:ea typeface="페이퍼로지 4 Regular" pitchFamily="34" charset="-122"/>
                 <a:cs typeface="페이퍼로지 4 Regular" pitchFamily="34" charset="-120"/>
               </a:rPr>
-              <a:t>아이디어 → 의도 → 표현 → 스토리보드 → 완료 · 2/4/7컷</a:t>
+              <a:t>대본 · 키프레임 포함 콘티 전체를 먼저 제안</a:t>
             </a:r>
             <a:endParaRPr lang="en-US" sz="900" dirty="0"/>
           </a:p>
@@ -14862,7 +14596,7 @@
                 <a:ea typeface="페이퍼로지 8 ExtraBold" pitchFamily="34" charset="-122"/>
                 <a:cs typeface="페이퍼로지 8 ExtraBold" pitchFamily="34" charset="-120"/>
               </a:rPr>
-              <a:t>표현 선택형</a:t>
+              <a:t>컷 단위 승인형 디렉팅</a:t>
             </a:r>
             <a:endParaRPr lang="en-US" sz="1100" dirty="0"/>
           </a:p>
@@ -14904,7 +14638,7 @@
                 <a:ea typeface="페이퍼로지 4 Regular" pitchFamily="34" charset="-122"/>
                 <a:cs typeface="페이퍼로지 4 Regular" pitchFamily="34" charset="-120"/>
               </a:rPr>
-              <a:t>영상 종류 · 화면 스타일 · 분위기 · 등장인물 선택</a:t>
+              <a:t>컷 재생성 · 키프레임 교체 · 순서 변경 — 컷 간 일관성 유지</a:t>
             </a:r>
             <a:endParaRPr lang="en-US" sz="900" dirty="0"/>
           </a:p>
@@ -15009,7 +14743,7 @@
                 <a:ea typeface="페이퍼로지 8 ExtraBold" pitchFamily="34" charset="-122"/>
                 <a:cs typeface="페이퍼로지 8 ExtraBold" pitchFamily="34" charset="-120"/>
               </a:rPr>
-              <a:t>컷 승인형 렌더</a:t>
+              <a:t>승인한 만큼만 비용</a:t>
             </a:r>
             <a:endParaRPr lang="en-US" sz="1100" dirty="0"/>
           </a:p>
@@ -15051,7 +14785,7 @@
                 <a:ea typeface="페이퍼로지 4 Regular" pitchFamily="34" charset="-122"/>
                 <a:cs typeface="페이퍼로지 4 Regular" pitchFamily="34" charset="-120"/>
               </a:rPr>
-              <a:t>컷별 승인·재생성 → VEO 3.1 / Gemini Omni 렌더</a:t>
+              <a:t>대본 · 키프레임 무료 · 승인된 성공 컷만 차감</a:t>
             </a:r>
             <a:endParaRPr lang="en-US" sz="900" dirty="0"/>
           </a:p>
@@ -15066,7 +14800,7 @@
         <p:spPr>
           <a:xfrm>
             <a:off x="533399" y="4514839"/>
-            <a:ext cx="769618" cy="209549"/>
+            <a:ext cx="2449824" cy="209549"/>
           </a:xfrm>
           <a:prstGeom prst="roundRect">
             <a:avLst>
@@ -15093,7 +14827,7 @@
         <p:spPr>
           <a:xfrm>
             <a:off x="533399" y="4514839"/>
-            <a:ext cx="769618" cy="209549"/>
+            <a:ext cx="2449824" cy="209549"/>
           </a:xfrm>
           <a:prstGeom prst="rect">
             <a:avLst/>
@@ -15117,7 +14851,7 @@
                 <a:ea typeface="페이퍼로지 8 ExtraBold" pitchFamily="34" charset="-122"/>
                 <a:cs typeface="페이퍼로지 8 ExtraBold" pitchFamily="34" charset="-120"/>
               </a:rPr>
-              <a:t>쇼츠 9:16</a:t>
+              <a:t>쇼츠 9:16 · 유튜브 16:9 · 인스타 1:1</a:t>
             </a:r>
             <a:endParaRPr lang="en-US" sz="800" dirty="0"/>
           </a:p>
@@ -15131,8 +14865,8 @@
         </p:nvSpPr>
         <p:spPr>
           <a:xfrm>
-            <a:off x="1360167" y="4514839"/>
-            <a:ext cx="849628" cy="209549"/>
+            <a:off x="533399" y="4800588"/>
+            <a:ext cx="1889755" cy="209549"/>
           </a:xfrm>
           <a:prstGeom prst="roundRect">
             <a:avLst>
@@ -15158,8 +14892,8 @@
         </p:nvSpPr>
         <p:spPr>
           <a:xfrm>
-            <a:off x="1360167" y="4514839"/>
-            <a:ext cx="849628" cy="209549"/>
+            <a:off x="533399" y="4800588"/>
+            <a:ext cx="1889755" cy="209549"/>
           </a:xfrm>
           <a:prstGeom prst="rect">
             <a:avLst/>
@@ -15183,7 +14917,7 @@
                 <a:ea typeface="페이퍼로지 8 ExtraBold" pitchFamily="34" charset="-122"/>
                 <a:cs typeface="페이퍼로지 8 ExtraBold" pitchFamily="34" charset="-120"/>
               </a:rPr>
-              <a:t>유튜브 16:9</a:t>
+              <a:t>짧게 2컷 · 기본 4컷 · 길게 7컷</a:t>
             </a:r>
             <a:endParaRPr lang="en-US" sz="800" dirty="0"/>
           </a:p>
@@ -15197,8 +14931,8 @@
         </p:nvSpPr>
         <p:spPr>
           <a:xfrm>
-            <a:off x="2266944" y="4514839"/>
-            <a:ext cx="769618" cy="209549"/>
+            <a:off x="2480304" y="4800588"/>
+            <a:ext cx="1889755" cy="209549"/>
           </a:xfrm>
           <a:prstGeom prst="roundRect">
             <a:avLst>
@@ -15206,11 +14940,11 @@
             </a:avLst>
           </a:prstGeom>
           <a:solidFill>
-            <a:srgbClr val="EAF1FC"/>
+            <a:srgbClr val="F5F8FC"/>
           </a:solidFill>
           <a:ln w="6350">
             <a:solidFill>
-              <a:srgbClr val="EAF1FC"/>
+              <a:srgbClr val="E3EAF4"/>
             </a:solidFill>
             <a:prstDash val="solid"/>
           </a:ln>
@@ -15224,8 +14958,8 @@
         </p:nvSpPr>
         <p:spPr>
           <a:xfrm>
-            <a:off x="2266944" y="4514839"/>
-            <a:ext cx="769618" cy="209549"/>
+            <a:off x="2480304" y="4800588"/>
+            <a:ext cx="1889755" cy="209549"/>
           </a:xfrm>
           <a:prstGeom prst="rect">
             <a:avLst/>
@@ -15243,13 +14977,13 @@
             <a:r>
               <a:rPr lang="en-US" sz="800" dirty="0">
                 <a:solidFill>
-                  <a:srgbClr val="1B468B"/>
-                </a:solidFill>
-                <a:latin typeface="페이퍼로지 8 ExtraBold" pitchFamily="34" charset="0"/>
-                <a:ea typeface="페이퍼로지 8 ExtraBold" pitchFamily="34" charset="-122"/>
-                <a:cs typeface="페이퍼로지 8 ExtraBold" pitchFamily="34" charset="-120"/>
-              </a:rPr>
-              <a:t>인스타 1:1</a:t>
+                  <a:srgbClr val="64748B"/>
+                </a:solidFill>
+                <a:latin typeface="페이퍼로지 8 ExtraBold" pitchFamily="34" charset="0"/>
+                <a:ea typeface="페이퍼로지 8 ExtraBold" pitchFamily="34" charset="-122"/>
+                <a:cs typeface="페이퍼로지 8 ExtraBold" pitchFamily="34" charset="-120"/>
+              </a:rPr>
+              <a:t>VEO 3.1 / Gemini Omni</a:t>
             </a:r>
             <a:endParaRPr lang="en-US" sz="800" dirty="0"/>
           </a:p>
@@ -15258,72 +14992,6 @@
       <p:sp>
         <p:nvSpPr>
           <p:cNvPr id="32" name="Shape 30"/>
-          <p:cNvSpPr/>
-          <p:nvPr/>
-        </p:nvSpPr>
-        <p:spPr>
-          <a:xfrm>
-            <a:off x="533399" y="4800588"/>
-            <a:ext cx="1569716" cy="209549"/>
-          </a:xfrm>
-          <a:prstGeom prst="roundRect">
-            <a:avLst>
-              <a:gd name="adj" fmla="val 43637"/>
-            </a:avLst>
-          </a:prstGeom>
-          <a:solidFill>
-            <a:srgbClr val="F5F8FC"/>
-          </a:solidFill>
-          <a:ln w="6350">
-            <a:solidFill>
-              <a:srgbClr val="E3EAF4"/>
-            </a:solidFill>
-            <a:prstDash val="solid"/>
-          </a:ln>
-        </p:spPr>
-      </p:sp>
-      <p:sp>
-        <p:nvSpPr>
-          <p:cNvPr id="33" name="Text 31"/>
-          <p:cNvSpPr txBox="1"/>
-          <p:nvPr/>
-        </p:nvSpPr>
-        <p:spPr>
-          <a:xfrm>
-            <a:off x="533399" y="4800588"/>
-            <a:ext cx="1569716" cy="209549"/>
-          </a:xfrm>
-          <a:prstGeom prst="rect">
-            <a:avLst/>
-          </a:prstGeom>
-          <a:noFill/>
-          <a:ln/>
-        </p:spPr>
-        <p:txBody>
-          <a:bodyPr wrap="square" lIns="0" tIns="0" rIns="0" bIns="0" rtlCol="0" anchor="ctr"/>
-          <a:lstStyle/>
-          <a:p>
-            <a:pPr algn="ctr" indent="0" marL="0">
-              <a:buNone/>
-            </a:pPr>
-            <a:r>
-              <a:rPr lang="en-US" sz="800" dirty="0">
-                <a:solidFill>
-                  <a:srgbClr val="64748B"/>
-                </a:solidFill>
-                <a:latin typeface="페이퍼로지 8 ExtraBold" pitchFamily="34" charset="0"/>
-                <a:ea typeface="페이퍼로지 8 ExtraBold" pitchFamily="34" charset="-122"/>
-                <a:cs typeface="페이퍼로지 8 ExtraBold" pitchFamily="34" charset="-120"/>
-              </a:rPr>
-              <a:t>배너 영상 · 시작/엔드 프레임</a:t>
-            </a:r>
-            <a:endParaRPr lang="en-US" sz="800" dirty="0"/>
-          </a:p>
-        </p:txBody>
-      </p:sp>
-      <p:sp>
-        <p:nvSpPr>
-          <p:cNvPr id="34" name="Shape 32"/>
           <p:cNvSpPr/>
           <p:nvPr/>
         </p:nvSpPr>
@@ -15348,7 +15016,7 @@
       </p:sp>
       <p:sp>
         <p:nvSpPr>
-          <p:cNvPr id="35" name="Shape 33"/>
+          <p:cNvPr id="33" name="Shape 31"/>
           <p:cNvSpPr/>
           <p:nvPr/>
         </p:nvSpPr>
@@ -15373,7 +15041,7 @@
       </p:sp>
       <p:sp>
         <p:nvSpPr>
-          <p:cNvPr id="36" name="Text 34"/>
+          <p:cNvPr id="34" name="Text 32"/>
           <p:cNvSpPr txBox="1"/>
           <p:nvPr/>
         </p:nvSpPr>
@@ -15412,7 +15080,7 @@
       </p:sp>
       <p:sp>
         <p:nvSpPr>
-          <p:cNvPr id="37" name="Text 35"/>
+          <p:cNvPr id="35" name="Text 33"/>
           <p:cNvSpPr txBox="1"/>
           <p:nvPr/>
         </p:nvSpPr>
@@ -15451,7 +15119,7 @@
       </p:sp>
       <p:sp>
         <p:nvSpPr>
-          <p:cNvPr id="38" name="Text 36"/>
+          <p:cNvPr id="36" name="Text 34"/>
           <p:cNvSpPr txBox="1"/>
           <p:nvPr/>
         </p:nvSpPr>
@@ -15490,7 +15158,7 @@
       </p:sp>
       <p:sp>
         <p:nvSpPr>
-          <p:cNvPr id="39" name="Shape 37"/>
+          <p:cNvPr id="37" name="Shape 35"/>
           <p:cNvSpPr/>
           <p:nvPr/>
         </p:nvSpPr>
@@ -15524,7 +15192,7 @@
       </p:sp>
       <p:pic>
         <p:nvPicPr>
-          <p:cNvPr id="40" name="Image 0" descr="/home/user/mplanit/ai-solution/assets/png/reels-idea.png">    </p:cNvPr>
+          <p:cNvPr id="38" name="Image 0" descr="/home/user/mplanit/ai-solution/assets/png/reels-idea.png">    </p:cNvPr>
           <p:cNvPicPr>
             <a:picLocks noChangeAspect="1"/>
           </p:cNvPicPr>
@@ -15548,7 +15216,7 @@
       </p:pic>
       <p:sp>
         <p:nvSpPr>
-          <p:cNvPr id="41" name="Shape 38"/>
+          <p:cNvPr id="39" name="Shape 36"/>
           <p:cNvSpPr/>
           <p:nvPr/>
         </p:nvSpPr>
@@ -15573,7 +15241,7 @@
       </p:sp>
       <p:sp>
         <p:nvSpPr>
-          <p:cNvPr id="42" name="Text 39"/>
+          <p:cNvPr id="40" name="Text 37"/>
           <p:cNvSpPr txBox="1"/>
           <p:nvPr/>
         </p:nvSpPr>
@@ -15612,7 +15280,7 @@
       </p:sp>
       <p:sp>
         <p:nvSpPr>
-          <p:cNvPr id="43" name="Shape 40"/>
+          <p:cNvPr id="41" name="Shape 38"/>
           <p:cNvSpPr/>
           <p:nvPr/>
         </p:nvSpPr>
@@ -15646,7 +15314,7 @@
       </p:sp>
       <p:pic>
         <p:nvPicPr>
-          <p:cNvPr id="44" name="Image 1" descr="/home/user/mplanit/ai-solution/assets/png/reels-style.png">    </p:cNvPr>
+          <p:cNvPr id="42" name="Image 1" descr="/home/user/mplanit/ai-solution/assets/png/reels-style.png">    </p:cNvPr>
           <p:cNvPicPr>
             <a:picLocks noChangeAspect="1"/>
           </p:cNvPicPr>
@@ -15670,7 +15338,7 @@
       </p:pic>
       <p:sp>
         <p:nvSpPr>
-          <p:cNvPr id="45" name="Shape 41"/>
+          <p:cNvPr id="43" name="Shape 39"/>
           <p:cNvSpPr/>
           <p:nvPr/>
         </p:nvSpPr>
@@ -15695,7 +15363,7 @@
       </p:sp>
       <p:sp>
         <p:nvSpPr>
-          <p:cNvPr id="46" name="Text 42"/>
+          <p:cNvPr id="44" name="Text 40"/>
           <p:cNvSpPr txBox="1"/>
           <p:nvPr/>
         </p:nvSpPr>
@@ -15734,7 +15402,7 @@
       </p:sp>
       <p:sp>
         <p:nvSpPr>
-          <p:cNvPr id="47" name="Shape 43"/>
+          <p:cNvPr id="45" name="Shape 41"/>
           <p:cNvSpPr/>
           <p:nvPr/>
         </p:nvSpPr>
@@ -15768,7 +15436,7 @@
       </p:sp>
       <p:pic>
         <p:nvPicPr>
-          <p:cNvPr id="48" name="Image 2" descr="/home/user/mplanit/ai-solution/assets/png/reels-video.png">    </p:cNvPr>
+          <p:cNvPr id="46" name="Image 2" descr="/home/user/mplanit/ai-solution/assets/png/reels-video.png">    </p:cNvPr>
           <p:cNvPicPr>
             <a:picLocks noChangeAspect="1"/>
           </p:cNvPicPr>
@@ -15792,7 +15460,7 @@
       </p:pic>
       <p:sp>
         <p:nvSpPr>
-          <p:cNvPr id="49" name="Shape 44"/>
+          <p:cNvPr id="47" name="Shape 42"/>
           <p:cNvSpPr/>
           <p:nvPr/>
         </p:nvSpPr>
@@ -15817,7 +15485,7 @@
       </p:sp>
       <p:sp>
         <p:nvSpPr>
-          <p:cNvPr id="50" name="Text 45"/>
+          <p:cNvPr id="48" name="Text 43"/>
           <p:cNvSpPr txBox="1"/>
           <p:nvPr/>
         </p:nvSpPr>
@@ -15856,7 +15524,7 @@
       </p:sp>
       <p:sp>
         <p:nvSpPr>
-          <p:cNvPr id="51" name="Shape 46"/>
+          <p:cNvPr id="49" name="Shape 44"/>
           <p:cNvSpPr/>
           <p:nvPr/>
         </p:nvSpPr>
@@ -15879,7 +15547,7 @@
       </p:sp>
       <p:sp>
         <p:nvSpPr>
-          <p:cNvPr id="52" name="Text 47"/>
+          <p:cNvPr id="50" name="Text 45"/>
           <p:cNvSpPr txBox="1"/>
           <p:nvPr/>
         </p:nvSpPr>
@@ -15918,7 +15586,7 @@
       </p:sp>
       <p:sp>
         <p:nvSpPr>
-          <p:cNvPr id="53" name="Text 48"/>
+          <p:cNvPr id="51" name="Text 46"/>
           <p:cNvSpPr txBox="1"/>
           <p:nvPr/>
         </p:nvSpPr>
@@ -15949,7 +15617,7 @@
                 <a:ea typeface="페이퍼로지 4 Regular" pitchFamily="34" charset="-122"/>
                 <a:cs typeface="페이퍼로지 4 Regular" pitchFamily="34" charset="-120"/>
               </a:rPr>
-              <a:t>05 / 09</a:t>
+              <a:t>05 / 08</a:t>
             </a:r>
             <a:endParaRPr lang="en-US" sz="800" dirty="0"/>
           </a:p>
@@ -16099,7 +15767,7 @@
                 <a:ea typeface="페이퍼로지 8 ExtraBold" pitchFamily="34" charset="-122"/>
                 <a:cs typeface="페이퍼로지 8 ExtraBold" pitchFamily="34" charset="-120"/>
               </a:rPr>
-              <a:t>AI LAB · GEO Metric Care — </a:t>
+              <a:t>GEO Metric Care — </a:t>
             </a:r>
             <a:pPr indent="0" marL="0">
               <a:buNone/>
@@ -16113,7 +15781,7 @@
                 <a:ea typeface="페이퍼로지 8 ExtraBold" pitchFamily="34" charset="-122"/>
                 <a:cs typeface="페이퍼로지 8 ExtraBold" pitchFamily="34" charset="-120"/>
               </a:rPr>
-              <a:t>AI 기반 SEO + GEO 통합 분석</a:t>
+              <a:t>브랜드 노출을 진단하고 개선하는 GEO 솔루션</a:t>
             </a:r>
             <a:endParaRPr lang="en-US" sz="2100" dirty="0"/>
           </a:p>
@@ -16152,7 +15820,7 @@
                 <a:ea typeface="페이퍼로지 4 Regular" pitchFamily="34" charset="-122"/>
                 <a:cs typeface="페이퍼로지 4 Regular" pitchFamily="34" charset="-120"/>
               </a:rPr>
-              <a:t>전통적인 SEO 점검과 AI 검색 최적화 분석을 한 번에 — 메타 태그 최적화 상태까지 점검</a:t>
+              <a:t>GEO — ChatGPT · 네이버 AI 등 AI 답변에 브랜드가 언급·추천되도록 최적화하는 전략</a:t>
             </a:r>
             <a:endParaRPr lang="en-US" sz="1000" dirty="0"/>
           </a:p>
@@ -16346,7 +16014,7 @@
                 <a:ea typeface="페이퍼로지 8 ExtraBold" pitchFamily="34" charset="-122"/>
                 <a:cs typeface="페이퍼로지 8 ExtraBold" pitchFamily="34" charset="-120"/>
               </a:rPr>
-              <a:t>점수 3종 진단</a:t>
+              <a:t>AI 가독성 진단</a:t>
             </a:r>
             <a:endParaRPr lang="en-US" sz="1100" dirty="0"/>
           </a:p>
@@ -16388,7 +16056,7 @@
                 <a:ea typeface="페이퍼로지 4 Regular" pitchFamily="34" charset="-122"/>
                 <a:cs typeface="페이퍼로지 4 Regular" pitchFamily="34" charset="-120"/>
               </a:rPr>
-              <a:t>종합 · SEO · GEO 동시 산출 — 자사 84 / 95 / 72</a:t>
+              <a:t>AI가 읽고 인용하기 쉬운 사이트인지 점검</a:t>
             </a:r>
             <a:endParaRPr lang="en-US" sz="900" dirty="0"/>
           </a:p>
@@ -16493,7 +16161,7 @@
                 <a:ea typeface="페이퍼로지 8 ExtraBold" pitchFamily="34" charset="-122"/>
                 <a:cs typeface="페이퍼로지 8 ExtraBold" pitchFamily="34" charset="-120"/>
               </a:rPr>
-              <a:t>판정 기준</a:t>
+              <a:t>네이버 AI 브리핑 대응</a:t>
             </a:r>
             <a:endParaRPr lang="en-US" sz="1100" dirty="0"/>
           </a:p>
@@ -16535,7 +16203,7 @@
                 <a:ea typeface="페이퍼로지 4 Regular" pitchFamily="34" charset="-122"/>
                 <a:cs typeface="페이퍼로지 4 Regular" pitchFamily="34" charset="-120"/>
               </a:rPr>
-              <a:t>80↑ 인용 가능 · 70점대 기본 · 60↓ 개선 필요</a:t>
+              <a:t>국내 고객 접점인 네이버 AI까지 통합 점검</a:t>
             </a:r>
             <a:endParaRPr lang="en-US" sz="900" dirty="0"/>
           </a:p>
@@ -16640,7 +16308,7 @@
                 <a:ea typeface="페이퍼로지 8 ExtraBold" pitchFamily="34" charset="-122"/>
                 <a:cs typeface="페이퍼로지 8 ExtraBold" pitchFamily="34" charset="-120"/>
               </a:rPr>
-              <a:t>진단 범위</a:t>
+              <a:t>브랜드 신뢰도 분석</a:t>
             </a:r>
             <a:endParaRPr lang="en-US" sz="1100" dirty="0"/>
           </a:p>
@@ -16682,7 +16350,7 @@
                 <a:ea typeface="페이퍼로지 4 Regular" pitchFamily="34" charset="-122"/>
                 <a:cs typeface="페이퍼로지 4 Regular" pitchFamily="34" charset="-120"/>
               </a:rPr>
-              <a:t>ChatGPT · Gemini · Perplexity · 네이버 AI 브리핑</a:t>
+              <a:t>홈페이지 · 블로그 · 카페 등 AI 참조 채널 분석</a:t>
             </a:r>
             <a:endParaRPr lang="en-US" sz="900" dirty="0"/>
           </a:p>
@@ -16787,7 +16455,7 @@
                 <a:ea typeface="페이퍼로지 8 ExtraBold" pitchFamily="34" charset="-122"/>
                 <a:cs typeface="페이퍼로지 8 ExtraBold" pitchFamily="34" charset="-120"/>
               </a:rPr>
-              <a:t>항목별 현재값 · 권장 기준</a:t>
+              <a:t>개선 가이드 제공</a:t>
             </a:r>
             <a:endParaRPr lang="en-US" sz="1100" dirty="0"/>
           </a:p>
@@ -16829,7 +16497,7 @@
                 <a:ea typeface="페이퍼로지 4 Regular" pitchFamily="34" charset="-122"/>
                 <a:cs typeface="페이퍼로지 4 Regular" pitchFamily="34" charset="-120"/>
               </a:rPr>
-              <a:t>인용 신뢰도 · 통계 포함 · 스키마 · 엔티티 연결성</a:t>
+              <a:t>노출 저해 요인 도출 → 개선 방향 제시</a:t>
             </a:r>
             <a:endParaRPr lang="en-US" sz="900" dirty="0"/>
           </a:p>
@@ -16918,7 +16586,7 @@
                 <a:ea typeface="페이퍼로지 8 ExtraBold" pitchFamily="34" charset="-122"/>
                 <a:cs typeface="페이퍼로지 8 ExtraBold" pitchFamily="34" charset="-120"/>
               </a:rPr>
-              <a:t>고객은 AI에게 묻고 있는데, 우리 브랜드는 AI 답변에 등장하고 있나요?</a:t>
+              <a:t>AI가 추천하는 브랜드, 지금 준비하세요</a:t>
             </a:r>
             <a:endParaRPr lang="en-US" sz="1000" dirty="0"/>
           </a:p>
@@ -16957,7 +16625,7 @@
                 <a:ea typeface="페이퍼로지 4 Regular" pitchFamily="34" charset="-122"/>
                 <a:cs typeface="페이퍼로지 4 Regular" pitchFamily="34" charset="-120"/>
               </a:rPr>
-              <a:t>엠플랜잇 AEO·GEO 개선 가이드(2026.09)</a:t>
+              <a:t>종합 · SEO · GEO 점수 진단 (80↑ 인용 가능 · 70점대 기본 · 60↓ 개선 필요)</a:t>
             </a:r>
             <a:endParaRPr lang="en-US" sz="750" dirty="0"/>
           </a:p>
@@ -17626,7 +17294,7 @@
                 <a:ea typeface="페이퍼로지 4 Regular" pitchFamily="34" charset="-122"/>
                 <a:cs typeface="페이퍼로지 4 Regular" pitchFamily="34" charset="-120"/>
               </a:rPr>
-              <a:t>AI LAB · GEO Metric Care Solution</a:t>
+              <a:t>AI LAB · GEO Metric Care Solution — 흥국화재 TM 제안 장표(2026.09) 기준</a:t>
             </a:r>
             <a:endParaRPr lang="en-US" sz="800" dirty="0"/>
           </a:p>
@@ -17665,7 +17333,7 @@
                 <a:ea typeface="페이퍼로지 4 Regular" pitchFamily="34" charset="-122"/>
                 <a:cs typeface="페이퍼로지 4 Regular" pitchFamily="34" charset="-120"/>
               </a:rPr>
-              <a:t>06 / 09</a:t>
+              <a:t>06 / 08</a:t>
             </a:r>
             <a:endParaRPr lang="en-US" sz="800" dirty="0"/>
           </a:p>
@@ -21173,7 +20841,7 @@
                 <a:ea typeface="페이퍼로지 4 Regular" pitchFamily="34" charset="-122"/>
                 <a:cs typeface="페이퍼로지 4 Regular" pitchFamily="34" charset="-120"/>
               </a:rPr>
-              <a:t>07 / 09</a:t>
+              <a:t>07 / 08</a:t>
             </a:r>
             <a:endParaRPr lang="en-US" sz="800" dirty="0"/>
           </a:p>
@@ -24249,1975 +23917,7 @@
                 <a:ea typeface="페이퍼로지 4 Regular" pitchFamily="34" charset="-122"/>
                 <a:cs typeface="페이퍼로지 4 Regular" pitchFamily="34" charset="-120"/>
               </a:rPr>
-              <a:t>08 / 09</a:t>
-            </a:r>
-            <a:endParaRPr lang="en-US" sz="800" dirty="0"/>
-          </a:p>
-        </p:txBody>
-      </p:sp>
-    </p:spTree>
-  </p:cSld>
-  <p:clrMapOvr>
-    <a:masterClrMapping/>
-  </p:clrMapOvr>
-</p:sld>
-</file>
-
-<file path=ppt/slides/slide9.xml><?xml version="1.0" encoding="utf-8"?>
-<p:sld xmlns:a="http://schemas.openxmlformats.org/drawingml/2006/main" xmlns:r="http://schemas.openxmlformats.org/officeDocument/2006/relationships" xmlns:p="http://schemas.openxmlformats.org/presentationml/2006/main">
-  <p:cSld name="Slide 9">
-    <p:bg>
-      <p:bgPr>
-        <a:solidFill>
-          <a:srgbClr val="FFFFFF"/>
-        </a:solidFill>
-      </p:bgPr>
-    </p:bg>
-    <p:spTree>
-      <p:nvGrpSpPr>
-        <p:cNvPr id="1" name=""/>
-        <p:cNvGrpSpPr/>
-        <p:nvPr/>
-      </p:nvGrpSpPr>
-      <p:grpSpPr>
-        <a:xfrm>
-          <a:off x="0" y="0"/>
-          <a:ext cx="0" cy="0"/>
-          <a:chOff x="0" y="0"/>
-          <a:chExt cx="0" cy="0"/>
-        </a:xfrm>
-      </p:grpSpPr>
-      <p:sp>
-        <p:nvSpPr>
-          <p:cNvPr id="2" name="Shape 0"/>
-          <p:cNvSpPr/>
-          <p:nvPr/>
-        </p:nvSpPr>
-        <p:spPr>
-          <a:xfrm>
-            <a:off x="0" y="0"/>
-            <a:ext cx="12191970" cy="47625"/>
-          </a:xfrm>
-          <a:prstGeom prst="rect">
-            <a:avLst/>
-          </a:prstGeom>
-          <a:solidFill>
-            <a:srgbClr val="1B468B"/>
-          </a:solidFill>
-          <a:ln/>
-        </p:spPr>
-      </p:sp>
-      <p:sp>
-        <p:nvSpPr>
-          <p:cNvPr id="3" name="Shape 1"/>
-          <p:cNvSpPr/>
-          <p:nvPr/>
-        </p:nvSpPr>
-        <p:spPr>
-          <a:xfrm>
-            <a:off x="5943600" y="0"/>
-            <a:ext cx="6248370" cy="47625"/>
-          </a:xfrm>
-          <a:prstGeom prst="rect">
-            <a:avLst/>
-          </a:prstGeom>
-          <a:solidFill>
-            <a:srgbClr val="399BC1"/>
-          </a:solidFill>
-          <a:ln/>
-        </p:spPr>
-      </p:sp>
-      <p:sp>
-        <p:nvSpPr>
-          <p:cNvPr id="4" name="Text 2"/>
-          <p:cNvSpPr txBox="1"/>
-          <p:nvPr/>
-        </p:nvSpPr>
-        <p:spPr>
-          <a:xfrm>
-            <a:off x="533399" y="419099"/>
-            <a:ext cx="6667483" cy="152400"/>
-          </a:xfrm>
-          <a:prstGeom prst="rect">
-            <a:avLst/>
-          </a:prstGeom>
-          <a:noFill/>
-          <a:ln/>
-        </p:spPr>
-        <p:txBody>
-          <a:bodyPr wrap="square" lIns="0" tIns="0" rIns="0" bIns="0" rtlCol="0" anchor="ctr"/>
-          <a:lstStyle/>
-          <a:p>
-            <a:pPr indent="0" marL="0">
-              <a:buNone/>
-            </a:pPr>
-            <a:r>
-              <a:rPr lang="en-US" sz="850" spc="200" kern="0" dirty="0">
-                <a:solidFill>
-                  <a:srgbClr val="399BC1"/>
-                </a:solidFill>
-                <a:latin typeface="페이퍼로지 8 ExtraBold" pitchFamily="34" charset="0"/>
-                <a:ea typeface="페이퍼로지 8 ExtraBold" pitchFamily="34" charset="-122"/>
-                <a:cs typeface="페이퍼로지 8 ExtraBold" pitchFamily="34" charset="-120"/>
-              </a:rPr>
-              <a:t>APPENDIX · 근거와 표기 기준</a:t>
-            </a:r>
-            <a:endParaRPr lang="en-US" sz="850" dirty="0"/>
-          </a:p>
-        </p:txBody>
-      </p:sp>
-      <p:sp>
-        <p:nvSpPr>
-          <p:cNvPr id="5" name="Text 3"/>
-          <p:cNvSpPr txBox="1"/>
-          <p:nvPr/>
-        </p:nvSpPr>
-        <p:spPr>
-          <a:xfrm>
-            <a:off x="533399" y="590549"/>
-            <a:ext cx="8953478" cy="323849"/>
-          </a:xfrm>
-          <a:prstGeom prst="rect">
-            <a:avLst/>
-          </a:prstGeom>
-          <a:noFill/>
-          <a:ln/>
-        </p:spPr>
-        <p:txBody>
-          <a:bodyPr wrap="square" lIns="0" tIns="0" rIns="0" bIns="0" rtlCol="0" anchor="ctr"/>
-          <a:lstStyle/>
-          <a:p>
-            <a:pPr indent="0" marL="0">
-              <a:buNone/>
-            </a:pPr>
-            <a:r>
-              <a:rPr lang="en-US" sz="2100" dirty="0">
-                <a:solidFill>
-                  <a:srgbClr val="0F1B2E"/>
-                </a:solidFill>
-                <a:latin typeface="페이퍼로지 8 ExtraBold" pitchFamily="34" charset="0"/>
-                <a:ea typeface="페이퍼로지 8 ExtraBold" pitchFamily="34" charset="-122"/>
-                <a:cs typeface="페이퍼로지 8 ExtraBold" pitchFamily="34" charset="-120"/>
-              </a:rPr>
-              <a:t>제공 범위와 표기 기준 — </a:t>
-            </a:r>
-            <a:pPr indent="0" marL="0">
-              <a:buNone/>
-            </a:pPr>
-            <a:r>
-              <a:rPr lang="en-US" sz="2100" dirty="0">
-                <a:solidFill>
-                  <a:srgbClr val="1B468B"/>
-                </a:solidFill>
-                <a:latin typeface="페이퍼로지 8 ExtraBold" pitchFamily="34" charset="0"/>
-                <a:ea typeface="페이퍼로지 8 ExtraBold" pitchFamily="34" charset="-122"/>
-                <a:cs typeface="페이퍼로지 8 ExtraBold" pitchFamily="34" charset="-120"/>
-              </a:rPr>
-              <a:t>과장 없이, 확인된 것만</a:t>
-            </a:r>
-            <a:endParaRPr lang="en-US" sz="2100" dirty="0"/>
-          </a:p>
-        </p:txBody>
-      </p:sp>
-      <p:sp>
-        <p:nvSpPr>
-          <p:cNvPr id="6" name="Text 4"/>
-          <p:cNvSpPr txBox="1"/>
-          <p:nvPr/>
-        </p:nvSpPr>
-        <p:spPr>
-          <a:xfrm>
-            <a:off x="533399" y="952498"/>
-            <a:ext cx="8953478" cy="171450"/>
-          </a:xfrm>
-          <a:prstGeom prst="rect">
-            <a:avLst/>
-          </a:prstGeom>
-          <a:noFill/>
-          <a:ln/>
-        </p:spPr>
-        <p:txBody>
-          <a:bodyPr wrap="square" lIns="0" tIns="0" rIns="0" bIns="0" rtlCol="0" anchor="ctr"/>
-          <a:lstStyle/>
-          <a:p>
-            <a:pPr indent="0" marL="0">
-              <a:buNone/>
-            </a:pPr>
-            <a:r>
-              <a:rPr lang="en-US" sz="1000" dirty="0">
-                <a:solidFill>
-                  <a:srgbClr val="64748B"/>
-                </a:solidFill>
-                <a:latin typeface="페이퍼로지 4 Regular" pitchFamily="34" charset="0"/>
-                <a:ea typeface="페이퍼로지 4 Regular" pitchFamily="34" charset="-122"/>
-                <a:cs typeface="페이퍼로지 4 Regular" pitchFamily="34" charset="-120"/>
-              </a:rPr>
-              <a:t>장표에 쓴 화면·수치·명칭의 출처와, 오해를 막기 위한 표기 원칙</a:t>
-            </a:r>
-            <a:endParaRPr lang="en-US" sz="1000" dirty="0"/>
-          </a:p>
-        </p:txBody>
-      </p:sp>
-      <p:sp>
-        <p:nvSpPr>
-          <p:cNvPr id="7" name="Shape 5"/>
-          <p:cNvSpPr/>
-          <p:nvPr/>
-        </p:nvSpPr>
-        <p:spPr>
-          <a:xfrm>
-            <a:off x="9048727" y="571499"/>
-            <a:ext cx="2609843" cy="247649"/>
-          </a:xfrm>
-          <a:prstGeom prst="roundRect">
-            <a:avLst>
-              <a:gd name="adj" fmla="val 44308"/>
-            </a:avLst>
-          </a:prstGeom>
-          <a:solidFill>
-            <a:srgbClr val="EAF1FC"/>
-          </a:solidFill>
-          <a:ln w="9525">
-            <a:solidFill>
-              <a:srgbClr val="CFDCEE"/>
-            </a:solidFill>
-            <a:prstDash val="solid"/>
-          </a:ln>
-        </p:spPr>
-      </p:sp>
-      <p:sp>
-        <p:nvSpPr>
-          <p:cNvPr id="8" name="Text 6"/>
-          <p:cNvSpPr txBox="1"/>
-          <p:nvPr/>
-        </p:nvSpPr>
-        <p:spPr>
-          <a:xfrm>
-            <a:off x="9048727" y="571499"/>
-            <a:ext cx="2609843" cy="247649"/>
-          </a:xfrm>
-          <a:prstGeom prst="rect">
-            <a:avLst/>
-          </a:prstGeom>
-          <a:noFill/>
-          <a:ln/>
-        </p:spPr>
-        <p:txBody>
-          <a:bodyPr wrap="square" lIns="0" tIns="0" rIns="0" bIns="0" rtlCol="0" anchor="ctr"/>
-          <a:lstStyle/>
-          <a:p>
-            <a:pPr algn="ctr" indent="0" marL="0">
-              <a:buNone/>
-            </a:pPr>
-            <a:r>
-              <a:rPr lang="en-US" sz="850" dirty="0">
-                <a:solidFill>
-                  <a:srgbClr val="1B468B"/>
-                </a:solidFill>
-                <a:latin typeface="페이퍼로지 8 ExtraBold" pitchFamily="34" charset="0"/>
-                <a:ea typeface="페이퍼로지 8 ExtraBold" pitchFamily="34" charset="-122"/>
-                <a:cs typeface="페이퍼로지 8 ExtraBold" pitchFamily="34" charset="-120"/>
-              </a:rPr>
-              <a:t>2026.09 기준</a:t>
-            </a:r>
-            <a:endParaRPr lang="en-US" sz="850" dirty="0"/>
-          </a:p>
-        </p:txBody>
-      </p:sp>
-      <p:sp>
-        <p:nvSpPr>
-          <p:cNvPr id="9" name="Shape 7"/>
-          <p:cNvSpPr/>
-          <p:nvPr/>
-        </p:nvSpPr>
-        <p:spPr>
-          <a:xfrm>
-            <a:off x="533399" y="1200147"/>
-            <a:ext cx="11125172" cy="0"/>
-          </a:xfrm>
-          <a:prstGeom prst="line">
-            <a:avLst/>
-          </a:prstGeom>
-          <a:noFill/>
-          <a:ln w="9525">
-            <a:solidFill>
-              <a:srgbClr val="E3EAF4"/>
-            </a:solidFill>
-            <a:prstDash val="solid"/>
-          </a:ln>
-        </p:spPr>
-      </p:sp>
-      <p:sp>
-        <p:nvSpPr>
-          <p:cNvPr id="10" name="Shape 8"/>
-          <p:cNvSpPr/>
-          <p:nvPr/>
-        </p:nvSpPr>
-        <p:spPr>
-          <a:xfrm>
-            <a:off x="533399" y="1447796"/>
-            <a:ext cx="5372087" cy="3390892"/>
-          </a:xfrm>
-          <a:prstGeom prst="roundRect">
-            <a:avLst>
-              <a:gd name="adj" fmla="val 1348"/>
-            </a:avLst>
-          </a:prstGeom>
-          <a:solidFill>
-            <a:srgbClr val="FBFDFF"/>
-          </a:solidFill>
-          <a:ln w="9525">
-            <a:solidFill>
-              <a:srgbClr val="E3EAF4"/>
-            </a:solidFill>
-            <a:prstDash val="solid"/>
-          </a:ln>
-        </p:spPr>
-      </p:sp>
-      <p:sp>
-        <p:nvSpPr>
-          <p:cNvPr id="11" name="Text 9"/>
-          <p:cNvSpPr txBox="1"/>
-          <p:nvPr/>
-        </p:nvSpPr>
-        <p:spPr>
-          <a:xfrm>
-            <a:off x="704848" y="1600196"/>
-            <a:ext cx="5029187" cy="190500"/>
-          </a:xfrm>
-          <a:prstGeom prst="rect">
-            <a:avLst/>
-          </a:prstGeom>
-          <a:noFill/>
-          <a:ln/>
-        </p:spPr>
-        <p:txBody>
-          <a:bodyPr wrap="square" lIns="0" tIns="0" rIns="0" bIns="0" rtlCol="0" anchor="ctr"/>
-          <a:lstStyle/>
-          <a:p>
-            <a:pPr indent="0" marL="0">
-              <a:buNone/>
-            </a:pPr>
-            <a:r>
-              <a:rPr lang="en-US" sz="1200" dirty="0">
-                <a:solidFill>
-                  <a:srgbClr val="0F1B2E"/>
-                </a:solidFill>
-                <a:latin typeface="페이퍼로지 8 ExtraBold" pitchFamily="34" charset="0"/>
-                <a:ea typeface="페이퍼로지 8 ExtraBold" pitchFamily="34" charset="-122"/>
-                <a:cs typeface="페이퍼로지 8 ExtraBold" pitchFamily="34" charset="-120"/>
-              </a:rPr>
-              <a:t>자료 근거</a:t>
-            </a:r>
-            <a:endParaRPr lang="en-US" sz="1200" dirty="0"/>
-          </a:p>
-        </p:txBody>
-      </p:sp>
-      <p:sp>
-        <p:nvSpPr>
-          <p:cNvPr id="12" name="Text 10"/>
-          <p:cNvSpPr txBox="1"/>
-          <p:nvPr/>
-        </p:nvSpPr>
-        <p:spPr>
-          <a:xfrm>
-            <a:off x="704848" y="1809745"/>
-            <a:ext cx="5029187" cy="152400"/>
-          </a:xfrm>
-          <a:prstGeom prst="rect">
-            <a:avLst/>
-          </a:prstGeom>
-          <a:noFill/>
-          <a:ln/>
-        </p:spPr>
-        <p:txBody>
-          <a:bodyPr wrap="square" lIns="0" tIns="0" rIns="0" bIns="0" rtlCol="0" anchor="ctr"/>
-          <a:lstStyle/>
-          <a:p>
-            <a:pPr indent="0" marL="0">
-              <a:buNone/>
-            </a:pPr>
-            <a:r>
-              <a:rPr lang="en-US" sz="850" dirty="0">
-                <a:solidFill>
-                  <a:srgbClr val="64748B"/>
-                </a:solidFill>
-                <a:latin typeface="페이퍼로지 4 Regular" pitchFamily="34" charset="0"/>
-                <a:ea typeface="페이퍼로지 4 Regular" pitchFamily="34" charset="-122"/>
-                <a:cs typeface="페이퍼로지 4 Regular" pitchFamily="34" charset="-120"/>
-              </a:rPr>
-              <a:t>이 장표에 쓰인 화면과 수치의 출처</a:t>
-            </a:r>
-            <a:endParaRPr lang="en-US" sz="850" dirty="0"/>
-          </a:p>
-        </p:txBody>
-      </p:sp>
-      <p:sp>
-        <p:nvSpPr>
-          <p:cNvPr id="13" name="Text 11"/>
-          <p:cNvSpPr txBox="1"/>
-          <p:nvPr/>
-        </p:nvSpPr>
-        <p:spPr>
-          <a:xfrm>
-            <a:off x="704848" y="2057395"/>
-            <a:ext cx="5029187" cy="361949"/>
-          </a:xfrm>
-          <a:prstGeom prst="rect">
-            <a:avLst/>
-          </a:prstGeom>
-          <a:noFill/>
-          <a:ln/>
-        </p:spPr>
-        <p:txBody>
-          <a:bodyPr wrap="square" lIns="0" tIns="0" rIns="0" bIns="0" rtlCol="0" anchor="ctr"/>
-          <a:lstStyle/>
-          <a:p>
-            <a:pPr indent="0" marL="0">
-              <a:lnSpc>
-                <a:spcPct val="125000"/>
-              </a:lnSpc>
-              <a:buNone/>
-            </a:pPr>
-            <a:r>
-              <a:rPr lang="en-US" sz="800" dirty="0">
-                <a:solidFill>
-                  <a:srgbClr val="399BC1"/>
-                </a:solidFill>
-                <a:latin typeface="페이퍼로지 8 ExtraBold" pitchFamily="34" charset="0"/>
-                <a:ea typeface="페이퍼로지 8 ExtraBold" pitchFamily="34" charset="-122"/>
-                <a:cs typeface="페이퍼로지 8 ExtraBold" pitchFamily="34" charset="-120"/>
-              </a:rPr>
-              <a:t>·  </a:t>
-            </a:r>
-            <a:pPr indent="0" marL="0">
-              <a:lnSpc>
-                <a:spcPct val="125000"/>
-              </a:lnSpc>
-              <a:buNone/>
-            </a:pPr>
-            <a:r>
-              <a:rPr lang="en-US" sz="800" dirty="0">
-                <a:solidFill>
-                  <a:srgbClr val="1B468B"/>
-                </a:solidFill>
-                <a:latin typeface="페이퍼로지 8 ExtraBold" pitchFamily="34" charset="0"/>
-                <a:ea typeface="페이퍼로지 8 ExtraBold" pitchFamily="34" charset="-122"/>
-                <a:cs typeface="페이퍼로지 8 ExtraBold" pitchFamily="34" charset="-120"/>
-              </a:rPr>
-              <a:t>제품 화면 — </a:t>
-            </a:r>
-            <a:pPr indent="0" marL="0">
-              <a:lnSpc>
-                <a:spcPct val="125000"/>
-              </a:lnSpc>
-              <a:buNone/>
-            </a:pPr>
-            <a:r>
-              <a:rPr lang="en-US" sz="800" dirty="0">
-                <a:solidFill>
-                  <a:srgbClr val="334155"/>
-                </a:solidFill>
-                <a:latin typeface="페이퍼로지 4 Regular" pitchFamily="34" charset="0"/>
-                <a:ea typeface="페이퍼로지 4 Regular" pitchFamily="34" charset="-122"/>
-                <a:cs typeface="페이퍼로지 4 Regular" pitchFamily="34" charset="-120"/>
-              </a:rPr>
-              <a:t>사내 솔루션 소개 PPTX(배너핏 3장 · 릴스 스튜디오 4장 · GEO 2장), AD_report 화면 4종, 커머스허브 캡처</a:t>
-            </a:r>
-            <a:endParaRPr lang="en-US" sz="800" dirty="0"/>
-          </a:p>
-        </p:txBody>
-      </p:sp>
-      <p:sp>
-        <p:nvSpPr>
-          <p:cNvPr id="14" name="Text 12"/>
-          <p:cNvSpPr txBox="1"/>
-          <p:nvPr/>
-        </p:nvSpPr>
-        <p:spPr>
-          <a:xfrm>
-            <a:off x="704848" y="2457444"/>
-            <a:ext cx="5029187" cy="361949"/>
-          </a:xfrm>
-          <a:prstGeom prst="rect">
-            <a:avLst/>
-          </a:prstGeom>
-          <a:noFill/>
-          <a:ln/>
-        </p:spPr>
-        <p:txBody>
-          <a:bodyPr wrap="square" lIns="0" tIns="0" rIns="0" bIns="0" rtlCol="0" anchor="ctr"/>
-          <a:lstStyle/>
-          <a:p>
-            <a:pPr indent="0" marL="0">
-              <a:lnSpc>
-                <a:spcPct val="125000"/>
-              </a:lnSpc>
-              <a:buNone/>
-            </a:pPr>
-            <a:r>
-              <a:rPr lang="en-US" sz="800" dirty="0">
-                <a:solidFill>
-                  <a:srgbClr val="399BC1"/>
-                </a:solidFill>
-                <a:latin typeface="페이퍼로지 8 ExtraBold" pitchFamily="34" charset="0"/>
-                <a:ea typeface="페이퍼로지 8 ExtraBold" pitchFamily="34" charset="-122"/>
-                <a:cs typeface="페이퍼로지 8 ExtraBold" pitchFamily="34" charset="-120"/>
-              </a:rPr>
-              <a:t>·  </a:t>
-            </a:r>
-            <a:pPr indent="0" marL="0">
-              <a:lnSpc>
-                <a:spcPct val="125000"/>
-              </a:lnSpc>
-              <a:buNone/>
-            </a:pPr>
-            <a:r>
-              <a:rPr lang="en-US" sz="800" dirty="0">
-                <a:solidFill>
-                  <a:srgbClr val="1B468B"/>
-                </a:solidFill>
-                <a:latin typeface="페이퍼로지 8 ExtraBold" pitchFamily="34" charset="0"/>
-                <a:ea typeface="페이퍼로지 8 ExtraBold" pitchFamily="34" charset="-122"/>
-                <a:cs typeface="페이퍼로지 8 ExtraBold" pitchFamily="34" charset="-120"/>
-              </a:rPr>
-              <a:t>연동 사양 — </a:t>
-            </a:r>
-            <a:pPr indent="0" marL="0">
-              <a:lnSpc>
-                <a:spcPct val="125000"/>
-              </a:lnSpc>
-              <a:buNone/>
-            </a:pPr>
-            <a:r>
-              <a:rPr lang="en-US" sz="800" dirty="0">
-                <a:solidFill>
-                  <a:srgbClr val="334155"/>
-                </a:solidFill>
-                <a:latin typeface="페이퍼로지 4 Regular" pitchFamily="34" charset="0"/>
-                <a:ea typeface="페이퍼로지 4 Regular" pitchFamily="34" charset="-122"/>
-                <a:cs typeface="페이퍼로지 4 Regular" pitchFamily="34" charset="-120"/>
-              </a:rPr>
-              <a:t>카카오쇼핑 API 서비스소개서(판매 채널 7 · 광고 매체 14 · 수집 주기)</a:t>
-            </a:r>
-            <a:endParaRPr lang="en-US" sz="800" dirty="0"/>
-          </a:p>
-        </p:txBody>
-      </p:sp>
-      <p:sp>
-        <p:nvSpPr>
-          <p:cNvPr id="15" name="Text 13"/>
-          <p:cNvSpPr txBox="1"/>
-          <p:nvPr/>
-        </p:nvSpPr>
-        <p:spPr>
-          <a:xfrm>
-            <a:off x="704848" y="2857493"/>
-            <a:ext cx="5029187" cy="361949"/>
-          </a:xfrm>
-          <a:prstGeom prst="rect">
-            <a:avLst/>
-          </a:prstGeom>
-          <a:noFill/>
-          <a:ln/>
-        </p:spPr>
-        <p:txBody>
-          <a:bodyPr wrap="square" lIns="0" tIns="0" rIns="0" bIns="0" rtlCol="0" anchor="ctr"/>
-          <a:lstStyle/>
-          <a:p>
-            <a:pPr indent="0" marL="0">
-              <a:lnSpc>
-                <a:spcPct val="125000"/>
-              </a:lnSpc>
-              <a:buNone/>
-            </a:pPr>
-            <a:r>
-              <a:rPr lang="en-US" sz="800" dirty="0">
-                <a:solidFill>
-                  <a:srgbClr val="399BC1"/>
-                </a:solidFill>
-                <a:latin typeface="페이퍼로지 8 ExtraBold" pitchFamily="34" charset="0"/>
-                <a:ea typeface="페이퍼로지 8 ExtraBold" pitchFamily="34" charset="-122"/>
-                <a:cs typeface="페이퍼로지 8 ExtraBold" pitchFamily="34" charset="-120"/>
-              </a:rPr>
-              <a:t>·  </a:t>
-            </a:r>
-            <a:pPr indent="0" marL="0">
-              <a:lnSpc>
-                <a:spcPct val="125000"/>
-              </a:lnSpc>
-              <a:buNone/>
-            </a:pPr>
-            <a:r>
-              <a:rPr lang="en-US" sz="800" dirty="0">
-                <a:solidFill>
-                  <a:srgbClr val="1B468B"/>
-                </a:solidFill>
-                <a:latin typeface="페이퍼로지 8 ExtraBold" pitchFamily="34" charset="0"/>
-                <a:ea typeface="페이퍼로지 8 ExtraBold" pitchFamily="34" charset="-122"/>
-                <a:cs typeface="페이퍼로지 8 ExtraBold" pitchFamily="34" charset="-120"/>
-              </a:rPr>
-              <a:t>GEO 기준 — </a:t>
-            </a:r>
-            <a:pPr indent="0" marL="0">
-              <a:lnSpc>
-                <a:spcPct val="125000"/>
-              </a:lnSpc>
-              <a:buNone/>
-            </a:pPr>
-            <a:r>
-              <a:rPr lang="en-US" sz="800" dirty="0">
-                <a:solidFill>
-                  <a:srgbClr val="334155"/>
-                </a:solidFill>
-                <a:latin typeface="페이퍼로지 4 Regular" pitchFamily="34" charset="0"/>
-                <a:ea typeface="페이퍼로지 4 Regular" pitchFamily="34" charset="-122"/>
-                <a:cs typeface="페이퍼로지 4 Regular" pitchFamily="34" charset="-120"/>
-              </a:rPr>
-              <a:t>AI 최적화 GEO 가이드(AX본부): 점수 해석 · 3대 리스크 · 개선 우선순위</a:t>
-            </a:r>
-            <a:endParaRPr lang="en-US" sz="800" dirty="0"/>
-          </a:p>
-        </p:txBody>
-      </p:sp>
-      <p:sp>
-        <p:nvSpPr>
-          <p:cNvPr id="16" name="Text 14"/>
-          <p:cNvSpPr txBox="1"/>
-          <p:nvPr/>
-        </p:nvSpPr>
-        <p:spPr>
-          <a:xfrm>
-            <a:off x="704848" y="3257542"/>
-            <a:ext cx="5029187" cy="361949"/>
-          </a:xfrm>
-          <a:prstGeom prst="rect">
-            <a:avLst/>
-          </a:prstGeom>
-          <a:noFill/>
-          <a:ln/>
-        </p:spPr>
-        <p:txBody>
-          <a:bodyPr wrap="square" lIns="0" tIns="0" rIns="0" bIns="0" rtlCol="0" anchor="ctr"/>
-          <a:lstStyle/>
-          <a:p>
-            <a:pPr indent="0" marL="0">
-              <a:lnSpc>
-                <a:spcPct val="125000"/>
-              </a:lnSpc>
-              <a:buNone/>
-            </a:pPr>
-            <a:r>
-              <a:rPr lang="en-US" sz="800" dirty="0">
-                <a:solidFill>
-                  <a:srgbClr val="399BC1"/>
-                </a:solidFill>
-                <a:latin typeface="페이퍼로지 8 ExtraBold" pitchFamily="34" charset="0"/>
-                <a:ea typeface="페이퍼로지 8 ExtraBold" pitchFamily="34" charset="-122"/>
-                <a:cs typeface="페이퍼로지 8 ExtraBold" pitchFamily="34" charset="-120"/>
-              </a:rPr>
-              <a:t>·  </a:t>
-            </a:r>
-            <a:pPr indent="0" marL="0">
-              <a:lnSpc>
-                <a:spcPct val="125000"/>
-              </a:lnSpc>
-              <a:buNone/>
-            </a:pPr>
-            <a:r>
-              <a:rPr lang="en-US" sz="800" dirty="0">
-                <a:solidFill>
-                  <a:srgbClr val="1B468B"/>
-                </a:solidFill>
-                <a:latin typeface="페이퍼로지 8 ExtraBold" pitchFamily="34" charset="0"/>
-                <a:ea typeface="페이퍼로지 8 ExtraBold" pitchFamily="34" charset="-122"/>
-                <a:cs typeface="페이퍼로지 8 ExtraBold" pitchFamily="34" charset="-120"/>
-              </a:rPr>
-              <a:t>MI — </a:t>
-            </a:r>
-            <a:pPr indent="0" marL="0">
-              <a:lnSpc>
-                <a:spcPct val="125000"/>
-              </a:lnSpc>
-              <a:buNone/>
-            </a:pPr>
-            <a:r>
-              <a:rPr lang="en-US" sz="800" dirty="0">
-                <a:solidFill>
-                  <a:srgbClr val="334155"/>
-                </a:solidFill>
-                <a:latin typeface="페이퍼로지 4 Regular" pitchFamily="34" charset="0"/>
-                <a:ea typeface="페이퍼로지 4 Regular" pitchFamily="34" charset="-122"/>
-                <a:cs typeface="페이퍼로지 4 Regular" pitchFamily="34" charset="-120"/>
-              </a:rPr>
-              <a:t>사내 제공 정보(네이버 자동입찰 · 대량 통합 리포트). 공식 Solution 페이지는 M Ai Platform · MARS로 소개</a:t>
-            </a:r>
-            <a:endParaRPr lang="en-US" sz="800" dirty="0"/>
-          </a:p>
-        </p:txBody>
-      </p:sp>
-      <p:sp>
-        <p:nvSpPr>
-          <p:cNvPr id="17" name="Text 15"/>
-          <p:cNvSpPr txBox="1"/>
-          <p:nvPr/>
-        </p:nvSpPr>
-        <p:spPr>
-          <a:xfrm>
-            <a:off x="704848" y="3657591"/>
-            <a:ext cx="5029187" cy="361949"/>
-          </a:xfrm>
-          <a:prstGeom prst="rect">
-            <a:avLst/>
-          </a:prstGeom>
-          <a:noFill/>
-          <a:ln/>
-        </p:spPr>
-        <p:txBody>
-          <a:bodyPr wrap="square" lIns="0" tIns="0" rIns="0" bIns="0" rtlCol="0" anchor="ctr"/>
-          <a:lstStyle/>
-          <a:p>
-            <a:pPr indent="0" marL="0">
-              <a:lnSpc>
-                <a:spcPct val="125000"/>
-              </a:lnSpc>
-              <a:buNone/>
-            </a:pPr>
-            <a:r>
-              <a:rPr lang="en-US" sz="800" dirty="0">
-                <a:solidFill>
-                  <a:srgbClr val="399BC1"/>
-                </a:solidFill>
-                <a:latin typeface="페이퍼로지 8 ExtraBold" pitchFamily="34" charset="0"/>
-                <a:ea typeface="페이퍼로지 8 ExtraBold" pitchFamily="34" charset="-122"/>
-                <a:cs typeface="페이퍼로지 8 ExtraBold" pitchFamily="34" charset="-120"/>
-              </a:rPr>
-              <a:t>·  </a:t>
-            </a:r>
-            <a:pPr indent="0" marL="0">
-              <a:lnSpc>
-                <a:spcPct val="125000"/>
-              </a:lnSpc>
-              <a:buNone/>
-            </a:pPr>
-            <a:r>
-              <a:rPr lang="en-US" sz="800" dirty="0">
-                <a:solidFill>
-                  <a:srgbClr val="1B468B"/>
-                </a:solidFill>
-                <a:latin typeface="페이퍼로지 8 ExtraBold" pitchFamily="34" charset="0"/>
-                <a:ea typeface="페이퍼로지 8 ExtraBold" pitchFamily="34" charset="-122"/>
-                <a:cs typeface="페이퍼로지 8 ExtraBold" pitchFamily="34" charset="-120"/>
-              </a:rPr>
-              <a:t>시장 수치 — </a:t>
-            </a:r>
-            <a:pPr indent="0" marL="0">
-              <a:lnSpc>
-                <a:spcPct val="125000"/>
-              </a:lnSpc>
-              <a:buNone/>
-            </a:pPr>
-            <a:r>
-              <a:rPr lang="en-US" sz="800" dirty="0">
-                <a:solidFill>
-                  <a:srgbClr val="334155"/>
-                </a:solidFill>
-                <a:latin typeface="페이퍼로지 4 Regular" pitchFamily="34" charset="0"/>
-                <a:ea typeface="페이퍼로지 4 Regular" pitchFamily="34" charset="-122"/>
-                <a:cs typeface="페이퍼로지 4 Regular" pitchFamily="34" charset="-120"/>
-              </a:rPr>
-              <a:t>OpenAI(2026.07) · Similarweb AI Search Stats 2026 · 국내 광고업계 보도 · 크몽 숏폼 단가 가이드</a:t>
-            </a:r>
-            <a:endParaRPr lang="en-US" sz="800" dirty="0"/>
-          </a:p>
-        </p:txBody>
-      </p:sp>
-      <p:sp>
-        <p:nvSpPr>
-          <p:cNvPr id="18" name="Text 16"/>
-          <p:cNvSpPr txBox="1"/>
-          <p:nvPr/>
-        </p:nvSpPr>
-        <p:spPr>
-          <a:xfrm>
-            <a:off x="704848" y="4057640"/>
-            <a:ext cx="5029187" cy="361949"/>
-          </a:xfrm>
-          <a:prstGeom prst="rect">
-            <a:avLst/>
-          </a:prstGeom>
-          <a:noFill/>
-          <a:ln/>
-        </p:spPr>
-        <p:txBody>
-          <a:bodyPr wrap="square" lIns="0" tIns="0" rIns="0" bIns="0" rtlCol="0" anchor="ctr"/>
-          <a:lstStyle/>
-          <a:p>
-            <a:pPr indent="0" marL="0">
-              <a:lnSpc>
-                <a:spcPct val="125000"/>
-              </a:lnSpc>
-              <a:buNone/>
-            </a:pPr>
-            <a:r>
-              <a:rPr lang="en-US" sz="800" dirty="0">
-                <a:solidFill>
-                  <a:srgbClr val="399BC1"/>
-                </a:solidFill>
-                <a:latin typeface="페이퍼로지 8 ExtraBold" pitchFamily="34" charset="0"/>
-                <a:ea typeface="페이퍼로지 8 ExtraBold" pitchFamily="34" charset="-122"/>
-                <a:cs typeface="페이퍼로지 8 ExtraBold" pitchFamily="34" charset="-120"/>
-              </a:rPr>
-              <a:t>·  </a:t>
-            </a:r>
-            <a:pPr indent="0" marL="0">
-              <a:lnSpc>
-                <a:spcPct val="125000"/>
-              </a:lnSpc>
-              <a:buNone/>
-            </a:pPr>
-            <a:r>
-              <a:rPr lang="en-US" sz="800" dirty="0">
-                <a:solidFill>
-                  <a:srgbClr val="1B468B"/>
-                </a:solidFill>
-                <a:latin typeface="페이퍼로지 8 ExtraBold" pitchFamily="34" charset="0"/>
-                <a:ea typeface="페이퍼로지 8 ExtraBold" pitchFamily="34" charset="-122"/>
-                <a:cs typeface="페이퍼로지 8 ExtraBold" pitchFamily="34" charset="-120"/>
-              </a:rPr>
-              <a:t>공개 프로젝트 · 파트너 — </a:t>
-            </a:r>
-            <a:pPr indent="0" marL="0">
-              <a:lnSpc>
-                <a:spcPct val="125000"/>
-              </a:lnSpc>
-              <a:buNone/>
-            </a:pPr>
-            <a:r>
-              <a:rPr lang="en-US" sz="800" dirty="0">
-                <a:solidFill>
-                  <a:srgbClr val="334155"/>
-                </a:solidFill>
-                <a:latin typeface="페이퍼로지 4 Regular" pitchFamily="34" charset="0"/>
-                <a:ea typeface="페이퍼로지 4 Regular" pitchFamily="34" charset="-122"/>
-                <a:cs typeface="페이퍼로지 4 Regular" pitchFamily="34" charset="-120"/>
-              </a:rPr>
-              <a:t>엠플랜잇 공식 홈페이지 공개 기준</a:t>
-            </a:r>
-            <a:endParaRPr lang="en-US" sz="800" dirty="0"/>
-          </a:p>
-        </p:txBody>
-      </p:sp>
-      <p:sp>
-        <p:nvSpPr>
-          <p:cNvPr id="19" name="Shape 17"/>
-          <p:cNvSpPr/>
-          <p:nvPr/>
-        </p:nvSpPr>
-        <p:spPr>
-          <a:xfrm>
-            <a:off x="6286484" y="1447796"/>
-            <a:ext cx="5372087" cy="3390892"/>
-          </a:xfrm>
-          <a:prstGeom prst="roundRect">
-            <a:avLst>
-              <a:gd name="adj" fmla="val 1348"/>
-            </a:avLst>
-          </a:prstGeom>
-          <a:solidFill>
-            <a:srgbClr val="FFFBF5"/>
-          </a:solidFill>
-          <a:ln w="9525">
-            <a:solidFill>
-              <a:srgbClr val="F0E2CC"/>
-            </a:solidFill>
-            <a:prstDash val="solid"/>
-          </a:ln>
-        </p:spPr>
-      </p:sp>
-      <p:sp>
-        <p:nvSpPr>
-          <p:cNvPr id="20" name="Text 18"/>
-          <p:cNvSpPr txBox="1"/>
-          <p:nvPr/>
-        </p:nvSpPr>
-        <p:spPr>
-          <a:xfrm>
-            <a:off x="6457934" y="1600196"/>
-            <a:ext cx="5029187" cy="190500"/>
-          </a:xfrm>
-          <a:prstGeom prst="rect">
-            <a:avLst/>
-          </a:prstGeom>
-          <a:noFill/>
-          <a:ln/>
-        </p:spPr>
-        <p:txBody>
-          <a:bodyPr wrap="square" lIns="0" tIns="0" rIns="0" bIns="0" rtlCol="0" anchor="ctr"/>
-          <a:lstStyle/>
-          <a:p>
-            <a:pPr indent="0" marL="0">
-              <a:buNone/>
-            </a:pPr>
-            <a:r>
-              <a:rPr lang="en-US" sz="1200" dirty="0">
-                <a:solidFill>
-                  <a:srgbClr val="0F1B2E"/>
-                </a:solidFill>
-                <a:latin typeface="페이퍼로지 8 ExtraBold" pitchFamily="34" charset="0"/>
-                <a:ea typeface="페이퍼로지 8 ExtraBold" pitchFamily="34" charset="-122"/>
-                <a:cs typeface="페이퍼로지 8 ExtraBold" pitchFamily="34" charset="-120"/>
-              </a:rPr>
-              <a:t>표기 기준</a:t>
-            </a:r>
-            <a:endParaRPr lang="en-US" sz="1200" dirty="0"/>
-          </a:p>
-        </p:txBody>
-      </p:sp>
-      <p:sp>
-        <p:nvSpPr>
-          <p:cNvPr id="21" name="Text 19"/>
-          <p:cNvSpPr txBox="1"/>
-          <p:nvPr/>
-        </p:nvSpPr>
-        <p:spPr>
-          <a:xfrm>
-            <a:off x="6457934" y="1809745"/>
-            <a:ext cx="5029187" cy="152400"/>
-          </a:xfrm>
-          <a:prstGeom prst="rect">
-            <a:avLst/>
-          </a:prstGeom>
-          <a:noFill/>
-          <a:ln/>
-        </p:spPr>
-        <p:txBody>
-          <a:bodyPr wrap="square" lIns="0" tIns="0" rIns="0" bIns="0" rtlCol="0" anchor="ctr"/>
-          <a:lstStyle/>
-          <a:p>
-            <a:pPr indent="0" marL="0">
-              <a:buNone/>
-            </a:pPr>
-            <a:r>
-              <a:rPr lang="en-US" sz="850" dirty="0">
-                <a:solidFill>
-                  <a:srgbClr val="64748B"/>
-                </a:solidFill>
-                <a:latin typeface="페이퍼로지 4 Regular" pitchFamily="34" charset="0"/>
-                <a:ea typeface="페이퍼로지 4 Regular" pitchFamily="34" charset="-122"/>
-                <a:cs typeface="페이퍼로지 4 Regular" pitchFamily="34" charset="-120"/>
-              </a:rPr>
-              <a:t>제안·설명 시 지켜야 할 범위</a:t>
-            </a:r>
-            <a:endParaRPr lang="en-US" sz="850" dirty="0"/>
-          </a:p>
-        </p:txBody>
-      </p:sp>
-      <p:sp>
-        <p:nvSpPr>
-          <p:cNvPr id="22" name="Text 20"/>
-          <p:cNvSpPr txBox="1"/>
-          <p:nvPr/>
-        </p:nvSpPr>
-        <p:spPr>
-          <a:xfrm>
-            <a:off x="6457934" y="2057395"/>
-            <a:ext cx="5029187" cy="361949"/>
-          </a:xfrm>
-          <a:prstGeom prst="rect">
-            <a:avLst/>
-          </a:prstGeom>
-          <a:noFill/>
-          <a:ln/>
-        </p:spPr>
-        <p:txBody>
-          <a:bodyPr wrap="square" lIns="0" tIns="0" rIns="0" bIns="0" rtlCol="0" anchor="ctr"/>
-          <a:lstStyle/>
-          <a:p>
-            <a:pPr indent="0" marL="0">
-              <a:lnSpc>
-                <a:spcPct val="125000"/>
-              </a:lnSpc>
-              <a:buNone/>
-            </a:pPr>
-            <a:r>
-              <a:rPr lang="en-US" sz="800" dirty="0">
-                <a:solidFill>
-                  <a:srgbClr val="D97706"/>
-                </a:solidFill>
-                <a:latin typeface="페이퍼로지 8 ExtraBold" pitchFamily="34" charset="0"/>
-                <a:ea typeface="페이퍼로지 8 ExtraBold" pitchFamily="34" charset="-122"/>
-                <a:cs typeface="페이퍼로지 8 ExtraBold" pitchFamily="34" charset="-120"/>
-              </a:rPr>
-              <a:t>!  </a:t>
-            </a:r>
-            <a:pPr indent="0" marL="0">
-              <a:lnSpc>
-                <a:spcPct val="125000"/>
-              </a:lnSpc>
-              <a:buNone/>
-            </a:pPr>
-            <a:r>
-              <a:rPr lang="en-US" sz="800" dirty="0">
-                <a:solidFill>
-                  <a:srgbClr val="1B468B"/>
-                </a:solidFill>
-                <a:latin typeface="페이퍼로지 8 ExtraBold" pitchFamily="34" charset="0"/>
-                <a:ea typeface="페이퍼로지 8 ExtraBold" pitchFamily="34" charset="-122"/>
-                <a:cs typeface="페이퍼로지 8 ExtraBold" pitchFamily="34" charset="-120"/>
-              </a:rPr>
-              <a:t>전체 구조도는 서비스 포트폴리오입니다 — </a:t>
-            </a:r>
-            <a:pPr indent="0" marL="0">
-              <a:lnSpc>
-                <a:spcPct val="125000"/>
-              </a:lnSpc>
-              <a:buNone/>
-            </a:pPr>
-            <a:r>
-              <a:rPr lang="en-US" sz="800" dirty="0">
-                <a:solidFill>
-                  <a:srgbClr val="334155"/>
-                </a:solidFill>
-                <a:latin typeface="페이퍼로지 4 Regular" pitchFamily="34" charset="0"/>
-                <a:ea typeface="페이퍼로지 4 Regular" pitchFamily="34" charset="-122"/>
-                <a:cs typeface="페이퍼로지 4 Regular" pitchFamily="34" charset="-120"/>
-              </a:rPr>
-              <a:t>솔루션 간 자동 통합 아키텍처를 뜻하지 않습니다</a:t>
-            </a:r>
-            <a:endParaRPr lang="en-US" sz="800" dirty="0"/>
-          </a:p>
-        </p:txBody>
-      </p:sp>
-      <p:sp>
-        <p:nvSpPr>
-          <p:cNvPr id="23" name="Text 21"/>
-          <p:cNvSpPr txBox="1"/>
-          <p:nvPr/>
-        </p:nvSpPr>
-        <p:spPr>
-          <a:xfrm>
-            <a:off x="6457934" y="2457444"/>
-            <a:ext cx="5029187" cy="361949"/>
-          </a:xfrm>
-          <a:prstGeom prst="rect">
-            <a:avLst/>
-          </a:prstGeom>
-          <a:noFill/>
-          <a:ln/>
-        </p:spPr>
-        <p:txBody>
-          <a:bodyPr wrap="square" lIns="0" tIns="0" rIns="0" bIns="0" rtlCol="0" anchor="ctr"/>
-          <a:lstStyle/>
-          <a:p>
-            <a:pPr indent="0" marL="0">
-              <a:lnSpc>
-                <a:spcPct val="125000"/>
-              </a:lnSpc>
-              <a:buNone/>
-            </a:pPr>
-            <a:r>
-              <a:rPr lang="en-US" sz="800" dirty="0">
-                <a:solidFill>
-                  <a:srgbClr val="D97706"/>
-                </a:solidFill>
-                <a:latin typeface="페이퍼로지 8 ExtraBold" pitchFamily="34" charset="0"/>
-                <a:ea typeface="페이퍼로지 8 ExtraBold" pitchFamily="34" charset="-122"/>
-                <a:cs typeface="페이퍼로지 8 ExtraBold" pitchFamily="34" charset="-120"/>
-              </a:rPr>
-              <a:t>!  </a:t>
-            </a:r>
-            <a:pPr indent="0" marL="0">
-              <a:lnSpc>
-                <a:spcPct val="125000"/>
-              </a:lnSpc>
-              <a:buNone/>
-            </a:pPr>
-            <a:r>
-              <a:rPr lang="en-US" sz="800" dirty="0">
-                <a:solidFill>
-                  <a:srgbClr val="1B468B"/>
-                </a:solidFill>
-                <a:latin typeface="페이퍼로지 8 ExtraBold" pitchFamily="34" charset="0"/>
-                <a:ea typeface="페이퍼로지 8 ExtraBold" pitchFamily="34" charset="-122"/>
-                <a:cs typeface="페이퍼로지 8 ExtraBold" pitchFamily="34" charset="-120"/>
-              </a:rPr>
-              <a:t>GEO 점수는 자체 진단 기준입니다 — </a:t>
-            </a:r>
-            <a:pPr indent="0" marL="0">
-              <a:lnSpc>
-                <a:spcPct val="125000"/>
-              </a:lnSpc>
-              <a:buNone/>
-            </a:pPr>
-            <a:r>
-              <a:rPr lang="en-US" sz="800" dirty="0">
-                <a:solidFill>
-                  <a:srgbClr val="334155"/>
-                </a:solidFill>
-                <a:latin typeface="페이퍼로지 4 Regular" pitchFamily="34" charset="0"/>
-                <a:ea typeface="페이퍼로지 4 Regular" pitchFamily="34" charset="-122"/>
-                <a:cs typeface="페이퍼로지 4 Regular" pitchFamily="34" charset="-120"/>
-              </a:rPr>
-              <a:t>AI 답변 노출·인용률이나 검색순위가 아닙니다</a:t>
-            </a:r>
-            <a:endParaRPr lang="en-US" sz="800" dirty="0"/>
-          </a:p>
-        </p:txBody>
-      </p:sp>
-      <p:sp>
-        <p:nvSpPr>
-          <p:cNvPr id="24" name="Text 22"/>
-          <p:cNvSpPr txBox="1"/>
-          <p:nvPr/>
-        </p:nvSpPr>
-        <p:spPr>
-          <a:xfrm>
-            <a:off x="6457934" y="2857493"/>
-            <a:ext cx="5029187" cy="361949"/>
-          </a:xfrm>
-          <a:prstGeom prst="rect">
-            <a:avLst/>
-          </a:prstGeom>
-          <a:noFill/>
-          <a:ln/>
-        </p:spPr>
-        <p:txBody>
-          <a:bodyPr wrap="square" lIns="0" tIns="0" rIns="0" bIns="0" rtlCol="0" anchor="ctr"/>
-          <a:lstStyle/>
-          <a:p>
-            <a:pPr indent="0" marL="0">
-              <a:lnSpc>
-                <a:spcPct val="125000"/>
-              </a:lnSpc>
-              <a:buNone/>
-            </a:pPr>
-            <a:r>
-              <a:rPr lang="en-US" sz="800" dirty="0">
-                <a:solidFill>
-                  <a:srgbClr val="D97706"/>
-                </a:solidFill>
-                <a:latin typeface="페이퍼로지 8 ExtraBold" pitchFamily="34" charset="0"/>
-                <a:ea typeface="페이퍼로지 8 ExtraBold" pitchFamily="34" charset="-122"/>
-                <a:cs typeface="페이퍼로지 8 ExtraBold" pitchFamily="34" charset="-120"/>
-              </a:rPr>
-              <a:t>!  </a:t>
-            </a:r>
-            <a:pPr indent="0" marL="0">
-              <a:lnSpc>
-                <a:spcPct val="125000"/>
-              </a:lnSpc>
-              <a:buNone/>
-            </a:pPr>
-            <a:r>
-              <a:rPr lang="en-US" sz="800" dirty="0">
-                <a:solidFill>
-                  <a:srgbClr val="1B468B"/>
-                </a:solidFill>
-                <a:latin typeface="페이퍼로지 8 ExtraBold" pitchFamily="34" charset="0"/>
-                <a:ea typeface="페이퍼로지 8 ExtraBold" pitchFamily="34" charset="-122"/>
-                <a:cs typeface="페이퍼로지 8 ExtraBold" pitchFamily="34" charset="-120"/>
-              </a:rPr>
-              <a:t>화면 수치는 캡처 시점 데이터이며 광고주명·금액은 마스킹했습니다 — </a:t>
-            </a:r>
-            <a:pPr indent="0" marL="0">
-              <a:lnSpc>
-                <a:spcPct val="125000"/>
-              </a:lnSpc>
-              <a:buNone/>
-            </a:pPr>
-            <a:r>
-              <a:rPr lang="en-US" sz="800" dirty="0">
-                <a:solidFill>
-                  <a:srgbClr val="334155"/>
-                </a:solidFill>
-                <a:latin typeface="페이퍼로지 4 Regular" pitchFamily="34" charset="0"/>
-                <a:ea typeface="페이퍼로지 4 Regular" pitchFamily="34" charset="-122"/>
-                <a:cs typeface="페이퍼로지 4 Regular" pitchFamily="34" charset="-120"/>
-              </a:rPr>
-              <a:t>현재 성과가 아닙니다</a:t>
-            </a:r>
-            <a:endParaRPr lang="en-US" sz="800" dirty="0"/>
-          </a:p>
-        </p:txBody>
-      </p:sp>
-      <p:sp>
-        <p:nvSpPr>
-          <p:cNvPr id="25" name="Text 23"/>
-          <p:cNvSpPr txBox="1"/>
-          <p:nvPr/>
-        </p:nvSpPr>
-        <p:spPr>
-          <a:xfrm>
-            <a:off x="6457934" y="3257542"/>
-            <a:ext cx="5029187" cy="361949"/>
-          </a:xfrm>
-          <a:prstGeom prst="rect">
-            <a:avLst/>
-          </a:prstGeom>
-          <a:noFill/>
-          <a:ln/>
-        </p:spPr>
-        <p:txBody>
-          <a:bodyPr wrap="square" lIns="0" tIns="0" rIns="0" bIns="0" rtlCol="0" anchor="ctr"/>
-          <a:lstStyle/>
-          <a:p>
-            <a:pPr indent="0" marL="0">
-              <a:lnSpc>
-                <a:spcPct val="125000"/>
-              </a:lnSpc>
-              <a:buNone/>
-            </a:pPr>
-            <a:r>
-              <a:rPr lang="en-US" sz="800" dirty="0">
-                <a:solidFill>
-                  <a:srgbClr val="D97706"/>
-                </a:solidFill>
-                <a:latin typeface="페이퍼로지 8 ExtraBold" pitchFamily="34" charset="0"/>
-                <a:ea typeface="페이퍼로지 8 ExtraBold" pitchFamily="34" charset="-122"/>
-                <a:cs typeface="페이퍼로지 8 ExtraBold" pitchFamily="34" charset="-120"/>
-              </a:rPr>
-              <a:t>!  </a:t>
-            </a:r>
-            <a:pPr indent="0" marL="0">
-              <a:lnSpc>
-                <a:spcPct val="125000"/>
-              </a:lnSpc>
-              <a:buNone/>
-            </a:pPr>
-            <a:r>
-              <a:rPr lang="en-US" sz="800" dirty="0">
-                <a:solidFill>
-                  <a:srgbClr val="1B468B"/>
-                </a:solidFill>
-                <a:latin typeface="페이퍼로지 8 ExtraBold" pitchFamily="34" charset="0"/>
-                <a:ea typeface="페이퍼로지 8 ExtraBold" pitchFamily="34" charset="-122"/>
-                <a:cs typeface="페이퍼로지 8 ExtraBold" pitchFamily="34" charset="-120"/>
-              </a:rPr>
-              <a:t>채널·매체별 연동 범위와 집계 주기가 다릅니다 — </a:t>
-            </a:r>
-            <a:pPr indent="0" marL="0">
-              <a:lnSpc>
-                <a:spcPct val="125000"/>
-              </a:lnSpc>
-              <a:buNone/>
-            </a:pPr>
-            <a:r>
-              <a:rPr lang="en-US" sz="800" dirty="0">
-                <a:solidFill>
-                  <a:srgbClr val="334155"/>
-                </a:solidFill>
-                <a:latin typeface="페이퍼로지 4 Regular" pitchFamily="34" charset="0"/>
-                <a:ea typeface="페이퍼로지 4 Regular" pitchFamily="34" charset="-122"/>
-                <a:cs typeface="페이퍼로지 4 Regular" pitchFamily="34" charset="-120"/>
-              </a:rPr>
-              <a:t>판매 매출과 광고 기여 성과는 구분합니다</a:t>
-            </a:r>
-            <a:endParaRPr lang="en-US" sz="800" dirty="0"/>
-          </a:p>
-        </p:txBody>
-      </p:sp>
-      <p:sp>
-        <p:nvSpPr>
-          <p:cNvPr id="26" name="Text 24"/>
-          <p:cNvSpPr txBox="1"/>
-          <p:nvPr/>
-        </p:nvSpPr>
-        <p:spPr>
-          <a:xfrm>
-            <a:off x="6457934" y="3657591"/>
-            <a:ext cx="5029187" cy="361949"/>
-          </a:xfrm>
-          <a:prstGeom prst="rect">
-            <a:avLst/>
-          </a:prstGeom>
-          <a:noFill/>
-          <a:ln/>
-        </p:spPr>
-        <p:txBody>
-          <a:bodyPr wrap="square" lIns="0" tIns="0" rIns="0" bIns="0" rtlCol="0" anchor="ctr"/>
-          <a:lstStyle/>
-          <a:p>
-            <a:pPr indent="0" marL="0">
-              <a:lnSpc>
-                <a:spcPct val="125000"/>
-              </a:lnSpc>
-              <a:buNone/>
-            </a:pPr>
-            <a:r>
-              <a:rPr lang="en-US" sz="800" dirty="0">
-                <a:solidFill>
-                  <a:srgbClr val="D97706"/>
-                </a:solidFill>
-                <a:latin typeface="페이퍼로지 8 ExtraBold" pitchFamily="34" charset="0"/>
-                <a:ea typeface="페이퍼로지 8 ExtraBold" pitchFamily="34" charset="-122"/>
-                <a:cs typeface="페이퍼로지 8 ExtraBold" pitchFamily="34" charset="-120"/>
-              </a:rPr>
-              <a:t>!  </a:t>
-            </a:r>
-            <a:pPr indent="0" marL="0">
-              <a:lnSpc>
-                <a:spcPct val="125000"/>
-              </a:lnSpc>
-              <a:buNone/>
-            </a:pPr>
-            <a:r>
-              <a:rPr lang="en-US" sz="800" dirty="0">
-                <a:solidFill>
-                  <a:srgbClr val="334155"/>
-                </a:solidFill>
-                <a:latin typeface="페이퍼로지 4 Regular" pitchFamily="34" charset="0"/>
-                <a:ea typeface="페이퍼로지 4 Regular" pitchFamily="34" charset="-122"/>
-                <a:cs typeface="페이퍼로지 4 Regular" pitchFamily="34" charset="-120"/>
-              </a:rPr>
-              <a:t>카카오쇼핑(톡스토어)은 연동 승인 대기 상태입니다</a:t>
-            </a:r>
-            <a:endParaRPr lang="en-US" sz="800" dirty="0"/>
-          </a:p>
-        </p:txBody>
-      </p:sp>
-      <p:sp>
-        <p:nvSpPr>
-          <p:cNvPr id="27" name="Text 25"/>
-          <p:cNvSpPr txBox="1"/>
-          <p:nvPr/>
-        </p:nvSpPr>
-        <p:spPr>
-          <a:xfrm>
-            <a:off x="6457934" y="4057640"/>
-            <a:ext cx="5029187" cy="361949"/>
-          </a:xfrm>
-          <a:prstGeom prst="rect">
-            <a:avLst/>
-          </a:prstGeom>
-          <a:noFill/>
-          <a:ln/>
-        </p:spPr>
-        <p:txBody>
-          <a:bodyPr wrap="square" lIns="0" tIns="0" rIns="0" bIns="0" rtlCol="0" anchor="ctr"/>
-          <a:lstStyle/>
-          <a:p>
-            <a:pPr indent="0" marL="0">
-              <a:lnSpc>
-                <a:spcPct val="125000"/>
-              </a:lnSpc>
-              <a:buNone/>
-            </a:pPr>
-            <a:r>
-              <a:rPr lang="en-US" sz="800" dirty="0">
-                <a:solidFill>
-                  <a:srgbClr val="D97706"/>
-                </a:solidFill>
-                <a:latin typeface="페이퍼로지 8 ExtraBold" pitchFamily="34" charset="0"/>
-                <a:ea typeface="페이퍼로지 8 ExtraBold" pitchFamily="34" charset="-122"/>
-                <a:cs typeface="페이퍼로지 8 ExtraBold" pitchFamily="34" charset="-120"/>
-              </a:rPr>
-              <a:t>!  </a:t>
-            </a:r>
-            <a:pPr indent="0" marL="0">
-              <a:lnSpc>
-                <a:spcPct val="125000"/>
-              </a:lnSpc>
-              <a:buNone/>
-            </a:pPr>
-            <a:r>
-              <a:rPr lang="en-US" sz="800" dirty="0">
-                <a:solidFill>
-                  <a:srgbClr val="1B468B"/>
-                </a:solidFill>
-                <a:latin typeface="페이퍼로지 8 ExtraBold" pitchFamily="34" charset="0"/>
-                <a:ea typeface="페이퍼로지 8 ExtraBold" pitchFamily="34" charset="-122"/>
-                <a:cs typeface="페이퍼로지 8 ExtraBold" pitchFamily="34" charset="-120"/>
-              </a:rPr>
-              <a:t>MI 기능 범위·오픈 일정, 소상공인용 상품은 확정 전입니다 — </a:t>
-            </a:r>
-            <a:pPr indent="0" marL="0">
-              <a:lnSpc>
-                <a:spcPct val="125000"/>
-              </a:lnSpc>
-              <a:buNone/>
-            </a:pPr>
-            <a:r>
-              <a:rPr lang="en-US" sz="800" dirty="0">
-                <a:solidFill>
-                  <a:srgbClr val="334155"/>
-                </a:solidFill>
-                <a:latin typeface="페이퍼로지 4 Regular" pitchFamily="34" charset="0"/>
-                <a:ea typeface="페이퍼로지 4 Regular" pitchFamily="34" charset="-122"/>
-                <a:cs typeface="페이퍼로지 4 Regular" pitchFamily="34" charset="-120"/>
-              </a:rPr>
-              <a:t>도입 상담에서 확정</a:t>
-            </a:r>
-            <a:endParaRPr lang="en-US" sz="800" dirty="0"/>
-          </a:p>
-        </p:txBody>
-      </p:sp>
-      <p:sp>
-        <p:nvSpPr>
-          <p:cNvPr id="28" name="Text 26"/>
-          <p:cNvSpPr txBox="1"/>
-          <p:nvPr/>
-        </p:nvSpPr>
-        <p:spPr>
-          <a:xfrm>
-            <a:off x="6457934" y="4457689"/>
-            <a:ext cx="5029187" cy="361949"/>
-          </a:xfrm>
-          <a:prstGeom prst="rect">
-            <a:avLst/>
-          </a:prstGeom>
-          <a:noFill/>
-          <a:ln/>
-        </p:spPr>
-        <p:txBody>
-          <a:bodyPr wrap="square" lIns="0" tIns="0" rIns="0" bIns="0" rtlCol="0" anchor="ctr"/>
-          <a:lstStyle/>
-          <a:p>
-            <a:pPr indent="0" marL="0">
-              <a:lnSpc>
-                <a:spcPct val="125000"/>
-              </a:lnSpc>
-              <a:buNone/>
-            </a:pPr>
-            <a:r>
-              <a:rPr lang="en-US" sz="800" dirty="0">
-                <a:solidFill>
-                  <a:srgbClr val="D97706"/>
-                </a:solidFill>
-                <a:latin typeface="페이퍼로지 8 ExtraBold" pitchFamily="34" charset="0"/>
-                <a:ea typeface="페이퍼로지 8 ExtraBold" pitchFamily="34" charset="-122"/>
-                <a:cs typeface="페이퍼로지 8 ExtraBold" pitchFamily="34" charset="-120"/>
-              </a:rPr>
-              <a:t>!  </a:t>
-            </a:r>
-            <a:pPr indent="0" marL="0">
-              <a:lnSpc>
-                <a:spcPct val="125000"/>
-              </a:lnSpc>
-              <a:buNone/>
-            </a:pPr>
-            <a:r>
-              <a:rPr lang="en-US" sz="800" dirty="0">
-                <a:solidFill>
-                  <a:srgbClr val="334155"/>
-                </a:solidFill>
-                <a:latin typeface="페이퍼로지 4 Regular" pitchFamily="34" charset="0"/>
-                <a:ea typeface="페이퍼로지 4 Regular" pitchFamily="34" charset="-122"/>
-                <a:cs typeface="페이퍼로지 4 Regular" pitchFamily="34" charset="-120"/>
-              </a:rPr>
-              <a:t>광고주 프로젝트 수행 경험과 AI 솔루션 도입 실적은 별개입니다</a:t>
-            </a:r>
-            <a:endParaRPr lang="en-US" sz="800" dirty="0"/>
-          </a:p>
-        </p:txBody>
-      </p:sp>
-      <p:sp>
-        <p:nvSpPr>
-          <p:cNvPr id="29" name="Shape 27"/>
-          <p:cNvSpPr/>
-          <p:nvPr/>
-        </p:nvSpPr>
-        <p:spPr>
-          <a:xfrm>
-            <a:off x="533399" y="4972038"/>
-            <a:ext cx="3638541" cy="342899"/>
-          </a:xfrm>
-          <a:prstGeom prst="roundRect">
-            <a:avLst>
-              <a:gd name="adj" fmla="val 16000"/>
-            </a:avLst>
-          </a:prstGeom>
-          <a:solidFill>
-            <a:srgbClr val="F5F8FC"/>
-          </a:solidFill>
-          <a:ln w="9525">
-            <a:solidFill>
-              <a:srgbClr val="E3EAF4"/>
-            </a:solidFill>
-            <a:prstDash val="solid"/>
-          </a:ln>
-        </p:spPr>
-      </p:sp>
-      <p:sp>
-        <p:nvSpPr>
-          <p:cNvPr id="30" name="Text 28"/>
-          <p:cNvSpPr txBox="1"/>
-          <p:nvPr/>
-        </p:nvSpPr>
-        <p:spPr>
-          <a:xfrm>
-            <a:off x="666748" y="4972038"/>
-            <a:ext cx="3371842" cy="342899"/>
-          </a:xfrm>
-          <a:prstGeom prst="rect">
-            <a:avLst/>
-          </a:prstGeom>
-          <a:noFill/>
-          <a:ln/>
-        </p:spPr>
-        <p:txBody>
-          <a:bodyPr wrap="square" lIns="0" tIns="0" rIns="0" bIns="0" rtlCol="0" anchor="ctr"/>
-          <a:lstStyle/>
-          <a:p>
-            <a:pPr indent="0" marL="0">
-              <a:buNone/>
-            </a:pPr>
-            <a:r>
-              <a:rPr lang="en-US" sz="750" dirty="0">
-                <a:solidFill>
-                  <a:srgbClr val="1B468B"/>
-                </a:solidFill>
-                <a:latin typeface="페이퍼로지 8 ExtraBold" pitchFamily="34" charset="0"/>
-                <a:ea typeface="페이퍼로지 8 ExtraBold" pitchFamily="34" charset="-122"/>
-                <a:cs typeface="페이퍼로지 8 ExtraBold" pitchFamily="34" charset="-120"/>
-              </a:rPr>
-              <a:t>주간 10억 명  </a:t>
-            </a:r>
-            <a:pPr indent="0" marL="0">
-              <a:buNone/>
-            </a:pPr>
-            <a:r>
-              <a:rPr lang="en-US" sz="750" dirty="0">
-                <a:solidFill>
-                  <a:srgbClr val="334155"/>
-                </a:solidFill>
-                <a:latin typeface="페이퍼로지 4 Regular" pitchFamily="34" charset="0"/>
-                <a:ea typeface="페이퍼로지 4 Regular" pitchFamily="34" charset="-122"/>
-                <a:cs typeface="페이퍼로지 4 Regular" pitchFamily="34" charset="-120"/>
-              </a:rPr>
-              <a:t>ChatGPT 주간 활성 이용자(OpenAI, 2026.07)</a:t>
-            </a:r>
-            <a:endParaRPr lang="en-US" sz="750" dirty="0"/>
-          </a:p>
-        </p:txBody>
-      </p:sp>
-      <p:sp>
-        <p:nvSpPr>
-          <p:cNvPr id="31" name="Shape 29"/>
-          <p:cNvSpPr/>
-          <p:nvPr/>
-        </p:nvSpPr>
-        <p:spPr>
-          <a:xfrm>
-            <a:off x="4286239" y="4972038"/>
-            <a:ext cx="3638541" cy="342899"/>
-          </a:xfrm>
-          <a:prstGeom prst="roundRect">
-            <a:avLst>
-              <a:gd name="adj" fmla="val 16000"/>
-            </a:avLst>
-          </a:prstGeom>
-          <a:solidFill>
-            <a:srgbClr val="F5F8FC"/>
-          </a:solidFill>
-          <a:ln w="9525">
-            <a:solidFill>
-              <a:srgbClr val="E3EAF4"/>
-            </a:solidFill>
-            <a:prstDash val="solid"/>
-          </a:ln>
-        </p:spPr>
-      </p:sp>
-      <p:sp>
-        <p:nvSpPr>
-          <p:cNvPr id="32" name="Text 30"/>
-          <p:cNvSpPr txBox="1"/>
-          <p:nvPr/>
-        </p:nvSpPr>
-        <p:spPr>
-          <a:xfrm>
-            <a:off x="4419589" y="4972038"/>
-            <a:ext cx="3371842" cy="342899"/>
-          </a:xfrm>
-          <a:prstGeom prst="rect">
-            <a:avLst/>
-          </a:prstGeom>
-          <a:noFill/>
-          <a:ln/>
-        </p:spPr>
-        <p:txBody>
-          <a:bodyPr wrap="square" lIns="0" tIns="0" rIns="0" bIns="0" rtlCol="0" anchor="ctr"/>
-          <a:lstStyle/>
-          <a:p>
-            <a:pPr indent="0" marL="0">
-              <a:buNone/>
-            </a:pPr>
-            <a:r>
-              <a:rPr lang="en-US" sz="750" dirty="0">
-                <a:solidFill>
-                  <a:srgbClr val="1B468B"/>
-                </a:solidFill>
-                <a:latin typeface="페이퍼로지 8 ExtraBold" pitchFamily="34" charset="0"/>
-                <a:ea typeface="페이퍼로지 8 ExtraBold" pitchFamily="34" charset="-122"/>
-                <a:cs typeface="페이퍼로지 8 ExtraBold" pitchFamily="34" charset="-120"/>
-              </a:rPr>
-              <a:t>약 40%  </a:t>
-            </a:r>
-            <a:pPr indent="0" marL="0">
-              <a:buNone/>
-            </a:pPr>
-            <a:r>
-              <a:rPr lang="en-US" sz="750" dirty="0">
-                <a:solidFill>
-                  <a:srgbClr val="334155"/>
-                </a:solidFill>
-                <a:latin typeface="페이퍼로지 4 Regular" pitchFamily="34" charset="0"/>
-                <a:ea typeface="페이퍼로지 4 Regular" pitchFamily="34" charset="-122"/>
-                <a:cs typeface="페이퍼로지 4 Regular" pitchFamily="34" charset="-120"/>
-              </a:rPr>
-              <a:t>2026년 AI 제작 디지털 광고 비중 전망</a:t>
-            </a:r>
-            <a:endParaRPr lang="en-US" sz="750" dirty="0"/>
-          </a:p>
-        </p:txBody>
-      </p:sp>
-      <p:sp>
-        <p:nvSpPr>
-          <p:cNvPr id="33" name="Shape 31"/>
-          <p:cNvSpPr/>
-          <p:nvPr/>
-        </p:nvSpPr>
-        <p:spPr>
-          <a:xfrm>
-            <a:off x="8039080" y="4972038"/>
-            <a:ext cx="3638541" cy="342899"/>
-          </a:xfrm>
-          <a:prstGeom prst="roundRect">
-            <a:avLst>
-              <a:gd name="adj" fmla="val 16000"/>
-            </a:avLst>
-          </a:prstGeom>
-          <a:solidFill>
-            <a:srgbClr val="F5F8FC"/>
-          </a:solidFill>
-          <a:ln w="9525">
-            <a:solidFill>
-              <a:srgbClr val="E3EAF4"/>
-            </a:solidFill>
-            <a:prstDash val="solid"/>
-          </a:ln>
-        </p:spPr>
-      </p:sp>
-      <p:sp>
-        <p:nvSpPr>
-          <p:cNvPr id="34" name="Text 32"/>
-          <p:cNvSpPr txBox="1"/>
-          <p:nvPr/>
-        </p:nvSpPr>
-        <p:spPr>
-          <a:xfrm>
-            <a:off x="8172430" y="4972038"/>
-            <a:ext cx="3371842" cy="342899"/>
-          </a:xfrm>
-          <a:prstGeom prst="rect">
-            <a:avLst/>
-          </a:prstGeom>
-          <a:noFill/>
-          <a:ln/>
-        </p:spPr>
-        <p:txBody>
-          <a:bodyPr wrap="square" lIns="0" tIns="0" rIns="0" bIns="0" rtlCol="0" anchor="ctr"/>
-          <a:lstStyle/>
-          <a:p>
-            <a:pPr indent="0" marL="0">
-              <a:buNone/>
-            </a:pPr>
-            <a:r>
-              <a:rPr lang="en-US" sz="750" dirty="0">
-                <a:solidFill>
-                  <a:srgbClr val="1B468B"/>
-                </a:solidFill>
-                <a:latin typeface="페이퍼로지 8 ExtraBold" pitchFamily="34" charset="0"/>
-                <a:ea typeface="페이퍼로지 8 ExtraBold" pitchFamily="34" charset="-122"/>
-                <a:cs typeface="페이퍼로지 8 ExtraBold" pitchFamily="34" charset="-120"/>
-              </a:rPr>
-              <a:t>0.8~1.3%  </a:t>
-            </a:r>
-            <a:pPr indent="0" marL="0">
-              <a:buNone/>
-            </a:pPr>
-            <a:r>
-              <a:rPr lang="en-US" sz="750" dirty="0">
-                <a:solidFill>
-                  <a:srgbClr val="334155"/>
-                </a:solidFill>
-                <a:latin typeface="페이퍼로지 4 Regular" pitchFamily="34" charset="0"/>
-                <a:ea typeface="페이퍼로지 4 Regular" pitchFamily="34" charset="-122"/>
-                <a:cs typeface="페이퍼로지 4 Regular" pitchFamily="34" charset="-120"/>
-              </a:rPr>
-              <a:t>AI 검색 클릭률(구글 약 29%) — Similarweb 2026</a:t>
-            </a:r>
-            <a:endParaRPr lang="en-US" sz="750" dirty="0"/>
-          </a:p>
-        </p:txBody>
-      </p:sp>
-      <p:sp>
-        <p:nvSpPr>
-          <p:cNvPr id="35" name="Shape 33"/>
-          <p:cNvSpPr/>
-          <p:nvPr/>
-        </p:nvSpPr>
-        <p:spPr>
-          <a:xfrm>
-            <a:off x="533399" y="5429236"/>
-            <a:ext cx="11125172" cy="552449"/>
-          </a:xfrm>
-          <a:prstGeom prst="roundRect">
-            <a:avLst>
-              <a:gd name="adj" fmla="val 8276"/>
-            </a:avLst>
-          </a:prstGeom>
-          <a:solidFill>
-            <a:srgbClr val="334155"/>
-          </a:solidFill>
-          <a:ln w="12700">
-            <a:solidFill>
-              <a:srgbClr val="334155"/>
-            </a:solidFill>
-            <a:prstDash val="solid"/>
-          </a:ln>
-        </p:spPr>
-      </p:sp>
-      <p:sp>
-        <p:nvSpPr>
-          <p:cNvPr id="36" name="Text 34"/>
-          <p:cNvSpPr txBox="1"/>
-          <p:nvPr/>
-        </p:nvSpPr>
-        <p:spPr>
-          <a:xfrm>
-            <a:off x="723898" y="5524486"/>
-            <a:ext cx="6667483" cy="209549"/>
-          </a:xfrm>
-          <a:prstGeom prst="rect">
-            <a:avLst/>
-          </a:prstGeom>
-          <a:noFill/>
-          <a:ln/>
-        </p:spPr>
-        <p:txBody>
-          <a:bodyPr wrap="square" lIns="0" tIns="0" rIns="0" bIns="0" rtlCol="0" anchor="ctr"/>
-          <a:lstStyle/>
-          <a:p>
-            <a:pPr indent="0" marL="0">
-              <a:buNone/>
-            </a:pPr>
-            <a:r>
-              <a:rPr lang="en-US" sz="1200" dirty="0">
-                <a:solidFill>
-                  <a:srgbClr val="FFFFFF"/>
-                </a:solidFill>
-                <a:latin typeface="페이퍼로지 8 ExtraBold" pitchFamily="34" charset="0"/>
-                <a:ea typeface="페이퍼로지 8 ExtraBold" pitchFamily="34" charset="-122"/>
-                <a:cs typeface="페이퍼로지 8 ExtraBold" pitchFamily="34" charset="-120"/>
-              </a:rPr>
-              <a:t>기능·연동·운영 범위는 도입 상담에서 확정합니다</a:t>
-            </a:r>
-            <a:endParaRPr lang="en-US" sz="1200" dirty="0"/>
-          </a:p>
-        </p:txBody>
-      </p:sp>
-      <p:sp>
-        <p:nvSpPr>
-          <p:cNvPr id="37" name="Text 35"/>
-          <p:cNvSpPr txBox="1"/>
-          <p:nvPr/>
-        </p:nvSpPr>
-        <p:spPr>
-          <a:xfrm>
-            <a:off x="723898" y="5734036"/>
-            <a:ext cx="6667483" cy="190500"/>
-          </a:xfrm>
-          <a:prstGeom prst="rect">
-            <a:avLst/>
-          </a:prstGeom>
-          <a:noFill/>
-          <a:ln/>
-        </p:spPr>
-        <p:txBody>
-          <a:bodyPr wrap="square" lIns="0" tIns="0" rIns="0" bIns="0" rtlCol="0" anchor="ctr"/>
-          <a:lstStyle/>
-          <a:p>
-            <a:pPr indent="0" marL="0">
-              <a:buNone/>
-            </a:pPr>
-            <a:r>
-              <a:rPr lang="en-US" sz="900" dirty="0">
-                <a:solidFill>
-                  <a:srgbClr val="D9DEE7"/>
-                </a:solidFill>
-                <a:latin typeface="페이퍼로지 4 Regular" pitchFamily="34" charset="0"/>
-                <a:ea typeface="페이퍼로지 4 Regular" pitchFamily="34" charset="-122"/>
-                <a:cs typeface="페이퍼로지 4 Regular" pitchFamily="34" charset="-120"/>
-              </a:rPr>
-              <a:t>기술을 고르고, 브랜드에 맞추고, 실행을 돕습니다</a:t>
-            </a:r>
-            <a:endParaRPr lang="en-US" sz="900" dirty="0"/>
-          </a:p>
-        </p:txBody>
-      </p:sp>
-      <p:sp>
-        <p:nvSpPr>
-          <p:cNvPr id="38" name="Shape 36"/>
-          <p:cNvSpPr/>
-          <p:nvPr/>
-        </p:nvSpPr>
-        <p:spPr>
-          <a:xfrm>
-            <a:off x="9143977" y="5543536"/>
-            <a:ext cx="2324094" cy="323849"/>
-          </a:xfrm>
-          <a:prstGeom prst="roundRect">
-            <a:avLst>
-              <a:gd name="adj" fmla="val 28235"/>
-            </a:avLst>
-          </a:prstGeom>
-          <a:solidFill>
-            <a:srgbClr val="FFFFFF"/>
-          </a:solidFill>
-          <a:ln w="12700">
-            <a:solidFill>
-              <a:srgbClr val="FFFFFF"/>
-            </a:solidFill>
-            <a:prstDash val="solid"/>
-          </a:ln>
-        </p:spPr>
-      </p:sp>
-      <p:sp>
-        <p:nvSpPr>
-          <p:cNvPr id="39" name="Text 37"/>
-          <p:cNvSpPr txBox="1"/>
-          <p:nvPr/>
-        </p:nvSpPr>
-        <p:spPr>
-          <a:xfrm>
-            <a:off x="9143977" y="5543536"/>
-            <a:ext cx="2324094" cy="323849"/>
-          </a:xfrm>
-          <a:prstGeom prst="rect">
-            <a:avLst/>
-          </a:prstGeom>
-          <a:noFill/>
-          <a:ln/>
-        </p:spPr>
-        <p:txBody>
-          <a:bodyPr wrap="square" lIns="0" tIns="0" rIns="0" bIns="0" rtlCol="0" anchor="ctr"/>
-          <a:lstStyle/>
-          <a:p>
-            <a:pPr algn="ctr" indent="0" marL="0">
-              <a:buNone/>
-            </a:pPr>
-            <a:r>
-              <a:rPr lang="en-US" sz="900" dirty="0">
-                <a:solidFill>
-                  <a:srgbClr val="334155"/>
-                </a:solidFill>
-                <a:latin typeface="페이퍼로지 8 ExtraBold" pitchFamily="34" charset="0"/>
-                <a:ea typeface="페이퍼로지 8 ExtraBold" pitchFamily="34" charset="-122"/>
-                <a:cs typeface="페이퍼로지 8 ExtraBold" pitchFamily="34" charset="-120"/>
-              </a:rPr>
-              <a:t>mplanit@mplanit.co.kr</a:t>
-            </a:r>
-            <a:endParaRPr lang="en-US" sz="900" dirty="0"/>
-          </a:p>
-        </p:txBody>
-      </p:sp>
-      <p:sp>
-        <p:nvSpPr>
-          <p:cNvPr id="40" name="Shape 38"/>
-          <p:cNvSpPr/>
-          <p:nvPr/>
-        </p:nvSpPr>
-        <p:spPr>
-          <a:xfrm>
-            <a:off x="533399" y="6400784"/>
-            <a:ext cx="11125172" cy="0"/>
-          </a:xfrm>
-          <a:prstGeom prst="line">
-            <a:avLst/>
-          </a:prstGeom>
-          <a:noFill/>
-          <a:ln w="9525">
-            <a:solidFill>
-              <a:srgbClr val="E3EAF4"/>
-            </a:solidFill>
-            <a:prstDash val="solid"/>
-          </a:ln>
-        </p:spPr>
-      </p:sp>
-      <p:sp>
-        <p:nvSpPr>
-          <p:cNvPr id="41" name="Text 39"/>
-          <p:cNvSpPr txBox="1"/>
-          <p:nvPr/>
-        </p:nvSpPr>
-        <p:spPr>
-          <a:xfrm>
-            <a:off x="533399" y="6457934"/>
-            <a:ext cx="7619981" cy="190500"/>
-          </a:xfrm>
-          <a:prstGeom prst="rect">
-            <a:avLst/>
-          </a:prstGeom>
-          <a:noFill/>
-          <a:ln/>
-        </p:spPr>
-        <p:txBody>
-          <a:bodyPr wrap="square" lIns="0" tIns="0" rIns="0" bIns="0" rtlCol="0" anchor="ctr"/>
-          <a:lstStyle/>
-          <a:p>
-            <a:pPr indent="0" marL="0">
-              <a:buNone/>
-            </a:pPr>
-            <a:r>
-              <a:rPr lang="en-US" sz="800" dirty="0">
-                <a:solidFill>
-                  <a:srgbClr val="94A3B8"/>
-                </a:solidFill>
-                <a:latin typeface="페이퍼로지 4 Regular" pitchFamily="34" charset="0"/>
-                <a:ea typeface="페이퍼로지 4 Regular" pitchFamily="34" charset="-122"/>
-                <a:cs typeface="페이퍼로지 4 Regular" pitchFamily="34" charset="-120"/>
-              </a:rPr>
-              <a:t>Appendix · 근거와 표기 기준</a:t>
-            </a:r>
-            <a:endParaRPr lang="en-US" sz="800" dirty="0"/>
-          </a:p>
-        </p:txBody>
-      </p:sp>
-      <p:sp>
-        <p:nvSpPr>
-          <p:cNvPr id="42" name="Text 40"/>
-          <p:cNvSpPr txBox="1"/>
-          <p:nvPr/>
-        </p:nvSpPr>
-        <p:spPr>
-          <a:xfrm>
-            <a:off x="9524976" y="6457934"/>
-            <a:ext cx="2133595" cy="190500"/>
-          </a:xfrm>
-          <a:prstGeom prst="rect">
-            <a:avLst/>
-          </a:prstGeom>
-          <a:noFill/>
-          <a:ln/>
-        </p:spPr>
-        <p:txBody>
-          <a:bodyPr wrap="square" lIns="0" tIns="0" rIns="0" bIns="0" rtlCol="0" anchor="ctr"/>
-          <a:lstStyle/>
-          <a:p>
-            <a:pPr algn="r" indent="0" marL="0">
-              <a:buNone/>
-            </a:pPr>
-            <a:r>
-              <a:rPr lang="en-US" sz="800" dirty="0">
-                <a:solidFill>
-                  <a:srgbClr val="94A3B8"/>
-                </a:solidFill>
-                <a:latin typeface="페이퍼로지 4 Regular" pitchFamily="34" charset="0"/>
-                <a:ea typeface="페이퍼로지 4 Regular" pitchFamily="34" charset="-122"/>
-                <a:cs typeface="페이퍼로지 4 Regular" pitchFamily="34" charset="-120"/>
-              </a:rPr>
-              <a:t>09 / 09</a:t>
+              <a:t>08 / 08</a:t>
             </a:r>
             <a:endParaRPr lang="en-US" sz="800" dirty="0"/>
           </a:p>

</xml_diff>